<commit_message>
Make SharePoint an optional Day 1 extension
</commit_message>
<xml_diff>
--- a/docs/public/downloads/CPAll-Power-Automate-Day-1.pptx
+++ b/docs/public/downloads/CPAll-Power-Automate-Day-1.pptx
@@ -2,48 +2,48 @@
 <file path=ppt/presentation.xml><?xml version="1.0" encoding="utf-8"?>
 <p:presentation xmlns:p="http://schemas.openxmlformats.org/presentationml/2006/main">
   <p:sldMasterIdLst>
-    <p:sldMasterId xmlns:r="http://schemas.openxmlformats.org/officeDocument/2006/relationships" id="2147483648" r:id="Rd269f04d1197423f"/>
+    <p:sldMasterId xmlns:r="http://schemas.openxmlformats.org/officeDocument/2006/relationships" id="2147483648" r:id="R81b787b45dba4605"/>
   </p:sldMasterIdLst>
   <p:notesMasterIdLst>
-    <p:notesMasterId xmlns:r="http://schemas.openxmlformats.org/officeDocument/2006/relationships" r:id="R5d2cf3a2dc994912"/>
+    <p:notesMasterId xmlns:r="http://schemas.openxmlformats.org/officeDocument/2006/relationships" r:id="Rb6513f92f00c49f1"/>
   </p:notesMasterIdLst>
   <p:sldIdLst>
-    <p:sldId xmlns:r="http://schemas.openxmlformats.org/officeDocument/2006/relationships" id="256" r:id="R512c0b779cf244bb"/>
-    <p:sldId xmlns:r="http://schemas.openxmlformats.org/officeDocument/2006/relationships" id="257" r:id="R859f92db673b4450"/>
-    <p:sldId xmlns:r="http://schemas.openxmlformats.org/officeDocument/2006/relationships" id="258" r:id="R9d60ad1b2a194dca"/>
-    <p:sldId xmlns:r="http://schemas.openxmlformats.org/officeDocument/2006/relationships" id="259" r:id="Rb54503e1888a4cd5"/>
-    <p:sldId xmlns:r="http://schemas.openxmlformats.org/officeDocument/2006/relationships" id="260" r:id="R646155ac8ba64cd8"/>
-    <p:sldId xmlns:r="http://schemas.openxmlformats.org/officeDocument/2006/relationships" id="261" r:id="R0766c67a856b4a94"/>
-    <p:sldId xmlns:r="http://schemas.openxmlformats.org/officeDocument/2006/relationships" id="262" r:id="Rabab31ba28f6402c"/>
-    <p:sldId xmlns:r="http://schemas.openxmlformats.org/officeDocument/2006/relationships" id="263" r:id="Ree8fbc6686fa4459"/>
-    <p:sldId xmlns:r="http://schemas.openxmlformats.org/officeDocument/2006/relationships" id="264" r:id="Rdc60696275f04ece"/>
-    <p:sldId xmlns:r="http://schemas.openxmlformats.org/officeDocument/2006/relationships" id="265" r:id="R160e4aedbffe4f89"/>
-    <p:sldId xmlns:r="http://schemas.openxmlformats.org/officeDocument/2006/relationships" id="266" r:id="Red1bdac95ea2413f"/>
-    <p:sldId xmlns:r="http://schemas.openxmlformats.org/officeDocument/2006/relationships" id="267" r:id="Refc2856dd373499d"/>
-    <p:sldId xmlns:r="http://schemas.openxmlformats.org/officeDocument/2006/relationships" id="268" r:id="Ra08dd14db14e4dc7"/>
-    <p:sldId xmlns:r="http://schemas.openxmlformats.org/officeDocument/2006/relationships" id="269" r:id="R43a966cccb044f80"/>
-    <p:sldId xmlns:r="http://schemas.openxmlformats.org/officeDocument/2006/relationships" id="270" r:id="R6c327f7ba50e426c"/>
-    <p:sldId xmlns:r="http://schemas.openxmlformats.org/officeDocument/2006/relationships" id="271" r:id="R0db9fd1743fb40de"/>
-    <p:sldId xmlns:r="http://schemas.openxmlformats.org/officeDocument/2006/relationships" id="272" r:id="R7aab2ce571dc4955"/>
-    <p:sldId xmlns:r="http://schemas.openxmlformats.org/officeDocument/2006/relationships" id="273" r:id="R2e4fda8ec08b47f9"/>
-    <p:sldId xmlns:r="http://schemas.openxmlformats.org/officeDocument/2006/relationships" id="274" r:id="Rb9ea3095f7a84ef7"/>
-    <p:sldId xmlns:r="http://schemas.openxmlformats.org/officeDocument/2006/relationships" id="275" r:id="R311c25e40f6c4731"/>
-    <p:sldId xmlns:r="http://schemas.openxmlformats.org/officeDocument/2006/relationships" id="276" r:id="Rd62d411ed77c4d75"/>
-    <p:sldId xmlns:r="http://schemas.openxmlformats.org/officeDocument/2006/relationships" id="277" r:id="Re62f6f3203bf4ab5"/>
-    <p:sldId xmlns:r="http://schemas.openxmlformats.org/officeDocument/2006/relationships" id="278" r:id="R0dc095f554f04e8d"/>
-    <p:sldId xmlns:r="http://schemas.openxmlformats.org/officeDocument/2006/relationships" id="279" r:id="Rd2a7d201b7ad4464"/>
-    <p:sldId xmlns:r="http://schemas.openxmlformats.org/officeDocument/2006/relationships" id="280" r:id="R9254c1a0469c4009"/>
-    <p:sldId xmlns:r="http://schemas.openxmlformats.org/officeDocument/2006/relationships" id="281" r:id="R42babee24e724124"/>
-    <p:sldId xmlns:r="http://schemas.openxmlformats.org/officeDocument/2006/relationships" id="282" r:id="Rb74b536d4623455c"/>
-    <p:sldId xmlns:r="http://schemas.openxmlformats.org/officeDocument/2006/relationships" id="283" r:id="R4255be435a874537"/>
-    <p:sldId xmlns:r="http://schemas.openxmlformats.org/officeDocument/2006/relationships" id="284" r:id="R6b29014dcda441b6"/>
-    <p:sldId xmlns:r="http://schemas.openxmlformats.org/officeDocument/2006/relationships" id="285" r:id="R1360d2de191f4662"/>
-    <p:sldId xmlns:r="http://schemas.openxmlformats.org/officeDocument/2006/relationships" id="286" r:id="R9f7654d7b16440e8"/>
-    <p:sldId xmlns:r="http://schemas.openxmlformats.org/officeDocument/2006/relationships" id="287" r:id="Re9b4cf4efc744d50"/>
-    <p:sldId xmlns:r="http://schemas.openxmlformats.org/officeDocument/2006/relationships" id="288" r:id="Rd1d99fdff82c47c3"/>
-    <p:sldId xmlns:r="http://schemas.openxmlformats.org/officeDocument/2006/relationships" id="289" r:id="R66c0717f94dc469e"/>
-    <p:sldId xmlns:r="http://schemas.openxmlformats.org/officeDocument/2006/relationships" id="290" r:id="Ra84aa46d817f441c"/>
-    <p:sldId xmlns:r="http://schemas.openxmlformats.org/officeDocument/2006/relationships" id="291" r:id="Rc05e8b1acb8f4664"/>
+    <p:sldId xmlns:r="http://schemas.openxmlformats.org/officeDocument/2006/relationships" id="256" r:id="Rd97261eaaed54fc0"/>
+    <p:sldId xmlns:r="http://schemas.openxmlformats.org/officeDocument/2006/relationships" id="257" r:id="Rad85941a176e42b2"/>
+    <p:sldId xmlns:r="http://schemas.openxmlformats.org/officeDocument/2006/relationships" id="258" r:id="R866954dba3884eeb"/>
+    <p:sldId xmlns:r="http://schemas.openxmlformats.org/officeDocument/2006/relationships" id="259" r:id="Rc95982950778465c"/>
+    <p:sldId xmlns:r="http://schemas.openxmlformats.org/officeDocument/2006/relationships" id="260" r:id="Rebdcb165480e47a3"/>
+    <p:sldId xmlns:r="http://schemas.openxmlformats.org/officeDocument/2006/relationships" id="261" r:id="Ra885affa79944988"/>
+    <p:sldId xmlns:r="http://schemas.openxmlformats.org/officeDocument/2006/relationships" id="262" r:id="Re728248a1ec44ac9"/>
+    <p:sldId xmlns:r="http://schemas.openxmlformats.org/officeDocument/2006/relationships" id="263" r:id="Re005d4b4b30543ca"/>
+    <p:sldId xmlns:r="http://schemas.openxmlformats.org/officeDocument/2006/relationships" id="264" r:id="R46d05e2004a94bb7"/>
+    <p:sldId xmlns:r="http://schemas.openxmlformats.org/officeDocument/2006/relationships" id="265" r:id="R7f14b37d58804db8"/>
+    <p:sldId xmlns:r="http://schemas.openxmlformats.org/officeDocument/2006/relationships" id="266" r:id="Rb76de04ab0a3418d"/>
+    <p:sldId xmlns:r="http://schemas.openxmlformats.org/officeDocument/2006/relationships" id="267" r:id="Rdf7e6012bbcc4215"/>
+    <p:sldId xmlns:r="http://schemas.openxmlformats.org/officeDocument/2006/relationships" id="268" r:id="Rda05934d58ce4b9f"/>
+    <p:sldId xmlns:r="http://schemas.openxmlformats.org/officeDocument/2006/relationships" id="269" r:id="Rb419314befcf41f7"/>
+    <p:sldId xmlns:r="http://schemas.openxmlformats.org/officeDocument/2006/relationships" id="270" r:id="R89a7a9eb28a440a3"/>
+    <p:sldId xmlns:r="http://schemas.openxmlformats.org/officeDocument/2006/relationships" id="271" r:id="R60f291d60bb14134"/>
+    <p:sldId xmlns:r="http://schemas.openxmlformats.org/officeDocument/2006/relationships" id="272" r:id="R3d40a1206a2a4be7"/>
+    <p:sldId xmlns:r="http://schemas.openxmlformats.org/officeDocument/2006/relationships" id="273" r:id="R6ad7e7d1876843bc"/>
+    <p:sldId xmlns:r="http://schemas.openxmlformats.org/officeDocument/2006/relationships" id="274" r:id="R654082119f7f4d83"/>
+    <p:sldId xmlns:r="http://schemas.openxmlformats.org/officeDocument/2006/relationships" id="275" r:id="Rb3c2d07a2f184ea0"/>
+    <p:sldId xmlns:r="http://schemas.openxmlformats.org/officeDocument/2006/relationships" id="276" r:id="R14c2de9aa50c4bd6"/>
+    <p:sldId xmlns:r="http://schemas.openxmlformats.org/officeDocument/2006/relationships" id="277" r:id="Rd2c13914311449be"/>
+    <p:sldId xmlns:r="http://schemas.openxmlformats.org/officeDocument/2006/relationships" id="278" r:id="R092d5832733642ef"/>
+    <p:sldId xmlns:r="http://schemas.openxmlformats.org/officeDocument/2006/relationships" id="279" r:id="R6807bbc698454f7a"/>
+    <p:sldId xmlns:r="http://schemas.openxmlformats.org/officeDocument/2006/relationships" id="280" r:id="R3a803ef766114a2f"/>
+    <p:sldId xmlns:r="http://schemas.openxmlformats.org/officeDocument/2006/relationships" id="281" r:id="R582f4b0f808b4768"/>
+    <p:sldId xmlns:r="http://schemas.openxmlformats.org/officeDocument/2006/relationships" id="282" r:id="Rc97f74535e9d429e"/>
+    <p:sldId xmlns:r="http://schemas.openxmlformats.org/officeDocument/2006/relationships" id="283" r:id="R2e72fbfa3ad248a8"/>
+    <p:sldId xmlns:r="http://schemas.openxmlformats.org/officeDocument/2006/relationships" id="284" r:id="R5f40b5853c6f4a72"/>
+    <p:sldId xmlns:r="http://schemas.openxmlformats.org/officeDocument/2006/relationships" id="285" r:id="R6d3c4fdb60014fad"/>
+    <p:sldId xmlns:r="http://schemas.openxmlformats.org/officeDocument/2006/relationships" id="286" r:id="R1cd621c48f20479d"/>
+    <p:sldId xmlns:r="http://schemas.openxmlformats.org/officeDocument/2006/relationships" id="287" r:id="R4ad5a80a63124657"/>
+    <p:sldId xmlns:r="http://schemas.openxmlformats.org/officeDocument/2006/relationships" id="288" r:id="R2786538b1d484433"/>
+    <p:sldId xmlns:r="http://schemas.openxmlformats.org/officeDocument/2006/relationships" id="289" r:id="R61c5cb0b42684c64"/>
+    <p:sldId xmlns:r="http://schemas.openxmlformats.org/officeDocument/2006/relationships" id="290" r:id="R3c6d1569a2c24791"/>
+    <p:sldId xmlns:r="http://schemas.openxmlformats.org/officeDocument/2006/relationships" id="291" r:id="R0c0182931346430f"/>
   </p:sldIdLst>
   <p:sldSz cx="12192000" cy="6858000"/>
   <p:notesSz cx="6858000" cy="9144000"/>
@@ -492,17 +492,17 @@
           </a:p>
           <a:p xmlns:a="http://schemas.openxmlformats.org/drawingml/2006/main">
             <a:r>
-              <a:t>Analogy bridge: Back-office operations runner → Power Automate cloud flow → today we will move one request through six Standard connectors.</a:t>
-            </a:r>
-          </a:p>
-          <a:p xmlns:a="http://schemas.openxmlformats.org/drawingml/2006/main">
-            <a:r>
-              <a:t>Learner link: [Day 1 learner journey](./README.md)</a:t>
-            </a:r>
-          </a:p>
-          <a:p xmlns:a="http://schemas.openxmlformats.org/drawingml/2006/main">
-            <a:r>
-              <a:t>Analogy reminder: the back-office operations runner helps us see how a Power Automate flow carries one request through defined services. Always return to the official connector or action name and the observable Exercise checkpoint.</a:t>
+              <a:t>Analogy bridge: Back-office operations runner → Power Automate cloud flow → one request moves through the core services, with SharePoint available as an extra filing cabinet.</a:t>
+            </a:r>
+          </a:p>
+          <a:p xmlns:a="http://schemas.openxmlformats.org/drawingml/2006/main">
+            <a:r>
+              <a:t>Learner link: https://teerasej.github.io/cpall-gosoft-power-automate-2026/</a:t>
+            </a:r>
+          </a:p>
+          <a:p xmlns:a="http://schemas.openxmlformats.org/drawingml/2006/main">
+            <a:r>
+              <a:t>Analogy reminder: return to the official connector or action name and the observable Exercise checkpoint.</a:t>
             </a:r>
           </a:p>
         </p:txBody>
@@ -582,12 +582,12 @@
           </a:p>
           <a:p xmlns:a="http://schemas.openxmlformats.org/drawingml/2006/main">
             <a:r>
-              <a:t>Speaker cue: เครื่องหมาย Succeeded ไม่แทนการตรวจ Inbox, Excel, SharePoint หรือ Teams</a:t>
-            </a:r>
-          </a:p>
-          <a:p xmlns:a="http://schemas.openxmlformats.org/drawingml/2006/main">
-            <a:r>
-              <a:t>Analogy reminder: the back-office operations runner helps us see how a Power Automate flow carries one request through defined services. Always return to the official connector or action name and the observable Exercise checkpoint.</a:t>
+              <a:t>Speaker cue: เครื่องหมาย Succeeded ไม่แทนการตรวจ Inbox, Excel หรือ Teams; ผู้ที่เลือก SharePoint ต้องตรวจไฟล์เพิ่ม</a:t>
+            </a:r>
+          </a:p>
+          <a:p xmlns:a="http://schemas.openxmlformats.org/drawingml/2006/main">
+            <a:r>
+              <a:t>Analogy reminder: observable evidence matters at every selected destination.</a:t>
             </a:r>
           </a:p>
         </p:txBody>
@@ -1447,7 +1447,7 @@
           </a:p>
           <a:p xmlns:a="http://schemas.openxmlformats.org/drawingml/2006/main">
             <a:r>
-              <a:t>Teach: ผู้เรียนจะสัมผัส connector ทีละตัวและเห็นผลจริงก่อนต่อเป็น workflow เดียว</a:t>
+              <a:t>Teach: ผู้เรียนจะเห็นผลจริงของ core connector ทีละตัว และเลือกต่อยอด SharePoint ได้เมื่อห้องพร้อม</a:t>
             </a:r>
           </a:p>
           <a:p xmlns:a="http://schemas.openxmlformats.org/drawingml/2006/main">
@@ -1457,7 +1457,7 @@
           </a:p>
           <a:p xmlns:a="http://schemas.openxmlformats.org/drawingml/2006/main">
             <a:r>
-              <a:t>Analogy reminder: the back-office operations runner helps us see how a Power Automate flow carries one request through defined services. Always return to the official connector or action name and the observable Exercise checkpoint.</a:t>
+              <a:t>Analogy reminder: SharePoint is an optional filing cabinet, not a core completion requirement.</a:t>
             </a:r>
           </a:p>
         </p:txBody>
@@ -1967,22 +1967,27 @@
           <a:lstStyle xmlns:a="http://schemas.openxmlformats.org/drawingml/2006/main"/>
           <a:p xmlns:a="http://schemas.openxmlformats.org/drawingml/2006/main">
             <a:r>
-              <a:t>Slide 25: Update the matching row</a:t>
-            </a:r>
-          </a:p>
-          <a:p xmlns:a="http://schemas.openxmlformats.org/drawingml/2006/main">
-            <a:r>
-              <a:t>Teach: `Update a row` ใช้ Key Column `RequestId` และ Forms `Response Id`</a:t>
-            </a:r>
-          </a:p>
-          <a:p xmlns:a="http://schemas.openxmlformats.org/drawingml/2006/main">
-            <a:r>
-              <a:t>Speaker cue: ตรวจทั้ง Status และ Decision และทดสอบคนละ RequestId</a:t>
-            </a:r>
-          </a:p>
-          <a:p xmlns:a="http://schemas.openxmlformats.org/drawingml/2006/main">
-            <a:r>
-              <a:t>Analogy reminder: the back-office operations runner helps us see how a Power Automate flow carries one request through defined services. Always return to the official connector or action name and the observable Exercise checkpoint.</a:t>
+              <a:t>Slide 25: Exercise 3 checkpoint and route handoff</a:t>
+            </a:r>
+          </a:p>
+          <a:p xmlns:a="http://schemas.openxmlformats.org/drawingml/2006/main">
+            <a:r>
+              <a:t>Teach: Exercise 3 ผ่านเมื่อ Approved และ Rejected อัปเดตแถวที่ถูกต้องและส่งอีเมลผลได้</a:t>
+            </a:r>
+          </a:p>
+          <a:p xmlns:a="http://schemas.openxmlformats.org/drawingml/2006/main">
+            <a:r>
+              <a:t>Speaker cue: เวลา 13:30 ให้เลือกเพียงหนึ่งกิจกรรม—Approval reinforcement หรือ SharePoint extension</a:t>
+            </a:r>
+          </a:p>
+          <a:p xmlns:a="http://schemas.openxmlformats.org/drawingml/2006/main">
+            <a:r>
+              <a:t>Jump instruction: หากไม่เลือก SharePoint ให้ส่ง direct link ของ Approval reinforcement เมื่อ checkpoint ผ่านแล้ว ข้าม Slides 26–28 และไป Slide 29 ทันที</a:t>
+            </a:r>
+          </a:p>
+          <a:p xmlns:a="http://schemas.openxmlformats.org/drawingml/2006/main">
+            <a:r>
+              <a:t>Do not show Route A, Route B, or SharePoint build steps to learners assigned to reinforcement.</a:t>
             </a:r>
           </a:p>
         </p:txBody>
@@ -2052,32 +2057,32 @@
           <a:lstStyle xmlns:a="http://schemas.openxmlformats.org/drawingml/2006/main"/>
           <a:p xmlns:a="http://schemas.openxmlformats.org/drawingml/2006/main">
             <a:r>
-              <a:t>Slide 26: SharePoint as the filing cabinet</a:t>
-            </a:r>
-          </a:p>
-          <a:p xmlns:a="http://schemas.openxmlformats.org/drawingml/2006/main">
-            <a:r>
-              <a:t>Teach: Excel ติดตามสถานะ ส่วน SharePoint document library เก็บไฟล์สรุปของ Approved</a:t>
-            </a:r>
-          </a:p>
-          <a:p xmlns:a="http://schemas.openxmlformats.org/drawingml/2006/main">
-            <a:r>
-              <a:t>Speaker cue: ใช้ site/library ที่มีอยู่แล้ว ไม่สร้าง list หรือ site ระหว่างคลาส</a:t>
-            </a:r>
-          </a:p>
-          <a:p xmlns:a="http://schemas.openxmlformats.org/drawingml/2006/main">
-            <a:r>
-              <a:t>Analogy bridge: ตู้เอกสารสำหรับเรื่องที่อนุมัติแล้ว → SharePoint document library → เฉพาะ Approved สร้าง text file หนึ่งไฟล์</a:t>
-            </a:r>
-          </a:p>
-          <a:p xmlns:a="http://schemas.openxmlformats.org/drawingml/2006/main">
-            <a:r>
-              <a:t>Learner link: [Exercise 7](./exercises/07-archive-approved-request-in-sharepoint/README.md)</a:t>
-            </a:r>
-          </a:p>
-          <a:p xmlns:a="http://schemas.openxmlformats.org/drawingml/2006/main">
-            <a:r>
-              <a:t>Analogy reminder: the back-office operations runner helps us see how a Power Automate flow carries one request through defined services. Always return to the official connector or action name and the observable Exercise checkpoint.</a:t>
+              <a:t>Slide 26: Choose the 13:30 route</a:t>
+            </a:r>
+          </a:p>
+          <a:p xmlns:a="http://schemas.openxmlformats.org/drawingml/2006/main">
+            <a:r>
+              <a:t>Teach: วิทยากรเลือก Approval reinforcement หรือ SharePoint extension เพียงเส้นทางเดียว</a:t>
+            </a:r>
+          </a:p>
+          <a:p xmlns:a="http://schemas.openxmlformats.org/drawingml/2006/main">
+            <a:r>
+              <a:t>Speaker cue: ผู้เรียน reinforcement ใช้เฉพาะ checkpoint link; ผู้เรียน SharePoint ใช้ selector หรือ direct route link</a:t>
+            </a:r>
+          </a:p>
+          <a:p xmlns:a="http://schemas.openxmlformats.org/drawingml/2006/main">
+            <a:r>
+              <a:t>Approval reinforcement: https://teerasej.github.io/cpall-gosoft-power-automate-2026/exercises/07-core-approval-reinforcement</a:t>
+            </a:r>
+          </a:p>
+          <a:p xmlns:a="http://schemas.openxmlformats.org/drawingml/2006/main">
+            <a:r>
+              <a:t>SharePoint selector: https://teerasej.github.io/cpall-gosoft-power-automate-2026/exercises/07-archive-approved-request-in-sharepoint</a:t>
+            </a:r>
+          </a:p>
+          <a:p xmlns:a="http://schemas.openxmlformats.org/drawingml/2006/main">
+            <a:r>
+              <a:t>Both paths rejoin at Exercise 8 and Slide 29.</a:t>
             </a:r>
           </a:p>
         </p:txBody>
@@ -2147,22 +2152,37 @@
           <a:lstStyle xmlns:a="http://schemas.openxmlformats.org/drawingml/2006/main"/>
           <a:p xmlns:a="http://schemas.openxmlformats.org/drawingml/2006/main">
             <a:r>
-              <a:t>Slide 27: Create one text file</a:t>
-            </a:r>
-          </a:p>
-          <a:p xmlns:a="http://schemas.openxmlformats.org/drawingml/2006/main">
-            <a:r>
-              <a:t>Teach: `Create file` อยู่ใน If yes หลัง Excel update และใช้ชื่อ `Request-[Response Id].txt`</a:t>
-            </a:r>
-          </a:p>
-          <a:p xmlns:a="http://schemas.openxmlformats.org/drawingml/2006/main">
-            <a:r>
-              <a:t>Speaker cue: ตรวจ Site Address, Folder Path, File Name และ File Content</a:t>
-            </a:r>
-          </a:p>
-          <a:p xmlns:a="http://schemas.openxmlformats.org/drawingml/2006/main">
-            <a:r>
-              <a:t>Analogy reminder: the back-office operations runner helps us see how a Power Automate flow carries one request through defined services. Always return to the official connector or action name and the observable Exercise checkpoint.</a:t>
+              <a:t>Slide 27: SharePoint readiness routes</a:t>
+            </a:r>
+          </a:p>
+          <a:p xmlns:a="http://schemas.openxmlformats.org/drawingml/2006/main">
+            <a:r>
+              <a:t>Teach: Route A สร้างและตรวจ private Team site; Route B ตรวจ site ที่ IT เตรียมให้ ผู้เรียนเปิดเพียง route เดียว</a:t>
+            </a:r>
+          </a:p>
+          <a:p xmlns:a="http://schemas.openxmlformats.org/drawingml/2006/main">
+            <a:r>
+              <a:t>Speaker cue: ส่ง direct link ของ route ที่เลือก ไม่ให้ผู้เรียนอ่านหรือทำอีก route; หาก Upload / Open / Delete ไม่ผ่านให้กลับ reinforcement หรือ Teams</a:t>
+            </a:r>
+          </a:p>
+          <a:p xmlns:a="http://schemas.openxmlformats.org/drawingml/2006/main">
+            <a:r>
+              <a:t>Route A: https://teerasej.github.io/cpall-gosoft-power-automate-2026/exercises/07a-create-and-validate-own-site</a:t>
+            </a:r>
+          </a:p>
+          <a:p xmlns:a="http://schemas.openxmlformats.org/drawingml/2006/main">
+            <a:r>
+              <a:t>Route B: https://teerasej.github.io/cpall-gosoft-power-automate-2026/exercises/07b-validate-it-provided-site</a:t>
+            </a:r>
+          </a:p>
+          <a:p xmlns:a="http://schemas.openxmlformats.org/drawingml/2006/main">
+            <a:r>
+              <a:t>Source: https://support.microsoft.com/office/create-a-team-site-in-sharepoint-ef10c1e7-15f3-42a3-98aa-b5972711777d</a:t>
+            </a:r>
+          </a:p>
+          <a:p xmlns:a="http://schemas.openxmlformats.org/drawingml/2006/main">
+            <a:r>
+              <a:t>Source: https://learn.microsoft.com/sharepoint/modern-experience-sharing-permissions</a:t>
             </a:r>
           </a:p>
         </p:txBody>
@@ -2232,22 +2252,22 @@
           <a:lstStyle xmlns:a="http://schemas.openxmlformats.org/drawingml/2006/main"/>
           <a:p xmlns:a="http://schemas.openxmlformats.org/drawingml/2006/main">
             <a:r>
-              <a:t>Slide 28: Prove the boundary</a:t>
-            </a:r>
-          </a:p>
-          <a:p xmlns:a="http://schemas.openxmlformats.org/drawingml/2006/main">
-            <a:r>
-              <a:t>Teach: Approved ต้องมีไฟล์; Rejected ต้องไม่มีไฟล์</a:t>
-            </a:r>
-          </a:p>
-          <a:p xmlns:a="http://schemas.openxmlformats.org/drawingml/2006/main">
-            <a:r>
-              <a:t>Speaker cue: การไม่เกิดไฟล์ใน Rejected เป็นผลที่ต้องตรวจ ไม่ใช่สิ่งที่เดา</a:t>
-            </a:r>
-          </a:p>
-          <a:p xmlns:a="http://schemas.openxmlformats.org/drawingml/2006/main">
-            <a:r>
-              <a:t>Analogy reminder: the back-office operations runner helps us see how a Power Automate flow carries one request through defined services. Always return to the official connector or action name and the observable Exercise checkpoint.</a:t>
+              <a:t>Slide 28: Rejoin at the checkpoint</a:t>
+            </a:r>
+          </a:p>
+          <a:p xmlns:a="http://schemas.openxmlformats.org/drawingml/2006/main">
+            <a:r>
+              <a:t>Teach: Reinforcement พิสูจน์ Response Id ใน Approval, Excel และ email; SharePoint พิสูจน์ Approved มีไฟล์และ Rejected ไม่มีไฟล์</a:t>
+            </a:r>
+          </a:p>
+          <a:p xmlns:a="http://schemas.openxmlformats.org/drawingml/2006/main">
+            <a:r>
+              <a:t>Speaker cue: บันทึก SharePoint เป็น Passed, Skipped by instructor หรือ Blocked; ไม่มีสถานะใดขวาง Exercise 8</a:t>
+            </a:r>
+          </a:p>
+          <a:p xmlns:a="http://schemas.openxmlformats.org/drawingml/2006/main">
+            <a:r>
+              <a:t>If readiness fails, stop the SharePoint extension and move to reinforcement or Teams without changing to another person's connection.</a:t>
             </a:r>
           </a:p>
         </p:txBody>
@@ -2682,17 +2702,17 @@
           </a:p>
           <a:p xmlns:a="http://schemas.openxmlformats.org/drawingml/2006/main">
             <a:r>
-              <a:t>Speaker cue: Approved: Excel updated, file created, Teams sent. Rejected: Excel updated, no file, Teams sent.</a:t>
-            </a:r>
-          </a:p>
-          <a:p xmlns:a="http://schemas.openxmlformats.org/drawingml/2006/main">
-            <a:r>
-              <a:t>Learner link: [Sample requests](./files/sample-requests.md)</a:t>
-            </a:r>
-          </a:p>
-          <a:p xmlns:a="http://schemas.openxmlformats.org/drawingml/2006/main">
-            <a:r>
-              <a:t>Analogy reminder: the back-office operations runner helps us see how a Power Automate flow carries one request through defined services. Always return to the official connector or action name and the observable Exercise checkpoint.</a:t>
+              <a:t>Speaker cue: Core: Approved and Rejected update Excel and send Teams. Optional SharePoint: Approved creates a file and Rejected does not.</a:t>
+            </a:r>
+          </a:p>
+          <a:p xmlns:a="http://schemas.openxmlformats.org/drawingml/2006/main">
+            <a:r>
+              <a:t>Learner link: https://teerasej.github.io/cpall-gosoft-power-automate-2026/resources/sample-requests</a:t>
+            </a:r>
+          </a:p>
+          <a:p xmlns:a="http://schemas.openxmlformats.org/drawingml/2006/main">
+            <a:r>
+              <a:t>Do not mark SharePoint as failed core completion when it was skipped or blocked.</a:t>
             </a:r>
           </a:p>
         </p:txBody>
@@ -3037,17 +3057,12 @@
           </a:p>
           <a:p xmlns:a="http://schemas.openxmlformats.org/drawingml/2006/main">
             <a:r>
-              <a:t>Speaker cue: ทบทวน Outlook, Forms, Excel, Approvals, SharePoint, Teams และ error recovery; จบ 16:00</a:t>
-            </a:r>
-          </a:p>
-          <a:p xmlns:a="http://schemas.openxmlformats.org/drawingml/2006/main">
-            <a:r>
-              <a:t>Analogy bridge: ผู้ช่วยหลังร้านทำตามขั้นตอนที่กำหนด → Day 1 Power Automate; พรุ่งนี้ผู้ช่วยหน้าเคาน์เตอร์จะสนทนาและส่งงานที่ยืนยันแล้วมาให้ flow</a:t>
-            </a:r>
-          </a:p>
-          <a:p xmlns:a="http://schemas.openxmlformats.org/drawingml/2006/main">
-            <a:r>
-              <a:t>Analogy reminder: the back-office operations runner helps us see how a Power Automate flow carries one request through defined services. Always return to the official connector or action name and the observable Exercise checkpoint.</a:t>
+              <a:t>Speaker cue: ทบทวน Outlook, Forms, Excel, Approvals, Teams และ error recovery; SharePoint เป็นหลักฐานเสริมเมื่อเลือกทำ; จบ 16:00</a:t>
+            </a:r>
+          </a:p>
+          <a:p xmlns:a="http://schemas.openxmlformats.org/drawingml/2006/main">
+            <a:r>
+              <a:t>Analogy bridge: ผู้ช่วยหลังร้านทำตามขั้นตอนที่กำหนด → Day 1 Power Automate; พรุ่งนี้ผู้ช่วยหน้าเคาน์เตอร์จะสนทนาและส่งงานที่ยืนยันแล้วมาให้ flow.</a:t>
             </a:r>
           </a:p>
         </p:txBody>
@@ -3122,7 +3137,7 @@
           </a:p>
           <a:p xmlns:a="http://schemas.openxmlformats.org/drawingml/2006/main">
             <a:r>
-              <a:t>Teach: สร้าง ทดสอบ ตรวจผลปลายทาง และอ่าน Run history ได้</a:t>
+              <a:t>Teach: สร้าง ทดสอบ ตรวจผลปลายทาง และอ่าน Run history ได้ โดยไม่ต้องผ่าน SharePoint</a:t>
             </a:r>
           </a:p>
           <a:p xmlns:a="http://schemas.openxmlformats.org/drawingml/2006/main">
@@ -3132,7 +3147,7 @@
           </a:p>
           <a:p xmlns:a="http://schemas.openxmlformats.org/drawingml/2006/main">
             <a:r>
-              <a:t>Analogy reminder: the back-office operations runner helps us see how a Power Automate flow carries one request through defined services. Always return to the official connector or action name and the observable Exercise checkpoint.</a:t>
+              <a:t>Core completion: Outlook, Forms, Excel, Approvals, Teams and recovery. SharePoint evidence is optional.</a:t>
             </a:r>
           </a:p>
         </p:txBody>
@@ -3467,7 +3482,7 @@
           </a:p>
           <a:p xmlns:a="http://schemas.openxmlformats.org/drawingml/2006/main">
             <a:r>
-              <a:t>Teach: Outlook, Forms, Excel, Approvals, SharePoint และ Teams เป็น Standard connectors ในเส้นทางนี้</a:t>
+              <a:t>Teach: Outlook, Forms, Excel, Approvals และ Teams เป็น core Standard connectors; SharePoint เป็น Standard connector ใน extension</a:t>
             </a:r>
           </a:p>
           <a:p xmlns:a="http://schemas.openxmlformats.org/drawingml/2006/main">
@@ -3477,12 +3492,7 @@
           </a:p>
           <a:p xmlns:a="http://schemas.openxmlformats.org/drawingml/2006/main">
             <a:r>
-              <a:t>Analogy bridge: จุดบริการหกจุดในหลังร้าน → six Standard connectors → แต่ละ Exercise มี checkpoint ที่ปลายทางจริง</a:t>
-            </a:r>
-          </a:p>
-          <a:p xmlns:a="http://schemas.openxmlformats.org/drawingml/2006/main">
-            <a:r>
-              <a:t>Analogy reminder: the back-office operations runner helps us see how a Power Automate flow carries one request through defined services. Always return to the official connector or action name and the observable Exercise checkpoint.</a:t>
+              <a:t>Analogy bridge: จุดบริการหลักในหลังร้าน → core Standard connectors → SharePoint เป็นตู้เอกสารเสริมเมื่อพื้นที่พร้อม.</a:t>
             </a:r>
           </a:p>
         </p:txBody>
@@ -3640,7 +3650,7 @@
   </p:cSld>
   <p:clrMap bg1="lt1" tx1="dk1" bg2="lt2" tx2="dk2" accent1="accent1" accent2="accent2" accent3="accent3" accent4="accent4" accent5="accent5" accent6="accent6" hlink="hlink" folHlink="folHlink"/>
   <p:sldLayoutIdLst>
-    <p:sldLayoutId xmlns:r="http://schemas.openxmlformats.org/officeDocument/2006/relationships" id="2147483649" r:id="Rd6692138b1c34688"/>
+    <p:sldLayoutId xmlns:r="http://schemas.openxmlformats.org/officeDocument/2006/relationships" id="2147483649" r:id="R3a2a0bfd228f4f96"/>
   </p:sldLayoutIdLst>
   <p:txStyles>
     <p:titleStyle>
@@ -4220,6 +4230,7 @@
           <a:lstStyle xmlns:a="http://schemas.openxmlformats.org/drawingml/2006/main"/>
           <a:p xmlns:a="http://schemas.openxmlformats.org/drawingml/2006/main">
             <a:pPr algn="l">
+              <a:buNone/>
               <a:defRPr sz="1125" b="1">
                 <a:solidFill>
                   <a:srgbClr val="C83C42"/>
@@ -4277,6 +4288,7 @@
           <a:lstStyle xmlns:a="http://schemas.openxmlformats.org/drawingml/2006/main"/>
           <a:p xmlns:a="http://schemas.openxmlformats.org/drawingml/2006/main">
             <a:pPr algn="l">
+              <a:buNone/>
               <a:defRPr sz="2925" b="1">
                 <a:solidFill>
                   <a:srgbClr val="17324D"/>
@@ -4367,6 +4379,7 @@
           <a:lstStyle xmlns:a="http://schemas.openxmlformats.org/drawingml/2006/main"/>
           <a:p xmlns:a="http://schemas.openxmlformats.org/drawingml/2006/main">
             <a:pPr algn="l">
+              <a:buNone/>
               <a:defRPr sz="975" b="0">
                 <a:solidFill>
                   <a:srgbClr val="506174"/>
@@ -4424,6 +4437,7 @@
           <a:lstStyle xmlns:a="http://schemas.openxmlformats.org/drawingml/2006/main"/>
           <a:p xmlns:a="http://schemas.openxmlformats.org/drawingml/2006/main">
             <a:pPr algn="r">
+              <a:buNone/>
               <a:defRPr sz="1200" b="1">
                 <a:solidFill>
                   <a:srgbClr val="17324D"/>
@@ -4514,6 +4528,7 @@
           <a:lstStyle xmlns:a="http://schemas.openxmlformats.org/drawingml/2006/main"/>
           <a:p xmlns:a="http://schemas.openxmlformats.org/drawingml/2006/main">
             <a:pPr algn="l">
+              <a:buNone/>
               <a:defRPr sz="2850" b="1">
                 <a:solidFill>
                   <a:srgbClr val="17324D"/>
@@ -4537,6 +4552,7 @@
           </a:p>
           <a:p xmlns:a="http://schemas.openxmlformats.org/drawingml/2006/main">
             <a:pPr algn="l">
+              <a:buNone/>
               <a:defRPr sz="2850" b="1">
                 <a:solidFill>
                   <a:srgbClr val="17324D"/>
@@ -4594,6 +4610,7 @@
           <a:lstStyle xmlns:a="http://schemas.openxmlformats.org/drawingml/2006/main"/>
           <a:p xmlns:a="http://schemas.openxmlformats.org/drawingml/2006/main">
             <a:pPr algn="l">
+              <a:buNone/>
               <a:defRPr sz="1875" b="0">
                 <a:solidFill>
                   <a:srgbClr val="506174"/>
@@ -4686,6 +4703,7 @@
           <a:lstStyle xmlns:a="http://schemas.openxmlformats.org/drawingml/2006/main"/>
           <a:p xmlns:a="http://schemas.openxmlformats.org/drawingml/2006/main">
             <a:pPr algn="ctr">
+              <a:buNone/>
               <a:defRPr sz="1500" b="1">
                 <a:solidFill>
                   <a:srgbClr val="C83C42"/>
@@ -4711,14 +4729,14 @@
       </p:sp>
       <p:pic>
         <p:nvPicPr>
-          <p:cNvPr id="22" name=""/>
+          <p:cNvPr id="24" name=""/>
           <p:cNvPicPr>
             <a:picLocks xmlns:a="http://schemas.openxmlformats.org/drawingml/2006/main" noChangeAspect="1"/>
           </p:cNvPicPr>
           <p:nvPr/>
         </p:nvPicPr>
         <p:blipFill>
-          <a:blip xmlns:r="http://schemas.openxmlformats.org/officeDocument/2006/relationships" xmlns:a="http://schemas.openxmlformats.org/drawingml/2006/main" r:embed="R52ee9752021d49b1"/>
+          <a:blip xmlns:r="http://schemas.openxmlformats.org/officeDocument/2006/relationships" xmlns:a="http://schemas.openxmlformats.org/drawingml/2006/main" r:embed="R1f2a4af5009c45f0"/>
           <a:srcRect xmlns:a="http://schemas.openxmlformats.org/drawingml/2006/main" l="16915" t="0" r="16915" b="0"/>
           <a:stretch xmlns:a="http://schemas.openxmlformats.org/drawingml/2006/main">
             <a:fillRect l="0" t="0" r="0" b="0"/>
@@ -4799,6 +4817,7 @@
           <a:lstStyle xmlns:a="http://schemas.openxmlformats.org/drawingml/2006/main"/>
           <a:p xmlns:a="http://schemas.openxmlformats.org/drawingml/2006/main">
             <a:pPr algn="l">
+              <a:buNone/>
               <a:defRPr sz="1125" b="1">
                 <a:solidFill>
                   <a:srgbClr val="C83C42"/>
@@ -4856,6 +4875,7 @@
           <a:lstStyle xmlns:a="http://schemas.openxmlformats.org/drawingml/2006/main"/>
           <a:p xmlns:a="http://schemas.openxmlformats.org/drawingml/2006/main">
             <a:pPr algn="l">
+              <a:buNone/>
               <a:defRPr sz="2925" b="1">
                 <a:solidFill>
                   <a:srgbClr val="17324D"/>
@@ -4946,6 +4966,7 @@
           <a:lstStyle xmlns:a="http://schemas.openxmlformats.org/drawingml/2006/main"/>
           <a:p xmlns:a="http://schemas.openxmlformats.org/drawingml/2006/main">
             <a:pPr algn="l">
+              <a:buNone/>
               <a:defRPr sz="975" b="0">
                 <a:solidFill>
                   <a:srgbClr val="506174"/>
@@ -5003,6 +5024,7 @@
           <a:lstStyle xmlns:a="http://schemas.openxmlformats.org/drawingml/2006/main"/>
           <a:p xmlns:a="http://schemas.openxmlformats.org/drawingml/2006/main">
             <a:pPr algn="r">
+              <a:buNone/>
               <a:defRPr sz="1200" b="1">
                 <a:solidFill>
                   <a:srgbClr val="17324D"/>
@@ -5060,6 +5082,7 @@
           <a:lstStyle xmlns:a="http://schemas.openxmlformats.org/drawingml/2006/main"/>
           <a:p xmlns:a="http://schemas.openxmlformats.org/drawingml/2006/main">
             <a:pPr algn="ctr">
+              <a:buNone/>
               <a:defRPr sz="2100" b="1">
                 <a:solidFill>
                   <a:srgbClr val="17324D"/>
@@ -5152,6 +5175,7 @@
           <a:lstStyle xmlns:a="http://schemas.openxmlformats.org/drawingml/2006/main"/>
           <a:p xmlns:a="http://schemas.openxmlformats.org/drawingml/2006/main">
             <a:pPr algn="l">
+              <a:buNone/>
               <a:defRPr sz="1275" b="1">
                 <a:solidFill>
                   <a:srgbClr val="C83C42"/>
@@ -5209,6 +5233,7 @@
           <a:lstStyle xmlns:a="http://schemas.openxmlformats.org/drawingml/2006/main"/>
           <a:p xmlns:a="http://schemas.openxmlformats.org/drawingml/2006/main">
             <a:pPr algn="ctr">
+              <a:buNone/>
               <a:defRPr sz="1650" b="1">
                 <a:solidFill>
                   <a:srgbClr val="17324D"/>
@@ -5334,6 +5359,7 @@
           <a:lstStyle xmlns:a="http://schemas.openxmlformats.org/drawingml/2006/main"/>
           <a:p xmlns:a="http://schemas.openxmlformats.org/drawingml/2006/main">
             <a:pPr algn="l">
+              <a:buNone/>
               <a:defRPr sz="1275" b="1">
                 <a:solidFill>
                   <a:srgbClr val="C83C42"/>
@@ -5391,6 +5417,7 @@
           <a:lstStyle xmlns:a="http://schemas.openxmlformats.org/drawingml/2006/main"/>
           <a:p xmlns:a="http://schemas.openxmlformats.org/drawingml/2006/main">
             <a:pPr algn="ctr">
+              <a:buNone/>
               <a:defRPr sz="1650" b="1">
                 <a:solidFill>
                   <a:srgbClr val="17324D"/>
@@ -5483,6 +5510,7 @@
           <a:lstStyle xmlns:a="http://schemas.openxmlformats.org/drawingml/2006/main"/>
           <a:p xmlns:a="http://schemas.openxmlformats.org/drawingml/2006/main">
             <a:pPr algn="l">
+              <a:buNone/>
               <a:defRPr sz="1125" b="1">
                 <a:solidFill>
                   <a:srgbClr val="C83C42"/>
@@ -5540,6 +5568,7 @@
           <a:lstStyle xmlns:a="http://schemas.openxmlformats.org/drawingml/2006/main"/>
           <a:p xmlns:a="http://schemas.openxmlformats.org/drawingml/2006/main">
             <a:pPr algn="l">
+              <a:buNone/>
               <a:defRPr sz="1575" b="0">
                 <a:solidFill>
                   <a:srgbClr val="17324D"/>
@@ -5558,7 +5587,7 @@
                 <a:ea typeface="Tahoma"/>
                 <a:cs typeface="Tahoma"/>
               </a:rPr>
-              <a:t>เครื่องหมาย Succeeded ไม่แทนการตรวจ Inbox, Excel, SharePoint หรือ Teams</a:t>
+              <a:t>Succeeded ไม่แทนการตรวจ Inbox, Excel หรือ Teams; SharePoint ต้องตรวจไฟล์เพิ่ม</a:t>
             </a:r>
           </a:p>
         </p:txBody>
@@ -5626,6 +5655,7 @@
           <a:lstStyle xmlns:a="http://schemas.openxmlformats.org/drawingml/2006/main"/>
           <a:p xmlns:a="http://schemas.openxmlformats.org/drawingml/2006/main">
             <a:pPr algn="l">
+              <a:buNone/>
               <a:defRPr sz="1125" b="1">
                 <a:solidFill>
                   <a:srgbClr val="C83C42"/>
@@ -5683,6 +5713,7 @@
           <a:lstStyle xmlns:a="http://schemas.openxmlformats.org/drawingml/2006/main"/>
           <a:p xmlns:a="http://schemas.openxmlformats.org/drawingml/2006/main">
             <a:pPr algn="l">
+              <a:buNone/>
               <a:defRPr sz="2925" b="1">
                 <a:solidFill>
                   <a:srgbClr val="17324D"/>
@@ -5773,6 +5804,7 @@
           <a:lstStyle xmlns:a="http://schemas.openxmlformats.org/drawingml/2006/main"/>
           <a:p xmlns:a="http://schemas.openxmlformats.org/drawingml/2006/main">
             <a:pPr algn="l">
+              <a:buNone/>
               <a:defRPr sz="975" b="0">
                 <a:solidFill>
                   <a:srgbClr val="506174"/>
@@ -5830,6 +5862,7 @@
           <a:lstStyle xmlns:a="http://schemas.openxmlformats.org/drawingml/2006/main"/>
           <a:p xmlns:a="http://schemas.openxmlformats.org/drawingml/2006/main">
             <a:pPr algn="r">
+              <a:buNone/>
               <a:defRPr sz="1200" b="1">
                 <a:solidFill>
                   <a:srgbClr val="17324D"/>
@@ -5887,6 +5920,7 @@
           <a:lstStyle xmlns:a="http://schemas.openxmlformats.org/drawingml/2006/main"/>
           <a:p xmlns:a="http://schemas.openxmlformats.org/drawingml/2006/main">
             <a:pPr algn="ctr">
+              <a:buNone/>
               <a:defRPr sz="2100" b="1">
                 <a:solidFill>
                   <a:srgbClr val="17324D"/>
@@ -5979,6 +6013,7 @@
           <a:lstStyle xmlns:a="http://schemas.openxmlformats.org/drawingml/2006/main"/>
           <a:p xmlns:a="http://schemas.openxmlformats.org/drawingml/2006/main">
             <a:pPr algn="l">
+              <a:buNone/>
               <a:defRPr sz="1275" b="1">
                 <a:solidFill>
                   <a:srgbClr val="C83C42"/>
@@ -6036,6 +6071,7 @@
           <a:lstStyle xmlns:a="http://schemas.openxmlformats.org/drawingml/2006/main"/>
           <a:p xmlns:a="http://schemas.openxmlformats.org/drawingml/2006/main">
             <a:pPr algn="ctr">
+              <a:buNone/>
               <a:defRPr sz="1650" b="1">
                 <a:solidFill>
                   <a:srgbClr val="17324D"/>
@@ -6161,6 +6197,7 @@
           <a:lstStyle xmlns:a="http://schemas.openxmlformats.org/drawingml/2006/main"/>
           <a:p xmlns:a="http://schemas.openxmlformats.org/drawingml/2006/main">
             <a:pPr algn="l">
+              <a:buNone/>
               <a:defRPr sz="1275" b="1">
                 <a:solidFill>
                   <a:srgbClr val="C83C42"/>
@@ -6218,6 +6255,7 @@
           <a:lstStyle xmlns:a="http://schemas.openxmlformats.org/drawingml/2006/main"/>
           <a:p xmlns:a="http://schemas.openxmlformats.org/drawingml/2006/main">
             <a:pPr algn="ctr">
+              <a:buNone/>
               <a:defRPr sz="1650" b="1">
                 <a:solidFill>
                   <a:srgbClr val="17324D"/>
@@ -6310,6 +6348,7 @@
           <a:lstStyle xmlns:a="http://schemas.openxmlformats.org/drawingml/2006/main"/>
           <a:p xmlns:a="http://schemas.openxmlformats.org/drawingml/2006/main">
             <a:pPr algn="l">
+              <a:buNone/>
               <a:defRPr sz="1125" b="1">
                 <a:solidFill>
                   <a:srgbClr val="C83C42"/>
@@ -6367,6 +6406,7 @@
           <a:lstStyle xmlns:a="http://schemas.openxmlformats.org/drawingml/2006/main"/>
           <a:p xmlns:a="http://schemas.openxmlformats.org/drawingml/2006/main">
             <a:pPr algn="l">
+              <a:buNone/>
               <a:defRPr sz="1575" b="0">
                 <a:solidFill>
                   <a:srgbClr val="17324D"/>
@@ -6453,6 +6493,7 @@
           <a:lstStyle xmlns:a="http://schemas.openxmlformats.org/drawingml/2006/main"/>
           <a:p xmlns:a="http://schemas.openxmlformats.org/drawingml/2006/main">
             <a:pPr algn="l">
+              <a:buNone/>
               <a:defRPr sz="1125" b="1">
                 <a:solidFill>
                   <a:srgbClr val="C83C42"/>
@@ -6510,6 +6551,7 @@
           <a:lstStyle xmlns:a="http://schemas.openxmlformats.org/drawingml/2006/main"/>
           <a:p xmlns:a="http://schemas.openxmlformats.org/drawingml/2006/main">
             <a:pPr algn="l">
+              <a:buNone/>
               <a:defRPr sz="2925" b="1">
                 <a:solidFill>
                   <a:srgbClr val="17324D"/>
@@ -6600,6 +6642,7 @@
           <a:lstStyle xmlns:a="http://schemas.openxmlformats.org/drawingml/2006/main"/>
           <a:p xmlns:a="http://schemas.openxmlformats.org/drawingml/2006/main">
             <a:pPr algn="l">
+              <a:buNone/>
               <a:defRPr sz="975" b="0">
                 <a:solidFill>
                   <a:srgbClr val="506174"/>
@@ -6657,6 +6700,7 @@
           <a:lstStyle xmlns:a="http://schemas.openxmlformats.org/drawingml/2006/main"/>
           <a:p xmlns:a="http://schemas.openxmlformats.org/drawingml/2006/main">
             <a:pPr algn="r">
+              <a:buNone/>
               <a:defRPr sz="1200" b="1">
                 <a:solidFill>
                   <a:srgbClr val="17324D"/>
@@ -6714,6 +6758,7 @@
           <a:lstStyle xmlns:a="http://schemas.openxmlformats.org/drawingml/2006/main"/>
           <a:p xmlns:a="http://schemas.openxmlformats.org/drawingml/2006/main">
             <a:pPr algn="ctr">
+              <a:buNone/>
               <a:defRPr sz="2100" b="1">
                 <a:solidFill>
                   <a:srgbClr val="17324D"/>
@@ -6806,6 +6851,7 @@
           <a:lstStyle xmlns:a="http://schemas.openxmlformats.org/drawingml/2006/main"/>
           <a:p xmlns:a="http://schemas.openxmlformats.org/drawingml/2006/main">
             <a:pPr algn="l">
+              <a:buNone/>
               <a:defRPr sz="1275" b="1">
                 <a:solidFill>
                   <a:srgbClr val="C83C42"/>
@@ -6863,6 +6909,7 @@
           <a:lstStyle xmlns:a="http://schemas.openxmlformats.org/drawingml/2006/main"/>
           <a:p xmlns:a="http://schemas.openxmlformats.org/drawingml/2006/main">
             <a:pPr algn="ctr">
+              <a:buNone/>
               <a:defRPr sz="1650" b="1">
                 <a:solidFill>
                   <a:srgbClr val="17324D"/>
@@ -6988,6 +7035,7 @@
           <a:lstStyle xmlns:a="http://schemas.openxmlformats.org/drawingml/2006/main"/>
           <a:p xmlns:a="http://schemas.openxmlformats.org/drawingml/2006/main">
             <a:pPr algn="l">
+              <a:buNone/>
               <a:defRPr sz="1275" b="1">
                 <a:solidFill>
                   <a:srgbClr val="C83C42"/>
@@ -7045,6 +7093,7 @@
           <a:lstStyle xmlns:a="http://schemas.openxmlformats.org/drawingml/2006/main"/>
           <a:p xmlns:a="http://schemas.openxmlformats.org/drawingml/2006/main">
             <a:pPr algn="ctr">
+              <a:buNone/>
               <a:defRPr sz="1650" b="1">
                 <a:solidFill>
                   <a:srgbClr val="17324D"/>
@@ -7137,6 +7186,7 @@
           <a:lstStyle xmlns:a="http://schemas.openxmlformats.org/drawingml/2006/main"/>
           <a:p xmlns:a="http://schemas.openxmlformats.org/drawingml/2006/main">
             <a:pPr algn="l">
+              <a:buNone/>
               <a:defRPr sz="1125" b="1">
                 <a:solidFill>
                   <a:srgbClr val="C83C42"/>
@@ -7194,6 +7244,7 @@
           <a:lstStyle xmlns:a="http://schemas.openxmlformats.org/drawingml/2006/main"/>
           <a:p xmlns:a="http://schemas.openxmlformats.org/drawingml/2006/main">
             <a:pPr algn="l">
+              <a:buNone/>
               <a:defRPr sz="1575" b="0">
                 <a:solidFill>
                   <a:srgbClr val="17324D"/>
@@ -7280,6 +7331,7 @@
           <a:lstStyle xmlns:a="http://schemas.openxmlformats.org/drawingml/2006/main"/>
           <a:p xmlns:a="http://schemas.openxmlformats.org/drawingml/2006/main">
             <a:pPr algn="l">
+              <a:buNone/>
               <a:defRPr sz="1125" b="1">
                 <a:solidFill>
                   <a:srgbClr val="C83C42"/>
@@ -7337,6 +7389,7 @@
           <a:lstStyle xmlns:a="http://schemas.openxmlformats.org/drawingml/2006/main"/>
           <a:p xmlns:a="http://schemas.openxmlformats.org/drawingml/2006/main">
             <a:pPr algn="l">
+              <a:buNone/>
               <a:defRPr sz="2925" b="1">
                 <a:solidFill>
                   <a:srgbClr val="17324D"/>
@@ -7427,6 +7480,7 @@
           <a:lstStyle xmlns:a="http://schemas.openxmlformats.org/drawingml/2006/main"/>
           <a:p xmlns:a="http://schemas.openxmlformats.org/drawingml/2006/main">
             <a:pPr algn="l">
+              <a:buNone/>
               <a:defRPr sz="975" b="0">
                 <a:solidFill>
                   <a:srgbClr val="506174"/>
@@ -7484,6 +7538,7 @@
           <a:lstStyle xmlns:a="http://schemas.openxmlformats.org/drawingml/2006/main"/>
           <a:p xmlns:a="http://schemas.openxmlformats.org/drawingml/2006/main">
             <a:pPr algn="r">
+              <a:buNone/>
               <a:defRPr sz="1200" b="1">
                 <a:solidFill>
                   <a:srgbClr val="17324D"/>
@@ -7541,6 +7596,7 @@
           <a:lstStyle xmlns:a="http://schemas.openxmlformats.org/drawingml/2006/main"/>
           <a:p xmlns:a="http://schemas.openxmlformats.org/drawingml/2006/main">
             <a:pPr algn="ctr">
+              <a:buNone/>
               <a:defRPr sz="2100" b="1">
                 <a:solidFill>
                   <a:srgbClr val="17324D"/>
@@ -7633,6 +7689,7 @@
           <a:lstStyle xmlns:a="http://schemas.openxmlformats.org/drawingml/2006/main"/>
           <a:p xmlns:a="http://schemas.openxmlformats.org/drawingml/2006/main">
             <a:pPr algn="l">
+              <a:buNone/>
               <a:defRPr sz="1275" b="1">
                 <a:solidFill>
                   <a:srgbClr val="C83C42"/>
@@ -7690,6 +7747,7 @@
           <a:lstStyle xmlns:a="http://schemas.openxmlformats.org/drawingml/2006/main"/>
           <a:p xmlns:a="http://schemas.openxmlformats.org/drawingml/2006/main">
             <a:pPr algn="ctr">
+              <a:buNone/>
               <a:defRPr sz="1650" b="1">
                 <a:solidFill>
                   <a:srgbClr val="17324D"/>
@@ -7815,6 +7873,7 @@
           <a:lstStyle xmlns:a="http://schemas.openxmlformats.org/drawingml/2006/main"/>
           <a:p xmlns:a="http://schemas.openxmlformats.org/drawingml/2006/main">
             <a:pPr algn="l">
+              <a:buNone/>
               <a:defRPr sz="1275" b="1">
                 <a:solidFill>
                   <a:srgbClr val="C83C42"/>
@@ -7872,6 +7931,7 @@
           <a:lstStyle xmlns:a="http://schemas.openxmlformats.org/drawingml/2006/main"/>
           <a:p xmlns:a="http://schemas.openxmlformats.org/drawingml/2006/main">
             <a:pPr algn="ctr">
+              <a:buNone/>
               <a:defRPr sz="1650" b="1">
                 <a:solidFill>
                   <a:srgbClr val="17324D"/>
@@ -7964,6 +8024,7 @@
           <a:lstStyle xmlns:a="http://schemas.openxmlformats.org/drawingml/2006/main"/>
           <a:p xmlns:a="http://schemas.openxmlformats.org/drawingml/2006/main">
             <a:pPr algn="l">
+              <a:buNone/>
               <a:defRPr sz="1125" b="1">
                 <a:solidFill>
                   <a:srgbClr val="C83C42"/>
@@ -8021,6 +8082,7 @@
           <a:lstStyle xmlns:a="http://schemas.openxmlformats.org/drawingml/2006/main"/>
           <a:p xmlns:a="http://schemas.openxmlformats.org/drawingml/2006/main">
             <a:pPr algn="l">
+              <a:buNone/>
               <a:defRPr sz="1575" b="0">
                 <a:solidFill>
                   <a:srgbClr val="17324D"/>
@@ -8107,6 +8169,7 @@
           <a:lstStyle xmlns:a="http://schemas.openxmlformats.org/drawingml/2006/main"/>
           <a:p xmlns:a="http://schemas.openxmlformats.org/drawingml/2006/main">
             <a:pPr algn="l">
+              <a:buNone/>
               <a:defRPr sz="1125" b="1">
                 <a:solidFill>
                   <a:srgbClr val="C83C42"/>
@@ -8164,6 +8227,7 @@
           <a:lstStyle xmlns:a="http://schemas.openxmlformats.org/drawingml/2006/main"/>
           <a:p xmlns:a="http://schemas.openxmlformats.org/drawingml/2006/main">
             <a:pPr algn="l">
+              <a:buNone/>
               <a:defRPr sz="2925" b="1">
                 <a:solidFill>
                   <a:srgbClr val="17324D"/>
@@ -8254,6 +8318,7 @@
           <a:lstStyle xmlns:a="http://schemas.openxmlformats.org/drawingml/2006/main"/>
           <a:p xmlns:a="http://schemas.openxmlformats.org/drawingml/2006/main">
             <a:pPr algn="l">
+              <a:buNone/>
               <a:defRPr sz="975" b="0">
                 <a:solidFill>
                   <a:srgbClr val="506174"/>
@@ -8311,6 +8376,7 @@
           <a:lstStyle xmlns:a="http://schemas.openxmlformats.org/drawingml/2006/main"/>
           <a:p xmlns:a="http://schemas.openxmlformats.org/drawingml/2006/main">
             <a:pPr algn="r">
+              <a:buNone/>
               <a:defRPr sz="1200" b="1">
                 <a:solidFill>
                   <a:srgbClr val="17324D"/>
@@ -8368,6 +8434,7 @@
           <a:lstStyle xmlns:a="http://schemas.openxmlformats.org/drawingml/2006/main"/>
           <a:p xmlns:a="http://schemas.openxmlformats.org/drawingml/2006/main">
             <a:pPr algn="ctr">
+              <a:buNone/>
               <a:defRPr sz="2100" b="1">
                 <a:solidFill>
                   <a:srgbClr val="17324D"/>
@@ -8460,6 +8527,7 @@
           <a:lstStyle xmlns:a="http://schemas.openxmlformats.org/drawingml/2006/main"/>
           <a:p xmlns:a="http://schemas.openxmlformats.org/drawingml/2006/main">
             <a:pPr algn="l">
+              <a:buNone/>
               <a:defRPr sz="1275" b="1">
                 <a:solidFill>
                   <a:srgbClr val="C83C42"/>
@@ -8517,6 +8585,7 @@
           <a:lstStyle xmlns:a="http://schemas.openxmlformats.org/drawingml/2006/main"/>
           <a:p xmlns:a="http://schemas.openxmlformats.org/drawingml/2006/main">
             <a:pPr algn="ctr">
+              <a:buNone/>
               <a:defRPr sz="1650" b="1">
                 <a:solidFill>
                   <a:srgbClr val="17324D"/>
@@ -8642,6 +8711,7 @@
           <a:lstStyle xmlns:a="http://schemas.openxmlformats.org/drawingml/2006/main"/>
           <a:p xmlns:a="http://schemas.openxmlformats.org/drawingml/2006/main">
             <a:pPr algn="l">
+              <a:buNone/>
               <a:defRPr sz="1275" b="1">
                 <a:solidFill>
                   <a:srgbClr val="C83C42"/>
@@ -8699,6 +8769,7 @@
           <a:lstStyle xmlns:a="http://schemas.openxmlformats.org/drawingml/2006/main"/>
           <a:p xmlns:a="http://schemas.openxmlformats.org/drawingml/2006/main">
             <a:pPr algn="ctr">
+              <a:buNone/>
               <a:defRPr sz="1650" b="1">
                 <a:solidFill>
                   <a:srgbClr val="17324D"/>
@@ -8791,6 +8862,7 @@
           <a:lstStyle xmlns:a="http://schemas.openxmlformats.org/drawingml/2006/main"/>
           <a:p xmlns:a="http://schemas.openxmlformats.org/drawingml/2006/main">
             <a:pPr algn="l">
+              <a:buNone/>
               <a:defRPr sz="1125" b="1">
                 <a:solidFill>
                   <a:srgbClr val="C83C42"/>
@@ -8848,6 +8920,7 @@
           <a:lstStyle xmlns:a="http://schemas.openxmlformats.org/drawingml/2006/main"/>
           <a:p xmlns:a="http://schemas.openxmlformats.org/drawingml/2006/main">
             <a:pPr algn="l">
+              <a:buNone/>
               <a:defRPr sz="1575" b="0">
                 <a:solidFill>
                   <a:srgbClr val="17324D"/>
@@ -8934,6 +9007,7 @@
           <a:lstStyle xmlns:a="http://schemas.openxmlformats.org/drawingml/2006/main"/>
           <a:p xmlns:a="http://schemas.openxmlformats.org/drawingml/2006/main">
             <a:pPr algn="l">
+              <a:buNone/>
               <a:defRPr sz="1125" b="1">
                 <a:solidFill>
                   <a:srgbClr val="C83C42"/>
@@ -8991,6 +9065,7 @@
           <a:lstStyle xmlns:a="http://schemas.openxmlformats.org/drawingml/2006/main"/>
           <a:p xmlns:a="http://schemas.openxmlformats.org/drawingml/2006/main">
             <a:pPr algn="l">
+              <a:buNone/>
               <a:defRPr sz="2925" b="1">
                 <a:solidFill>
                   <a:srgbClr val="17324D"/>
@@ -9081,6 +9156,7 @@
           <a:lstStyle xmlns:a="http://schemas.openxmlformats.org/drawingml/2006/main"/>
           <a:p xmlns:a="http://schemas.openxmlformats.org/drawingml/2006/main">
             <a:pPr algn="l">
+              <a:buNone/>
               <a:defRPr sz="975" b="0">
                 <a:solidFill>
                   <a:srgbClr val="506174"/>
@@ -9138,6 +9214,7 @@
           <a:lstStyle xmlns:a="http://schemas.openxmlformats.org/drawingml/2006/main"/>
           <a:p xmlns:a="http://schemas.openxmlformats.org/drawingml/2006/main">
             <a:pPr algn="r">
+              <a:buNone/>
               <a:defRPr sz="1200" b="1">
                 <a:solidFill>
                   <a:srgbClr val="17324D"/>
@@ -9195,6 +9272,7 @@
           <a:lstStyle xmlns:a="http://schemas.openxmlformats.org/drawingml/2006/main"/>
           <a:p xmlns:a="http://schemas.openxmlformats.org/drawingml/2006/main">
             <a:pPr algn="ctr">
+              <a:buNone/>
               <a:defRPr sz="2100" b="1">
                 <a:solidFill>
                   <a:srgbClr val="17324D"/>
@@ -9287,6 +9365,7 @@
           <a:lstStyle xmlns:a="http://schemas.openxmlformats.org/drawingml/2006/main"/>
           <a:p xmlns:a="http://schemas.openxmlformats.org/drawingml/2006/main">
             <a:pPr algn="l">
+              <a:buNone/>
               <a:defRPr sz="1275" b="1">
                 <a:solidFill>
                   <a:srgbClr val="C83C42"/>
@@ -9344,6 +9423,7 @@
           <a:lstStyle xmlns:a="http://schemas.openxmlformats.org/drawingml/2006/main"/>
           <a:p xmlns:a="http://schemas.openxmlformats.org/drawingml/2006/main">
             <a:pPr algn="ctr">
+              <a:buNone/>
               <a:defRPr sz="1650" b="1">
                 <a:solidFill>
                   <a:srgbClr val="17324D"/>
@@ -9469,6 +9549,7 @@
           <a:lstStyle xmlns:a="http://schemas.openxmlformats.org/drawingml/2006/main"/>
           <a:p xmlns:a="http://schemas.openxmlformats.org/drawingml/2006/main">
             <a:pPr algn="l">
+              <a:buNone/>
               <a:defRPr sz="1275" b="1">
                 <a:solidFill>
                   <a:srgbClr val="C83C42"/>
@@ -9526,6 +9607,7 @@
           <a:lstStyle xmlns:a="http://schemas.openxmlformats.org/drawingml/2006/main"/>
           <a:p xmlns:a="http://schemas.openxmlformats.org/drawingml/2006/main">
             <a:pPr algn="ctr">
+              <a:buNone/>
               <a:defRPr sz="1650" b="1">
                 <a:solidFill>
                   <a:srgbClr val="17324D"/>
@@ -9618,6 +9700,7 @@
           <a:lstStyle xmlns:a="http://schemas.openxmlformats.org/drawingml/2006/main"/>
           <a:p xmlns:a="http://schemas.openxmlformats.org/drawingml/2006/main">
             <a:pPr algn="l">
+              <a:buNone/>
               <a:defRPr sz="1125" b="1">
                 <a:solidFill>
                   <a:srgbClr val="C83C42"/>
@@ -9675,6 +9758,7 @@
           <a:lstStyle xmlns:a="http://schemas.openxmlformats.org/drawingml/2006/main"/>
           <a:p xmlns:a="http://schemas.openxmlformats.org/drawingml/2006/main">
             <a:pPr algn="l">
+              <a:buNone/>
               <a:defRPr sz="1575" b="0">
                 <a:solidFill>
                   <a:srgbClr val="17324D"/>
@@ -9761,6 +9845,7 @@
           <a:lstStyle xmlns:a="http://schemas.openxmlformats.org/drawingml/2006/main"/>
           <a:p xmlns:a="http://schemas.openxmlformats.org/drawingml/2006/main">
             <a:pPr algn="l">
+              <a:buNone/>
               <a:defRPr sz="1125" b="1">
                 <a:solidFill>
                   <a:srgbClr val="C83C42"/>
@@ -9818,6 +9903,7 @@
           <a:lstStyle xmlns:a="http://schemas.openxmlformats.org/drawingml/2006/main"/>
           <a:p xmlns:a="http://schemas.openxmlformats.org/drawingml/2006/main">
             <a:pPr algn="l">
+              <a:buNone/>
               <a:defRPr sz="2925" b="1">
                 <a:solidFill>
                   <a:srgbClr val="17324D"/>
@@ -9908,6 +9994,7 @@
           <a:lstStyle xmlns:a="http://schemas.openxmlformats.org/drawingml/2006/main"/>
           <a:p xmlns:a="http://schemas.openxmlformats.org/drawingml/2006/main">
             <a:pPr algn="l">
+              <a:buNone/>
               <a:defRPr sz="975" b="0">
                 <a:solidFill>
                   <a:srgbClr val="506174"/>
@@ -9965,6 +10052,7 @@
           <a:lstStyle xmlns:a="http://schemas.openxmlformats.org/drawingml/2006/main"/>
           <a:p xmlns:a="http://schemas.openxmlformats.org/drawingml/2006/main">
             <a:pPr algn="r">
+              <a:buNone/>
               <a:defRPr sz="1200" b="1">
                 <a:solidFill>
                   <a:srgbClr val="17324D"/>
@@ -10022,6 +10110,7 @@
           <a:lstStyle xmlns:a="http://schemas.openxmlformats.org/drawingml/2006/main"/>
           <a:p xmlns:a="http://schemas.openxmlformats.org/drawingml/2006/main">
             <a:pPr algn="ctr">
+              <a:buNone/>
               <a:defRPr sz="2100" b="1">
                 <a:solidFill>
                   <a:srgbClr val="17324D"/>
@@ -10114,6 +10203,7 @@
           <a:lstStyle xmlns:a="http://schemas.openxmlformats.org/drawingml/2006/main"/>
           <a:p xmlns:a="http://schemas.openxmlformats.org/drawingml/2006/main">
             <a:pPr algn="l">
+              <a:buNone/>
               <a:defRPr sz="1275" b="1">
                 <a:solidFill>
                   <a:srgbClr val="C83C42"/>
@@ -10171,6 +10261,7 @@
           <a:lstStyle xmlns:a="http://schemas.openxmlformats.org/drawingml/2006/main"/>
           <a:p xmlns:a="http://schemas.openxmlformats.org/drawingml/2006/main">
             <a:pPr algn="ctr">
+              <a:buNone/>
               <a:defRPr sz="1650" b="1">
                 <a:solidFill>
                   <a:srgbClr val="17324D"/>
@@ -10296,6 +10387,7 @@
           <a:lstStyle xmlns:a="http://schemas.openxmlformats.org/drawingml/2006/main"/>
           <a:p xmlns:a="http://schemas.openxmlformats.org/drawingml/2006/main">
             <a:pPr algn="l">
+              <a:buNone/>
               <a:defRPr sz="1275" b="1">
                 <a:solidFill>
                   <a:srgbClr val="C83C42"/>
@@ -10353,6 +10445,7 @@
           <a:lstStyle xmlns:a="http://schemas.openxmlformats.org/drawingml/2006/main"/>
           <a:p xmlns:a="http://schemas.openxmlformats.org/drawingml/2006/main">
             <a:pPr algn="ctr">
+              <a:buNone/>
               <a:defRPr sz="1650" b="1">
                 <a:solidFill>
                   <a:srgbClr val="17324D"/>
@@ -10478,6 +10571,7 @@
           <a:lstStyle xmlns:a="http://schemas.openxmlformats.org/drawingml/2006/main"/>
           <a:p xmlns:a="http://schemas.openxmlformats.org/drawingml/2006/main">
             <a:pPr algn="l">
+              <a:buNone/>
               <a:defRPr sz="1275" b="1">
                 <a:solidFill>
                   <a:srgbClr val="C83C42"/>
@@ -10535,6 +10629,7 @@
           <a:lstStyle xmlns:a="http://schemas.openxmlformats.org/drawingml/2006/main"/>
           <a:p xmlns:a="http://schemas.openxmlformats.org/drawingml/2006/main">
             <a:pPr algn="ctr">
+              <a:buNone/>
               <a:defRPr sz="1650" b="1">
                 <a:solidFill>
                   <a:srgbClr val="17324D"/>
@@ -10627,6 +10722,7 @@
           <a:lstStyle xmlns:a="http://schemas.openxmlformats.org/drawingml/2006/main"/>
           <a:p xmlns:a="http://schemas.openxmlformats.org/drawingml/2006/main">
             <a:pPr algn="l">
+              <a:buNone/>
               <a:defRPr sz="1125" b="1">
                 <a:solidFill>
                   <a:srgbClr val="C83C42"/>
@@ -10684,6 +10780,7 @@
           <a:lstStyle xmlns:a="http://schemas.openxmlformats.org/drawingml/2006/main"/>
           <a:p xmlns:a="http://schemas.openxmlformats.org/drawingml/2006/main">
             <a:pPr algn="l">
+              <a:buNone/>
               <a:defRPr sz="1575" b="0">
                 <a:solidFill>
                   <a:srgbClr val="17324D"/>
@@ -10770,6 +10867,7 @@
           <a:lstStyle xmlns:a="http://schemas.openxmlformats.org/drawingml/2006/main"/>
           <a:p xmlns:a="http://schemas.openxmlformats.org/drawingml/2006/main">
             <a:pPr algn="l">
+              <a:buNone/>
               <a:defRPr sz="1125" b="1">
                 <a:solidFill>
                   <a:srgbClr val="C83C42"/>
@@ -10827,6 +10925,7 @@
           <a:lstStyle xmlns:a="http://schemas.openxmlformats.org/drawingml/2006/main"/>
           <a:p xmlns:a="http://schemas.openxmlformats.org/drawingml/2006/main">
             <a:pPr algn="l">
+              <a:buNone/>
               <a:defRPr sz="2925" b="1">
                 <a:solidFill>
                   <a:srgbClr val="17324D"/>
@@ -10917,6 +11016,7 @@
           <a:lstStyle xmlns:a="http://schemas.openxmlformats.org/drawingml/2006/main"/>
           <a:p xmlns:a="http://schemas.openxmlformats.org/drawingml/2006/main">
             <a:pPr algn="l">
+              <a:buNone/>
               <a:defRPr sz="975" b="0">
                 <a:solidFill>
                   <a:srgbClr val="506174"/>
@@ -10974,6 +11074,7 @@
           <a:lstStyle xmlns:a="http://schemas.openxmlformats.org/drawingml/2006/main"/>
           <a:p xmlns:a="http://schemas.openxmlformats.org/drawingml/2006/main">
             <a:pPr algn="r">
+              <a:buNone/>
               <a:defRPr sz="1200" b="1">
                 <a:solidFill>
                   <a:srgbClr val="17324D"/>
@@ -11031,6 +11132,7 @@
           <a:lstStyle xmlns:a="http://schemas.openxmlformats.org/drawingml/2006/main"/>
           <a:p xmlns:a="http://schemas.openxmlformats.org/drawingml/2006/main">
             <a:pPr algn="ctr">
+              <a:buNone/>
               <a:defRPr sz="1875" b="0">
                 <a:solidFill>
                   <a:srgbClr val="506174"/>
@@ -11123,6 +11225,7 @@
           <a:lstStyle xmlns:a="http://schemas.openxmlformats.org/drawingml/2006/main"/>
           <a:p xmlns:a="http://schemas.openxmlformats.org/drawingml/2006/main">
             <a:pPr algn="l">
+              <a:buNone/>
               <a:defRPr sz="1125" b="1">
                 <a:solidFill>
                   <a:srgbClr val="C83C42"/>
@@ -11180,6 +11283,7 @@
           <a:lstStyle xmlns:a="http://schemas.openxmlformats.org/drawingml/2006/main"/>
           <a:p xmlns:a="http://schemas.openxmlformats.org/drawingml/2006/main">
             <a:pPr algn="l">
+              <a:buNone/>
               <a:defRPr sz="1875" b="0">
                 <a:solidFill>
                   <a:srgbClr val="17324D"/>
@@ -11305,6 +11409,7 @@
           <a:lstStyle xmlns:a="http://schemas.openxmlformats.org/drawingml/2006/main"/>
           <a:p xmlns:a="http://schemas.openxmlformats.org/drawingml/2006/main">
             <a:pPr algn="l">
+              <a:buNone/>
               <a:defRPr sz="1125" b="1">
                 <a:solidFill>
                   <a:srgbClr val="17324D"/>
@@ -11362,6 +11467,7 @@
           <a:lstStyle xmlns:a="http://schemas.openxmlformats.org/drawingml/2006/main"/>
           <a:p xmlns:a="http://schemas.openxmlformats.org/drawingml/2006/main">
             <a:pPr algn="l">
+              <a:buNone/>
               <a:defRPr sz="1875" b="1">
                 <a:solidFill>
                   <a:srgbClr val="17324D"/>
@@ -11487,6 +11593,7 @@
           <a:lstStyle xmlns:a="http://schemas.openxmlformats.org/drawingml/2006/main"/>
           <a:p xmlns:a="http://schemas.openxmlformats.org/drawingml/2006/main">
             <a:pPr algn="l">
+              <a:buNone/>
               <a:defRPr sz="1125" b="1">
                 <a:solidFill>
                   <a:srgbClr val="17324D"/>
@@ -11544,6 +11651,7 @@
           <a:lstStyle xmlns:a="http://schemas.openxmlformats.org/drawingml/2006/main"/>
           <a:p xmlns:a="http://schemas.openxmlformats.org/drawingml/2006/main">
             <a:pPr algn="l">
+              <a:buNone/>
               <a:defRPr sz="1875" b="0">
                 <a:solidFill>
                   <a:srgbClr val="17324D"/>
@@ -11601,6 +11709,7 @@
           <a:lstStyle xmlns:a="http://schemas.openxmlformats.org/drawingml/2006/main"/>
           <a:p xmlns:a="http://schemas.openxmlformats.org/drawingml/2006/main">
             <a:pPr algn="ctr">
+              <a:buNone/>
               <a:defRPr sz="1650" b="0">
                 <a:solidFill>
                   <a:srgbClr val="506174"/>
@@ -11687,6 +11796,7 @@
           <a:lstStyle xmlns:a="http://schemas.openxmlformats.org/drawingml/2006/main"/>
           <a:p xmlns:a="http://schemas.openxmlformats.org/drawingml/2006/main">
             <a:pPr algn="l">
+              <a:buNone/>
               <a:defRPr sz="1125" b="1">
                 <a:solidFill>
                   <a:srgbClr val="C83C42"/>
@@ -11744,6 +11854,7 @@
           <a:lstStyle xmlns:a="http://schemas.openxmlformats.org/drawingml/2006/main"/>
           <a:p xmlns:a="http://schemas.openxmlformats.org/drawingml/2006/main">
             <a:pPr algn="l">
+              <a:buNone/>
               <a:defRPr sz="2925" b="1">
                 <a:solidFill>
                   <a:srgbClr val="17324D"/>
@@ -11834,6 +11945,7 @@
           <a:lstStyle xmlns:a="http://schemas.openxmlformats.org/drawingml/2006/main"/>
           <a:p xmlns:a="http://schemas.openxmlformats.org/drawingml/2006/main">
             <a:pPr algn="l">
+              <a:buNone/>
               <a:defRPr sz="975" b="0">
                 <a:solidFill>
                   <a:srgbClr val="506174"/>
@@ -11891,6 +12003,7 @@
           <a:lstStyle xmlns:a="http://schemas.openxmlformats.org/drawingml/2006/main"/>
           <a:p xmlns:a="http://schemas.openxmlformats.org/drawingml/2006/main">
             <a:pPr algn="r">
+              <a:buNone/>
               <a:defRPr sz="1200" b="1">
                 <a:solidFill>
                   <a:srgbClr val="17324D"/>
@@ -11948,6 +12061,7 @@
           <a:lstStyle xmlns:a="http://schemas.openxmlformats.org/drawingml/2006/main"/>
           <a:p xmlns:a="http://schemas.openxmlformats.org/drawingml/2006/main">
             <a:pPr algn="ctr">
+              <a:buNone/>
               <a:defRPr sz="2100" b="1">
                 <a:solidFill>
                   <a:srgbClr val="17324D"/>
@@ -12040,6 +12154,7 @@
           <a:lstStyle xmlns:a="http://schemas.openxmlformats.org/drawingml/2006/main"/>
           <a:p xmlns:a="http://schemas.openxmlformats.org/drawingml/2006/main">
             <a:pPr algn="l">
+              <a:buNone/>
               <a:defRPr sz="1275" b="1">
                 <a:solidFill>
                   <a:srgbClr val="C83C42"/>
@@ -12097,6 +12212,7 @@
           <a:lstStyle xmlns:a="http://schemas.openxmlformats.org/drawingml/2006/main"/>
           <a:p xmlns:a="http://schemas.openxmlformats.org/drawingml/2006/main">
             <a:pPr algn="ctr">
+              <a:buNone/>
               <a:defRPr sz="1650" b="1">
                 <a:solidFill>
                   <a:srgbClr val="17324D"/>
@@ -12222,6 +12338,7 @@
           <a:lstStyle xmlns:a="http://schemas.openxmlformats.org/drawingml/2006/main"/>
           <a:p xmlns:a="http://schemas.openxmlformats.org/drawingml/2006/main">
             <a:pPr algn="l">
+              <a:buNone/>
               <a:defRPr sz="1275" b="1">
                 <a:solidFill>
                   <a:srgbClr val="C83C42"/>
@@ -12279,6 +12396,7 @@
           <a:lstStyle xmlns:a="http://schemas.openxmlformats.org/drawingml/2006/main"/>
           <a:p xmlns:a="http://schemas.openxmlformats.org/drawingml/2006/main">
             <a:pPr algn="ctr">
+              <a:buNone/>
               <a:defRPr sz="1650" b="1">
                 <a:solidFill>
                   <a:srgbClr val="17324D"/>
@@ -12371,6 +12489,7 @@
           <a:lstStyle xmlns:a="http://schemas.openxmlformats.org/drawingml/2006/main"/>
           <a:p xmlns:a="http://schemas.openxmlformats.org/drawingml/2006/main">
             <a:pPr algn="l">
+              <a:buNone/>
               <a:defRPr sz="1125" b="1">
                 <a:solidFill>
                   <a:srgbClr val="C83C42"/>
@@ -12428,6 +12547,7 @@
           <a:lstStyle xmlns:a="http://schemas.openxmlformats.org/drawingml/2006/main"/>
           <a:p xmlns:a="http://schemas.openxmlformats.org/drawingml/2006/main">
             <a:pPr algn="l">
+              <a:buNone/>
               <a:defRPr sz="1575" b="0">
                 <a:solidFill>
                   <a:srgbClr val="17324D"/>
@@ -12514,6 +12634,7 @@
           <a:lstStyle xmlns:a="http://schemas.openxmlformats.org/drawingml/2006/main"/>
           <a:p xmlns:a="http://schemas.openxmlformats.org/drawingml/2006/main">
             <a:pPr algn="l">
+              <a:buNone/>
               <a:defRPr sz="1125" b="1">
                 <a:solidFill>
                   <a:srgbClr val="C83C42"/>
@@ -12571,6 +12692,7 @@
           <a:lstStyle xmlns:a="http://schemas.openxmlformats.org/drawingml/2006/main"/>
           <a:p xmlns:a="http://schemas.openxmlformats.org/drawingml/2006/main">
             <a:pPr algn="l">
+              <a:buNone/>
               <a:defRPr sz="2925" b="1">
                 <a:solidFill>
                   <a:srgbClr val="17324D"/>
@@ -12661,6 +12783,7 @@
           <a:lstStyle xmlns:a="http://schemas.openxmlformats.org/drawingml/2006/main"/>
           <a:p xmlns:a="http://schemas.openxmlformats.org/drawingml/2006/main">
             <a:pPr algn="l">
+              <a:buNone/>
               <a:defRPr sz="975" b="0">
                 <a:solidFill>
                   <a:srgbClr val="506174"/>
@@ -12718,6 +12841,7 @@
           <a:lstStyle xmlns:a="http://schemas.openxmlformats.org/drawingml/2006/main"/>
           <a:p xmlns:a="http://schemas.openxmlformats.org/drawingml/2006/main">
             <a:pPr algn="r">
+              <a:buNone/>
               <a:defRPr sz="1200" b="1">
                 <a:solidFill>
                   <a:srgbClr val="17324D"/>
@@ -12775,6 +12899,7 @@
           <a:lstStyle xmlns:a="http://schemas.openxmlformats.org/drawingml/2006/main"/>
           <a:p xmlns:a="http://schemas.openxmlformats.org/drawingml/2006/main">
             <a:pPr algn="ctr">
+              <a:buNone/>
               <a:defRPr sz="2100" b="1">
                 <a:solidFill>
                   <a:srgbClr val="17324D"/>
@@ -12867,6 +12992,7 @@
           <a:lstStyle xmlns:a="http://schemas.openxmlformats.org/drawingml/2006/main"/>
           <a:p xmlns:a="http://schemas.openxmlformats.org/drawingml/2006/main">
             <a:pPr algn="l">
+              <a:buNone/>
               <a:defRPr sz="1275" b="1">
                 <a:solidFill>
                   <a:srgbClr val="C83C42"/>
@@ -12924,6 +13050,7 @@
           <a:lstStyle xmlns:a="http://schemas.openxmlformats.org/drawingml/2006/main"/>
           <a:p xmlns:a="http://schemas.openxmlformats.org/drawingml/2006/main">
             <a:pPr algn="ctr">
+              <a:buNone/>
               <a:defRPr sz="1650" b="1">
                 <a:solidFill>
                   <a:srgbClr val="17324D"/>
@@ -13049,6 +13176,7 @@
           <a:lstStyle xmlns:a="http://schemas.openxmlformats.org/drawingml/2006/main"/>
           <a:p xmlns:a="http://schemas.openxmlformats.org/drawingml/2006/main">
             <a:pPr algn="l">
+              <a:buNone/>
               <a:defRPr sz="1275" b="1">
                 <a:solidFill>
                   <a:srgbClr val="C83C42"/>
@@ -13106,6 +13234,7 @@
           <a:lstStyle xmlns:a="http://schemas.openxmlformats.org/drawingml/2006/main"/>
           <a:p xmlns:a="http://schemas.openxmlformats.org/drawingml/2006/main">
             <a:pPr algn="ctr">
+              <a:buNone/>
               <a:defRPr sz="1650" b="1">
                 <a:solidFill>
                   <a:srgbClr val="17324D"/>
@@ -13198,6 +13327,7 @@
           <a:lstStyle xmlns:a="http://schemas.openxmlformats.org/drawingml/2006/main"/>
           <a:p xmlns:a="http://schemas.openxmlformats.org/drawingml/2006/main">
             <a:pPr algn="l">
+              <a:buNone/>
               <a:defRPr sz="1125" b="1">
                 <a:solidFill>
                   <a:srgbClr val="C83C42"/>
@@ -13255,6 +13385,7 @@
           <a:lstStyle xmlns:a="http://schemas.openxmlformats.org/drawingml/2006/main"/>
           <a:p xmlns:a="http://schemas.openxmlformats.org/drawingml/2006/main">
             <a:pPr algn="l">
+              <a:buNone/>
               <a:defRPr sz="1575" b="0">
                 <a:solidFill>
                   <a:srgbClr val="17324D"/>
@@ -13341,6 +13472,7 @@
           <a:lstStyle xmlns:a="http://schemas.openxmlformats.org/drawingml/2006/main"/>
           <a:p xmlns:a="http://schemas.openxmlformats.org/drawingml/2006/main">
             <a:pPr algn="l">
+              <a:buNone/>
               <a:defRPr sz="1125" b="1">
                 <a:solidFill>
                   <a:srgbClr val="C83C42"/>
@@ -13398,6 +13530,7 @@
           <a:lstStyle xmlns:a="http://schemas.openxmlformats.org/drawingml/2006/main"/>
           <a:p xmlns:a="http://schemas.openxmlformats.org/drawingml/2006/main">
             <a:pPr algn="l">
+              <a:buNone/>
               <a:defRPr sz="2925" b="1">
                 <a:solidFill>
                   <a:srgbClr val="17324D"/>
@@ -13488,6 +13621,7 @@
           <a:lstStyle xmlns:a="http://schemas.openxmlformats.org/drawingml/2006/main"/>
           <a:p xmlns:a="http://schemas.openxmlformats.org/drawingml/2006/main">
             <a:pPr algn="l">
+              <a:buNone/>
               <a:defRPr sz="975" b="0">
                 <a:solidFill>
                   <a:srgbClr val="506174"/>
@@ -13545,6 +13679,7 @@
           <a:lstStyle xmlns:a="http://schemas.openxmlformats.org/drawingml/2006/main"/>
           <a:p xmlns:a="http://schemas.openxmlformats.org/drawingml/2006/main">
             <a:pPr algn="r">
+              <a:buNone/>
               <a:defRPr sz="1200" b="1">
                 <a:solidFill>
                   <a:srgbClr val="17324D"/>
@@ -13602,6 +13737,7 @@
           <a:lstStyle xmlns:a="http://schemas.openxmlformats.org/drawingml/2006/main"/>
           <a:p xmlns:a="http://schemas.openxmlformats.org/drawingml/2006/main">
             <a:pPr algn="ctr">
+              <a:buNone/>
               <a:defRPr sz="2100" b="1">
                 <a:solidFill>
                   <a:srgbClr val="17324D"/>
@@ -13620,7 +13756,7 @@
                 <a:ea typeface="Tahoma"/>
                 <a:cs typeface="Tahoma"/>
               </a:rPr>
-              <a:t>ผู้เรียนจะสัมผัส connector ทีละตัวและเห็นผลจริงก่อนต่อเป็น workflow เดียว</a:t>
+              <a:t>ผู้เรียนจะเห็นผลของ core connector ทีละตัว และเลือกต่อยอด SharePoint เมื่อห้องพร้อม</a:t>
             </a:r>
           </a:p>
         </p:txBody>
@@ -13694,6 +13830,7 @@
           <a:lstStyle xmlns:a="http://schemas.openxmlformats.org/drawingml/2006/main"/>
           <a:p xmlns:a="http://schemas.openxmlformats.org/drawingml/2006/main">
             <a:pPr algn="l">
+              <a:buNone/>
               <a:defRPr sz="1275" b="1">
                 <a:solidFill>
                   <a:srgbClr val="C83C42"/>
@@ -13751,6 +13888,7 @@
           <a:lstStyle xmlns:a="http://schemas.openxmlformats.org/drawingml/2006/main"/>
           <a:p xmlns:a="http://schemas.openxmlformats.org/drawingml/2006/main">
             <a:pPr algn="ctr">
+              <a:buNone/>
               <a:defRPr sz="1650" b="1">
                 <a:solidFill>
                   <a:srgbClr val="17324D"/>
@@ -13769,7 +13907,7 @@
                 <a:ea typeface="Tahoma"/>
                 <a:cs typeface="Tahoma"/>
               </a:rPr>
-              <a:t>Six connector touchpoints with one checkpoint each</a:t>
+              <a:t>Core connector checkpoints</a:t>
             </a:r>
           </a:p>
         </p:txBody>
@@ -13876,6 +14014,7 @@
           <a:lstStyle xmlns:a="http://schemas.openxmlformats.org/drawingml/2006/main"/>
           <a:p xmlns:a="http://schemas.openxmlformats.org/drawingml/2006/main">
             <a:pPr algn="l">
+              <a:buNone/>
               <a:defRPr sz="1275" b="1">
                 <a:solidFill>
                   <a:srgbClr val="C83C42"/>
@@ -13933,6 +14072,7 @@
           <a:lstStyle xmlns:a="http://schemas.openxmlformats.org/drawingml/2006/main"/>
           <a:p xmlns:a="http://schemas.openxmlformats.org/drawingml/2006/main">
             <a:pPr algn="ctr">
+              <a:buNone/>
               <a:defRPr sz="1650" b="1">
                 <a:solidFill>
                   <a:srgbClr val="17324D"/>
@@ -14025,6 +14165,7 @@
           <a:lstStyle xmlns:a="http://schemas.openxmlformats.org/drawingml/2006/main"/>
           <a:p xmlns:a="http://schemas.openxmlformats.org/drawingml/2006/main">
             <a:pPr algn="l">
+              <a:buNone/>
               <a:defRPr sz="1125" b="1">
                 <a:solidFill>
                   <a:srgbClr val="C83C42"/>
@@ -14082,6 +14223,7 @@
           <a:lstStyle xmlns:a="http://schemas.openxmlformats.org/drawingml/2006/main"/>
           <a:p xmlns:a="http://schemas.openxmlformats.org/drawingml/2006/main">
             <a:pPr algn="l">
+              <a:buNone/>
               <a:defRPr sz="1575" b="0">
                 <a:solidFill>
                   <a:srgbClr val="17324D"/>
@@ -14168,6 +14310,7 @@
           <a:lstStyle xmlns:a="http://schemas.openxmlformats.org/drawingml/2006/main"/>
           <a:p xmlns:a="http://schemas.openxmlformats.org/drawingml/2006/main">
             <a:pPr algn="l">
+              <a:buNone/>
               <a:defRPr sz="1125" b="1">
                 <a:solidFill>
                   <a:srgbClr val="C83C42"/>
@@ -14225,6 +14368,7 @@
           <a:lstStyle xmlns:a="http://schemas.openxmlformats.org/drawingml/2006/main"/>
           <a:p xmlns:a="http://schemas.openxmlformats.org/drawingml/2006/main">
             <a:pPr algn="l">
+              <a:buNone/>
               <a:defRPr sz="2925" b="1">
                 <a:solidFill>
                   <a:srgbClr val="17324D"/>
@@ -14315,6 +14459,7 @@
           <a:lstStyle xmlns:a="http://schemas.openxmlformats.org/drawingml/2006/main"/>
           <a:p xmlns:a="http://schemas.openxmlformats.org/drawingml/2006/main">
             <a:pPr algn="l">
+              <a:buNone/>
               <a:defRPr sz="975" b="0">
                 <a:solidFill>
                   <a:srgbClr val="506174"/>
@@ -14372,6 +14517,7 @@
           <a:lstStyle xmlns:a="http://schemas.openxmlformats.org/drawingml/2006/main"/>
           <a:p xmlns:a="http://schemas.openxmlformats.org/drawingml/2006/main">
             <a:pPr algn="r">
+              <a:buNone/>
               <a:defRPr sz="1200" b="1">
                 <a:solidFill>
                   <a:srgbClr val="17324D"/>
@@ -14429,6 +14575,7 @@
           <a:lstStyle xmlns:a="http://schemas.openxmlformats.org/drawingml/2006/main"/>
           <a:p xmlns:a="http://schemas.openxmlformats.org/drawingml/2006/main">
             <a:pPr algn="ctr">
+              <a:buNone/>
               <a:defRPr sz="2100" b="1">
                 <a:solidFill>
                   <a:srgbClr val="17324D"/>
@@ -14521,6 +14668,7 @@
           <a:lstStyle xmlns:a="http://schemas.openxmlformats.org/drawingml/2006/main"/>
           <a:p xmlns:a="http://schemas.openxmlformats.org/drawingml/2006/main">
             <a:pPr algn="l">
+              <a:buNone/>
               <a:defRPr sz="1275" b="1">
                 <a:solidFill>
                   <a:srgbClr val="C83C42"/>
@@ -14578,6 +14726,7 @@
           <a:lstStyle xmlns:a="http://schemas.openxmlformats.org/drawingml/2006/main"/>
           <a:p xmlns:a="http://schemas.openxmlformats.org/drawingml/2006/main">
             <a:pPr algn="ctr">
+              <a:buNone/>
               <a:defRPr sz="1650" b="1">
                 <a:solidFill>
                   <a:srgbClr val="17324D"/>
@@ -14703,6 +14852,7 @@
           <a:lstStyle xmlns:a="http://schemas.openxmlformats.org/drawingml/2006/main"/>
           <a:p xmlns:a="http://schemas.openxmlformats.org/drawingml/2006/main">
             <a:pPr algn="l">
+              <a:buNone/>
               <a:defRPr sz="1275" b="1">
                 <a:solidFill>
                   <a:srgbClr val="C83C42"/>
@@ -14760,6 +14910,7 @@
           <a:lstStyle xmlns:a="http://schemas.openxmlformats.org/drawingml/2006/main"/>
           <a:p xmlns:a="http://schemas.openxmlformats.org/drawingml/2006/main">
             <a:pPr algn="ctr">
+              <a:buNone/>
               <a:defRPr sz="1650" b="1">
                 <a:solidFill>
                   <a:srgbClr val="17324D"/>
@@ -14852,6 +15003,7 @@
           <a:lstStyle xmlns:a="http://schemas.openxmlformats.org/drawingml/2006/main"/>
           <a:p xmlns:a="http://schemas.openxmlformats.org/drawingml/2006/main">
             <a:pPr algn="l">
+              <a:buNone/>
               <a:defRPr sz="1125" b="1">
                 <a:solidFill>
                   <a:srgbClr val="C83C42"/>
@@ -14909,6 +15061,7 @@
           <a:lstStyle xmlns:a="http://schemas.openxmlformats.org/drawingml/2006/main"/>
           <a:p xmlns:a="http://schemas.openxmlformats.org/drawingml/2006/main">
             <a:pPr algn="l">
+              <a:buNone/>
               <a:defRPr sz="1575" b="0">
                 <a:solidFill>
                   <a:srgbClr val="17324D"/>
@@ -14995,6 +15148,7 @@
           <a:lstStyle xmlns:a="http://schemas.openxmlformats.org/drawingml/2006/main"/>
           <a:p xmlns:a="http://schemas.openxmlformats.org/drawingml/2006/main">
             <a:pPr algn="l">
+              <a:buNone/>
               <a:defRPr sz="1125" b="1">
                 <a:solidFill>
                   <a:srgbClr val="C83C42"/>
@@ -15052,6 +15206,7 @@
           <a:lstStyle xmlns:a="http://schemas.openxmlformats.org/drawingml/2006/main"/>
           <a:p xmlns:a="http://schemas.openxmlformats.org/drawingml/2006/main">
             <a:pPr algn="l">
+              <a:buNone/>
               <a:defRPr sz="2925" b="1">
                 <a:solidFill>
                   <a:srgbClr val="17324D"/>
@@ -15142,6 +15297,7 @@
           <a:lstStyle xmlns:a="http://schemas.openxmlformats.org/drawingml/2006/main"/>
           <a:p xmlns:a="http://schemas.openxmlformats.org/drawingml/2006/main">
             <a:pPr algn="l">
+              <a:buNone/>
               <a:defRPr sz="975" b="0">
                 <a:solidFill>
                   <a:srgbClr val="506174"/>
@@ -15199,6 +15355,7 @@
           <a:lstStyle xmlns:a="http://schemas.openxmlformats.org/drawingml/2006/main"/>
           <a:p xmlns:a="http://schemas.openxmlformats.org/drawingml/2006/main">
             <a:pPr algn="r">
+              <a:buNone/>
               <a:defRPr sz="1200" b="1">
                 <a:solidFill>
                   <a:srgbClr val="17324D"/>
@@ -15256,6 +15413,7 @@
           <a:lstStyle xmlns:a="http://schemas.openxmlformats.org/drawingml/2006/main"/>
           <a:p xmlns:a="http://schemas.openxmlformats.org/drawingml/2006/main">
             <a:pPr algn="l">
+              <a:buNone/>
               <a:defRPr sz="2100" b="1">
                 <a:solidFill>
                   <a:srgbClr val="17324D"/>
@@ -15313,6 +15471,7 @@
           <a:lstStyle xmlns:a="http://schemas.openxmlformats.org/drawingml/2006/main"/>
           <a:p xmlns:a="http://schemas.openxmlformats.org/drawingml/2006/main">
             <a:pPr algn="l">
+              <a:buNone/>
               <a:defRPr sz="1650" b="0">
                 <a:solidFill>
                   <a:srgbClr val="506174"/>
@@ -15405,6 +15564,7 @@
           <a:lstStyle xmlns:a="http://schemas.openxmlformats.org/drawingml/2006/main"/>
           <a:p xmlns:a="http://schemas.openxmlformats.org/drawingml/2006/main">
             <a:pPr algn="l">
+              <a:buNone/>
               <a:defRPr sz="1425" b="0">
                 <a:solidFill>
                   <a:srgbClr val="C83C42"/>
@@ -15430,14 +15590,14 @@
       </p:sp>
       <p:pic>
         <p:nvPicPr>
-          <p:cNvPr id="20" name=""/>
+          <p:cNvPr id="22" name=""/>
           <p:cNvPicPr>
             <a:picLocks xmlns:a="http://schemas.openxmlformats.org/drawingml/2006/main" noChangeAspect="1"/>
           </p:cNvPicPr>
           <p:nvPr/>
         </p:nvPicPr>
         <p:blipFill>
-          <a:blip xmlns:r="http://schemas.openxmlformats.org/officeDocument/2006/relationships" xmlns:a="http://schemas.openxmlformats.org/drawingml/2006/main" r:embed="R62cdfb2f92dc4e04"/>
+          <a:blip xmlns:r="http://schemas.openxmlformats.org/officeDocument/2006/relationships" xmlns:a="http://schemas.openxmlformats.org/drawingml/2006/main" r:embed="Rc96bab5b6aa240d9"/>
           <a:srcRect xmlns:a="http://schemas.openxmlformats.org/drawingml/2006/main" l="16727" t="0" r="16727" b="0"/>
           <a:stretch xmlns:a="http://schemas.openxmlformats.org/drawingml/2006/main">
             <a:fillRect l="0" t="0" r="0" b="0"/>
@@ -15518,6 +15678,7 @@
           <a:lstStyle xmlns:a="http://schemas.openxmlformats.org/drawingml/2006/main"/>
           <a:p xmlns:a="http://schemas.openxmlformats.org/drawingml/2006/main">
             <a:pPr algn="l">
+              <a:buNone/>
               <a:defRPr sz="1125" b="1">
                 <a:solidFill>
                   <a:srgbClr val="C83C42"/>
@@ -15575,6 +15736,7 @@
           <a:lstStyle xmlns:a="http://schemas.openxmlformats.org/drawingml/2006/main"/>
           <a:p xmlns:a="http://schemas.openxmlformats.org/drawingml/2006/main">
             <a:pPr algn="l">
+              <a:buNone/>
               <a:defRPr sz="2925" b="1">
                 <a:solidFill>
                   <a:srgbClr val="17324D"/>
@@ -15665,6 +15827,7 @@
           <a:lstStyle xmlns:a="http://schemas.openxmlformats.org/drawingml/2006/main"/>
           <a:p xmlns:a="http://schemas.openxmlformats.org/drawingml/2006/main">
             <a:pPr algn="l">
+              <a:buNone/>
               <a:defRPr sz="975" b="0">
                 <a:solidFill>
                   <a:srgbClr val="506174"/>
@@ -15722,6 +15885,7 @@
           <a:lstStyle xmlns:a="http://schemas.openxmlformats.org/drawingml/2006/main"/>
           <a:p xmlns:a="http://schemas.openxmlformats.org/drawingml/2006/main">
             <a:pPr algn="r">
+              <a:buNone/>
               <a:defRPr sz="1200" b="1">
                 <a:solidFill>
                   <a:srgbClr val="17324D"/>
@@ -15779,6 +15943,7 @@
           <a:lstStyle xmlns:a="http://schemas.openxmlformats.org/drawingml/2006/main"/>
           <a:p xmlns:a="http://schemas.openxmlformats.org/drawingml/2006/main">
             <a:pPr algn="ctr">
+              <a:buNone/>
               <a:defRPr sz="2100" b="1">
                 <a:solidFill>
                   <a:srgbClr val="17324D"/>
@@ -15871,6 +16036,7 @@
           <a:lstStyle xmlns:a="http://schemas.openxmlformats.org/drawingml/2006/main"/>
           <a:p xmlns:a="http://schemas.openxmlformats.org/drawingml/2006/main">
             <a:pPr algn="l">
+              <a:buNone/>
               <a:defRPr sz="1275" b="1">
                 <a:solidFill>
                   <a:srgbClr val="C83C42"/>
@@ -15928,6 +16094,7 @@
           <a:lstStyle xmlns:a="http://schemas.openxmlformats.org/drawingml/2006/main"/>
           <a:p xmlns:a="http://schemas.openxmlformats.org/drawingml/2006/main">
             <a:pPr algn="ctr">
+              <a:buNone/>
               <a:defRPr sz="1650" b="1">
                 <a:solidFill>
                   <a:srgbClr val="17324D"/>
@@ -16053,6 +16220,7 @@
           <a:lstStyle xmlns:a="http://schemas.openxmlformats.org/drawingml/2006/main"/>
           <a:p xmlns:a="http://schemas.openxmlformats.org/drawingml/2006/main">
             <a:pPr algn="l">
+              <a:buNone/>
               <a:defRPr sz="1275" b="1">
                 <a:solidFill>
                   <a:srgbClr val="C83C42"/>
@@ -16110,6 +16278,7 @@
           <a:lstStyle xmlns:a="http://schemas.openxmlformats.org/drawingml/2006/main"/>
           <a:p xmlns:a="http://schemas.openxmlformats.org/drawingml/2006/main">
             <a:pPr algn="ctr">
+              <a:buNone/>
               <a:defRPr sz="1650" b="1">
                 <a:solidFill>
                   <a:srgbClr val="17324D"/>
@@ -16202,6 +16371,7 @@
           <a:lstStyle xmlns:a="http://schemas.openxmlformats.org/drawingml/2006/main"/>
           <a:p xmlns:a="http://schemas.openxmlformats.org/drawingml/2006/main">
             <a:pPr algn="l">
+              <a:buNone/>
               <a:defRPr sz="1125" b="1">
                 <a:solidFill>
                   <a:srgbClr val="C83C42"/>
@@ -16259,6 +16429,7 @@
           <a:lstStyle xmlns:a="http://schemas.openxmlformats.org/drawingml/2006/main"/>
           <a:p xmlns:a="http://schemas.openxmlformats.org/drawingml/2006/main">
             <a:pPr algn="l">
+              <a:buNone/>
               <a:defRPr sz="1575" b="0">
                 <a:solidFill>
                   <a:srgbClr val="17324D"/>
@@ -16345,6 +16516,7 @@
           <a:lstStyle xmlns:a="http://schemas.openxmlformats.org/drawingml/2006/main"/>
           <a:p xmlns:a="http://schemas.openxmlformats.org/drawingml/2006/main">
             <a:pPr algn="l">
+              <a:buNone/>
               <a:defRPr sz="1125" b="1">
                 <a:solidFill>
                   <a:srgbClr val="C83C42"/>
@@ -16402,6 +16574,7 @@
           <a:lstStyle xmlns:a="http://schemas.openxmlformats.org/drawingml/2006/main"/>
           <a:p xmlns:a="http://schemas.openxmlformats.org/drawingml/2006/main">
             <a:pPr algn="l">
+              <a:buNone/>
               <a:defRPr sz="2925" b="1">
                 <a:solidFill>
                   <a:srgbClr val="17324D"/>
@@ -16492,6 +16665,7 @@
           <a:lstStyle xmlns:a="http://schemas.openxmlformats.org/drawingml/2006/main"/>
           <a:p xmlns:a="http://schemas.openxmlformats.org/drawingml/2006/main">
             <a:pPr algn="l">
+              <a:buNone/>
               <a:defRPr sz="975" b="0">
                 <a:solidFill>
                   <a:srgbClr val="506174"/>
@@ -16549,6 +16723,7 @@
           <a:lstStyle xmlns:a="http://schemas.openxmlformats.org/drawingml/2006/main"/>
           <a:p xmlns:a="http://schemas.openxmlformats.org/drawingml/2006/main">
             <a:pPr algn="r">
+              <a:buNone/>
               <a:defRPr sz="1200" b="1">
                 <a:solidFill>
                   <a:srgbClr val="17324D"/>
@@ -16606,6 +16781,7 @@
           <a:lstStyle xmlns:a="http://schemas.openxmlformats.org/drawingml/2006/main"/>
           <a:p xmlns:a="http://schemas.openxmlformats.org/drawingml/2006/main">
             <a:pPr algn="ctr">
+              <a:buNone/>
               <a:defRPr sz="2100" b="1">
                 <a:solidFill>
                   <a:srgbClr val="17324D"/>
@@ -16698,6 +16874,7 @@
           <a:lstStyle xmlns:a="http://schemas.openxmlformats.org/drawingml/2006/main"/>
           <a:p xmlns:a="http://schemas.openxmlformats.org/drawingml/2006/main">
             <a:pPr algn="l">
+              <a:buNone/>
               <a:defRPr sz="1275" b="1">
                 <a:solidFill>
                   <a:srgbClr val="C83C42"/>
@@ -16755,6 +16932,7 @@
           <a:lstStyle xmlns:a="http://schemas.openxmlformats.org/drawingml/2006/main"/>
           <a:p xmlns:a="http://schemas.openxmlformats.org/drawingml/2006/main">
             <a:pPr algn="ctr">
+              <a:buNone/>
               <a:defRPr sz="1650" b="1">
                 <a:solidFill>
                   <a:srgbClr val="17324D"/>
@@ -16880,6 +17058,7 @@
           <a:lstStyle xmlns:a="http://schemas.openxmlformats.org/drawingml/2006/main"/>
           <a:p xmlns:a="http://schemas.openxmlformats.org/drawingml/2006/main">
             <a:pPr algn="l">
+              <a:buNone/>
               <a:defRPr sz="1275" b="1">
                 <a:solidFill>
                   <a:srgbClr val="C83C42"/>
@@ -16937,6 +17116,7 @@
           <a:lstStyle xmlns:a="http://schemas.openxmlformats.org/drawingml/2006/main"/>
           <a:p xmlns:a="http://schemas.openxmlformats.org/drawingml/2006/main">
             <a:pPr algn="ctr">
+              <a:buNone/>
               <a:defRPr sz="1650" b="1">
                 <a:solidFill>
                   <a:srgbClr val="17324D"/>
@@ -17029,6 +17209,7 @@
           <a:lstStyle xmlns:a="http://schemas.openxmlformats.org/drawingml/2006/main"/>
           <a:p xmlns:a="http://schemas.openxmlformats.org/drawingml/2006/main">
             <a:pPr algn="l">
+              <a:buNone/>
               <a:defRPr sz="1125" b="1">
                 <a:solidFill>
                   <a:srgbClr val="C83C42"/>
@@ -17086,6 +17267,7 @@
           <a:lstStyle xmlns:a="http://schemas.openxmlformats.org/drawingml/2006/main"/>
           <a:p xmlns:a="http://schemas.openxmlformats.org/drawingml/2006/main">
             <a:pPr algn="l">
+              <a:buNone/>
               <a:defRPr sz="1575" b="0">
                 <a:solidFill>
                   <a:srgbClr val="17324D"/>
@@ -17172,6 +17354,7 @@
           <a:lstStyle xmlns:a="http://schemas.openxmlformats.org/drawingml/2006/main"/>
           <a:p xmlns:a="http://schemas.openxmlformats.org/drawingml/2006/main">
             <a:pPr algn="l">
+              <a:buNone/>
               <a:defRPr sz="1125" b="1">
                 <a:solidFill>
                   <a:srgbClr val="C83C42"/>
@@ -17229,6 +17412,7 @@
           <a:lstStyle xmlns:a="http://schemas.openxmlformats.org/drawingml/2006/main"/>
           <a:p xmlns:a="http://schemas.openxmlformats.org/drawingml/2006/main">
             <a:pPr algn="l">
+              <a:buNone/>
               <a:defRPr sz="2925" b="1">
                 <a:solidFill>
                   <a:srgbClr val="17324D"/>
@@ -17319,6 +17503,7 @@
           <a:lstStyle xmlns:a="http://schemas.openxmlformats.org/drawingml/2006/main"/>
           <a:p xmlns:a="http://schemas.openxmlformats.org/drawingml/2006/main">
             <a:pPr algn="l">
+              <a:buNone/>
               <a:defRPr sz="975" b="0">
                 <a:solidFill>
                   <a:srgbClr val="506174"/>
@@ -17376,6 +17561,7 @@
           <a:lstStyle xmlns:a="http://schemas.openxmlformats.org/drawingml/2006/main"/>
           <a:p xmlns:a="http://schemas.openxmlformats.org/drawingml/2006/main">
             <a:pPr algn="r">
+              <a:buNone/>
               <a:defRPr sz="1200" b="1">
                 <a:solidFill>
                   <a:srgbClr val="17324D"/>
@@ -17433,6 +17619,7 @@
           <a:lstStyle xmlns:a="http://schemas.openxmlformats.org/drawingml/2006/main"/>
           <a:p xmlns:a="http://schemas.openxmlformats.org/drawingml/2006/main">
             <a:pPr algn="ctr">
+              <a:buNone/>
               <a:defRPr sz="1875" b="0">
                 <a:solidFill>
                   <a:srgbClr val="506174"/>
@@ -17525,6 +17712,7 @@
           <a:lstStyle xmlns:a="http://schemas.openxmlformats.org/drawingml/2006/main"/>
           <a:p xmlns:a="http://schemas.openxmlformats.org/drawingml/2006/main">
             <a:pPr algn="l">
+              <a:buNone/>
               <a:defRPr sz="1125" b="1">
                 <a:solidFill>
                   <a:srgbClr val="C83C42"/>
@@ -17582,6 +17770,7 @@
           <a:lstStyle xmlns:a="http://schemas.openxmlformats.org/drawingml/2006/main"/>
           <a:p xmlns:a="http://schemas.openxmlformats.org/drawingml/2006/main">
             <a:pPr algn="l">
+              <a:buNone/>
               <a:defRPr sz="1875" b="0">
                 <a:solidFill>
                   <a:srgbClr val="17324D"/>
@@ -17707,6 +17896,7 @@
           <a:lstStyle xmlns:a="http://schemas.openxmlformats.org/drawingml/2006/main"/>
           <a:p xmlns:a="http://schemas.openxmlformats.org/drawingml/2006/main">
             <a:pPr algn="l">
+              <a:buNone/>
               <a:defRPr sz="1125" b="1">
                 <a:solidFill>
                   <a:srgbClr val="17324D"/>
@@ -17764,6 +17954,7 @@
           <a:lstStyle xmlns:a="http://schemas.openxmlformats.org/drawingml/2006/main"/>
           <a:p xmlns:a="http://schemas.openxmlformats.org/drawingml/2006/main">
             <a:pPr algn="l">
+              <a:buNone/>
               <a:defRPr sz="1875" b="1">
                 <a:solidFill>
                   <a:srgbClr val="17324D"/>
@@ -17889,6 +18080,7 @@
           <a:lstStyle xmlns:a="http://schemas.openxmlformats.org/drawingml/2006/main"/>
           <a:p xmlns:a="http://schemas.openxmlformats.org/drawingml/2006/main">
             <a:pPr algn="l">
+              <a:buNone/>
               <a:defRPr sz="1125" b="1">
                 <a:solidFill>
                   <a:srgbClr val="17324D"/>
@@ -17946,6 +18138,7 @@
           <a:lstStyle xmlns:a="http://schemas.openxmlformats.org/drawingml/2006/main"/>
           <a:p xmlns:a="http://schemas.openxmlformats.org/drawingml/2006/main">
             <a:pPr algn="l">
+              <a:buNone/>
               <a:defRPr sz="1875" b="0">
                 <a:solidFill>
                   <a:srgbClr val="17324D"/>
@@ -18003,6 +18196,7 @@
           <a:lstStyle xmlns:a="http://schemas.openxmlformats.org/drawingml/2006/main"/>
           <a:p xmlns:a="http://schemas.openxmlformats.org/drawingml/2006/main">
             <a:pPr algn="ctr">
+              <a:buNone/>
               <a:defRPr sz="1650" b="0">
                 <a:solidFill>
                   <a:srgbClr val="506174"/>
@@ -18089,6 +18283,7 @@
           <a:lstStyle xmlns:a="http://schemas.openxmlformats.org/drawingml/2006/main"/>
           <a:p xmlns:a="http://schemas.openxmlformats.org/drawingml/2006/main">
             <a:pPr algn="l">
+              <a:buNone/>
               <a:defRPr sz="1125" b="1">
                 <a:solidFill>
                   <a:srgbClr val="C83C42"/>
@@ -18146,6 +18341,7 @@
           <a:lstStyle xmlns:a="http://schemas.openxmlformats.org/drawingml/2006/main"/>
           <a:p xmlns:a="http://schemas.openxmlformats.org/drawingml/2006/main">
             <a:pPr algn="l">
+              <a:buNone/>
               <a:defRPr sz="2925" b="1">
                 <a:solidFill>
                   <a:srgbClr val="17324D"/>
@@ -18236,6 +18432,7 @@
           <a:lstStyle xmlns:a="http://schemas.openxmlformats.org/drawingml/2006/main"/>
           <a:p xmlns:a="http://schemas.openxmlformats.org/drawingml/2006/main">
             <a:pPr algn="l">
+              <a:buNone/>
               <a:defRPr sz="975" b="0">
                 <a:solidFill>
                   <a:srgbClr val="506174"/>
@@ -18293,6 +18490,7 @@
           <a:lstStyle xmlns:a="http://schemas.openxmlformats.org/drawingml/2006/main"/>
           <a:p xmlns:a="http://schemas.openxmlformats.org/drawingml/2006/main">
             <a:pPr algn="r">
+              <a:buNone/>
               <a:defRPr sz="1200" b="1">
                 <a:solidFill>
                   <a:srgbClr val="17324D"/>
@@ -18350,6 +18548,7 @@
           <a:lstStyle xmlns:a="http://schemas.openxmlformats.org/drawingml/2006/main"/>
           <a:p xmlns:a="http://schemas.openxmlformats.org/drawingml/2006/main">
             <a:pPr algn="ctr">
+              <a:buNone/>
               <a:defRPr sz="2100" b="1">
                 <a:solidFill>
                   <a:srgbClr val="17324D"/>
@@ -18442,6 +18641,7 @@
           <a:lstStyle xmlns:a="http://schemas.openxmlformats.org/drawingml/2006/main"/>
           <a:p xmlns:a="http://schemas.openxmlformats.org/drawingml/2006/main">
             <a:pPr algn="l">
+              <a:buNone/>
               <a:defRPr sz="1275" b="1">
                 <a:solidFill>
                   <a:srgbClr val="C83C42"/>
@@ -18499,6 +18699,7 @@
           <a:lstStyle xmlns:a="http://schemas.openxmlformats.org/drawingml/2006/main"/>
           <a:p xmlns:a="http://schemas.openxmlformats.org/drawingml/2006/main">
             <a:pPr algn="ctr">
+              <a:buNone/>
               <a:defRPr sz="1650" b="1">
                 <a:solidFill>
                   <a:srgbClr val="17324D"/>
@@ -18624,6 +18825,7 @@
           <a:lstStyle xmlns:a="http://schemas.openxmlformats.org/drawingml/2006/main"/>
           <a:p xmlns:a="http://schemas.openxmlformats.org/drawingml/2006/main">
             <a:pPr algn="l">
+              <a:buNone/>
               <a:defRPr sz="1275" b="1">
                 <a:solidFill>
                   <a:srgbClr val="C83C42"/>
@@ -18681,6 +18883,7 @@
           <a:lstStyle xmlns:a="http://schemas.openxmlformats.org/drawingml/2006/main"/>
           <a:p xmlns:a="http://schemas.openxmlformats.org/drawingml/2006/main">
             <a:pPr algn="ctr">
+              <a:buNone/>
               <a:defRPr sz="1650" b="1">
                 <a:solidFill>
                   <a:srgbClr val="17324D"/>
@@ -18773,6 +18976,7 @@
           <a:lstStyle xmlns:a="http://schemas.openxmlformats.org/drawingml/2006/main"/>
           <a:p xmlns:a="http://schemas.openxmlformats.org/drawingml/2006/main">
             <a:pPr algn="l">
+              <a:buNone/>
               <a:defRPr sz="1125" b="1">
                 <a:solidFill>
                   <a:srgbClr val="C83C42"/>
@@ -18830,6 +19034,7 @@
           <a:lstStyle xmlns:a="http://schemas.openxmlformats.org/drawingml/2006/main"/>
           <a:p xmlns:a="http://schemas.openxmlformats.org/drawingml/2006/main">
             <a:pPr algn="l">
+              <a:buNone/>
               <a:defRPr sz="1575" b="0">
                 <a:solidFill>
                   <a:srgbClr val="17324D"/>
@@ -18916,6 +19121,7 @@
           <a:lstStyle xmlns:a="http://schemas.openxmlformats.org/drawingml/2006/main"/>
           <a:p xmlns:a="http://schemas.openxmlformats.org/drawingml/2006/main">
             <a:pPr algn="l">
+              <a:buNone/>
               <a:defRPr sz="1125" b="1">
                 <a:solidFill>
                   <a:srgbClr val="C83C42"/>
@@ -18934,7 +19140,7 @@
                 <a:ea typeface="Tahoma"/>
                 <a:cs typeface="Tahoma"/>
               </a:rPr>
-              <a:t>DAY 1  ·  POWER AUTOMATE  /  SHAREPOINT</a:t>
+              <a:t>DAY 1  ·  POWER AUTOMATE  /  INSTRUCTOR-SELECTED</a:t>
             </a:r>
           </a:p>
         </p:txBody>
@@ -18973,6 +19179,7 @@
           <a:lstStyle xmlns:a="http://schemas.openxmlformats.org/drawingml/2006/main"/>
           <a:p xmlns:a="http://schemas.openxmlformats.org/drawingml/2006/main">
             <a:pPr algn="l">
+              <a:buNone/>
               <a:defRPr sz="2925" b="1">
                 <a:solidFill>
                   <a:srgbClr val="17324D"/>
@@ -18991,7 +19198,7 @@
                 <a:ea typeface="Tahoma"/>
                 <a:cs typeface="Tahoma"/>
               </a:rPr>
-              <a:t>SharePoint as the filing cabinet</a:t>
+              <a:t>Choose the 13:30 route</a:t>
             </a:r>
           </a:p>
         </p:txBody>
@@ -19063,6 +19270,7 @@
           <a:lstStyle xmlns:a="http://schemas.openxmlformats.org/drawingml/2006/main"/>
           <a:p xmlns:a="http://schemas.openxmlformats.org/drawingml/2006/main">
             <a:pPr algn="l">
+              <a:buNone/>
               <a:defRPr sz="975" b="0">
                 <a:solidFill>
                   <a:srgbClr val="506174"/>
@@ -19120,6 +19328,7 @@
           <a:lstStyle xmlns:a="http://schemas.openxmlformats.org/drawingml/2006/main"/>
           <a:p xmlns:a="http://schemas.openxmlformats.org/drawingml/2006/main">
             <a:pPr algn="r">
+              <a:buNone/>
               <a:defRPr sz="1200" b="1">
                 <a:solidFill>
                   <a:srgbClr val="17324D"/>
@@ -19177,6 +19386,7 @@
           <a:lstStyle xmlns:a="http://schemas.openxmlformats.org/drawingml/2006/main"/>
           <a:p xmlns:a="http://schemas.openxmlformats.org/drawingml/2006/main">
             <a:pPr algn="ctr">
+              <a:buNone/>
               <a:defRPr sz="1875" b="0">
                 <a:solidFill>
                   <a:srgbClr val="506174"/>
@@ -19195,7 +19405,7 @@
                 <a:ea typeface="Tahoma"/>
                 <a:cs typeface="Tahoma"/>
               </a:rPr>
-              <a:t>Excel ติดตามสถานะ ส่วน SharePoint document library เก็บไฟล์สรุปของ Approved</a:t>
+              <a:t>วิทยากรเลือก Approval reinforcement หรือ SharePoint extension เพียงหนึ่งเส้นทาง</a:t>
             </a:r>
           </a:p>
         </p:txBody>
@@ -19269,6 +19479,7 @@
           <a:lstStyle xmlns:a="http://schemas.openxmlformats.org/drawingml/2006/main"/>
           <a:p xmlns:a="http://schemas.openxmlformats.org/drawingml/2006/main">
             <a:pPr algn="l">
+              <a:buNone/>
               <a:defRPr sz="1125" b="1">
                 <a:solidFill>
                   <a:srgbClr val="C83C42"/>
@@ -19287,7 +19498,7 @@
                 <a:ea typeface="Tahoma"/>
                 <a:cs typeface="Tahoma"/>
               </a:rPr>
-              <a:t>ร้านสะดวกซื้อ</a:t>
+              <a:t>OPTION A</a:t>
             </a:r>
           </a:p>
         </p:txBody>
@@ -19326,6 +19537,7 @@
           <a:lstStyle xmlns:a="http://schemas.openxmlformats.org/drawingml/2006/main"/>
           <a:p xmlns:a="http://schemas.openxmlformats.org/drawingml/2006/main">
             <a:pPr algn="l">
+              <a:buNone/>
               <a:defRPr sz="1875" b="0">
                 <a:solidFill>
                   <a:srgbClr val="17324D"/>
@@ -19344,7 +19556,7 @@
                 <a:ea typeface="Tahoma"/>
                 <a:cs typeface="Tahoma"/>
               </a:rPr>
-              <a:t>ตู้เอกสารสำหรับเรื่องที่อนุมัติแล้ว</a:t>
+              <a:t>Approval reinforcement</a:t>
             </a:r>
           </a:p>
         </p:txBody>
@@ -19451,6 +19663,7 @@
           <a:lstStyle xmlns:a="http://schemas.openxmlformats.org/drawingml/2006/main"/>
           <a:p xmlns:a="http://schemas.openxmlformats.org/drawingml/2006/main">
             <a:pPr algn="l">
+              <a:buNone/>
               <a:defRPr sz="1125" b="1">
                 <a:solidFill>
                   <a:srgbClr val="17324D"/>
@@ -19469,7 +19682,7 @@
                 <a:ea typeface="Tahoma"/>
                 <a:cs typeface="Tahoma"/>
               </a:rPr>
-              <a:t>OFFICIAL TERM</a:t>
+              <a:t>CHOOSE ONE</a:t>
             </a:r>
           </a:p>
         </p:txBody>
@@ -19508,6 +19721,7 @@
           <a:lstStyle xmlns:a="http://schemas.openxmlformats.org/drawingml/2006/main"/>
           <a:p xmlns:a="http://schemas.openxmlformats.org/drawingml/2006/main">
             <a:pPr algn="l">
+              <a:buNone/>
               <a:defRPr sz="1875" b="1">
                 <a:solidFill>
                   <a:srgbClr val="17324D"/>
@@ -19526,7 +19740,7 @@
                 <a:ea typeface="Tahoma"/>
                 <a:cs typeface="Tahoma"/>
               </a:rPr>
-              <a:t>SharePoint document library</a:t>
+              <a:t>OR</a:t>
             </a:r>
           </a:p>
         </p:txBody>
@@ -19633,6 +19847,7 @@
           <a:lstStyle xmlns:a="http://schemas.openxmlformats.org/drawingml/2006/main"/>
           <a:p xmlns:a="http://schemas.openxmlformats.org/drawingml/2006/main">
             <a:pPr algn="l">
+              <a:buNone/>
               <a:defRPr sz="1125" b="1">
                 <a:solidFill>
                   <a:srgbClr val="17324D"/>
@@ -19651,7 +19866,7 @@
                 <a:ea typeface="Tahoma"/>
                 <a:cs typeface="Tahoma"/>
               </a:rPr>
-              <a:t>CHECKPOINT</a:t>
+              <a:t>OPTION B</a:t>
             </a:r>
           </a:p>
         </p:txBody>
@@ -19690,6 +19905,7 @@
           <a:lstStyle xmlns:a="http://schemas.openxmlformats.org/drawingml/2006/main"/>
           <a:p xmlns:a="http://schemas.openxmlformats.org/drawingml/2006/main">
             <a:pPr algn="l">
+              <a:buNone/>
               <a:defRPr sz="1875" b="0">
                 <a:solidFill>
                   <a:srgbClr val="17324D"/>
@@ -19708,7 +19924,7 @@
                 <a:ea typeface="Tahoma"/>
                 <a:cs typeface="Tahoma"/>
               </a:rPr>
-              <a:t>เฉพาะ Approved สร้าง text file หนึ่งไฟล์</a:t>
+              <a:t>SharePoint extension</a:t>
             </a:r>
           </a:p>
         </p:txBody>
@@ -19747,6 +19963,7 @@
           <a:lstStyle xmlns:a="http://schemas.openxmlformats.org/drawingml/2006/main"/>
           <a:p xmlns:a="http://schemas.openxmlformats.org/drawingml/2006/main">
             <a:pPr algn="ctr">
+              <a:buNone/>
               <a:defRPr sz="1650" b="0">
                 <a:solidFill>
                   <a:srgbClr val="506174"/>
@@ -19765,7 +19982,7 @@
                 <a:ea typeface="Tahoma"/>
                 <a:cs typeface="Tahoma"/>
               </a:rPr>
-              <a:t>ใช้ภาพเปรียบเทียบเพื่อจำหลักการ แล้วกลับไปตรวจผลจริงใน Exercise</a:t>
+              <a:t>ทั้งสองเส้นทางกลับมาเริ่ม Teams ที่ Slide 29</a:t>
             </a:r>
           </a:p>
         </p:txBody>
@@ -19833,6 +20050,7 @@
           <a:lstStyle xmlns:a="http://schemas.openxmlformats.org/drawingml/2006/main"/>
           <a:p xmlns:a="http://schemas.openxmlformats.org/drawingml/2006/main">
             <a:pPr algn="l">
+              <a:buNone/>
               <a:defRPr sz="1125" b="1">
                 <a:solidFill>
                   <a:srgbClr val="C83C42"/>
@@ -19851,7 +20069,7 @@
                 <a:ea typeface="Tahoma"/>
                 <a:cs typeface="Tahoma"/>
               </a:rPr>
-              <a:t>DAY 1  ·  POWER AUTOMATE  /  SHAREPOINT</a:t>
+              <a:t>DAY 1  ·  POWER AUTOMATE  /  INSTRUCTOR-SELECTED</a:t>
             </a:r>
           </a:p>
         </p:txBody>
@@ -19890,6 +20108,7 @@
           <a:lstStyle xmlns:a="http://schemas.openxmlformats.org/drawingml/2006/main"/>
           <a:p xmlns:a="http://schemas.openxmlformats.org/drawingml/2006/main">
             <a:pPr algn="l">
+              <a:buNone/>
               <a:defRPr sz="2925" b="1">
                 <a:solidFill>
                   <a:srgbClr val="17324D"/>
@@ -19908,7 +20127,7 @@
                 <a:ea typeface="Tahoma"/>
                 <a:cs typeface="Tahoma"/>
               </a:rPr>
-              <a:t>Create one text file</a:t>
+              <a:t>SharePoint readiness routes</a:t>
             </a:r>
           </a:p>
         </p:txBody>
@@ -19980,6 +20199,7 @@
           <a:lstStyle xmlns:a="http://schemas.openxmlformats.org/drawingml/2006/main"/>
           <a:p xmlns:a="http://schemas.openxmlformats.org/drawingml/2006/main">
             <a:pPr algn="l">
+              <a:buNone/>
               <a:defRPr sz="975" b="0">
                 <a:solidFill>
                   <a:srgbClr val="506174"/>
@@ -20037,6 +20257,7 @@
           <a:lstStyle xmlns:a="http://schemas.openxmlformats.org/drawingml/2006/main"/>
           <a:p xmlns:a="http://schemas.openxmlformats.org/drawingml/2006/main">
             <a:pPr algn="r">
+              <a:buNone/>
               <a:defRPr sz="1200" b="1">
                 <a:solidFill>
                   <a:srgbClr val="17324D"/>
@@ -20094,6 +20315,7 @@
           <a:lstStyle xmlns:a="http://schemas.openxmlformats.org/drawingml/2006/main"/>
           <a:p xmlns:a="http://schemas.openxmlformats.org/drawingml/2006/main">
             <a:pPr algn="ctr">
+              <a:buNone/>
               <a:defRPr sz="2100" b="1">
                 <a:solidFill>
                   <a:srgbClr val="17324D"/>
@@ -20112,7 +20334,7 @@
                 <a:ea typeface="Tahoma"/>
                 <a:cs typeface="Tahoma"/>
               </a:rPr>
-              <a:t>Create file อยู่ใน If yes หลัง Excel update และใช้ชื่อ Request-[Response Id].txt</a:t>
+              <a:t>Route A สร้าง private Team site; Route B ตรวจ site ที่ IT เตรียมให้</a:t>
             </a:r>
           </a:p>
         </p:txBody>
@@ -20186,6 +20408,7 @@
           <a:lstStyle xmlns:a="http://schemas.openxmlformats.org/drawingml/2006/main"/>
           <a:p xmlns:a="http://schemas.openxmlformats.org/drawingml/2006/main">
             <a:pPr algn="l">
+              <a:buNone/>
               <a:defRPr sz="1275" b="1">
                 <a:solidFill>
                   <a:srgbClr val="C83C42"/>
@@ -20243,6 +20466,7 @@
           <a:lstStyle xmlns:a="http://schemas.openxmlformats.org/drawingml/2006/main"/>
           <a:p xmlns:a="http://schemas.openxmlformats.org/drawingml/2006/main">
             <a:pPr algn="ctr">
+              <a:buNone/>
               <a:defRPr sz="1650" b="1">
                 <a:solidFill>
                   <a:srgbClr val="17324D"/>
@@ -20261,7 +20485,7 @@
                 <a:ea typeface="Tahoma"/>
                 <a:cs typeface="Tahoma"/>
               </a:rPr>
-              <a:t>Approved branch and file fields</a:t>
+              <a:t>Route A · สร้างและตรวจ site</a:t>
             </a:r>
           </a:p>
         </p:txBody>
@@ -20368,6 +20592,7 @@
           <a:lstStyle xmlns:a="http://schemas.openxmlformats.org/drawingml/2006/main"/>
           <a:p xmlns:a="http://schemas.openxmlformats.org/drawingml/2006/main">
             <a:pPr algn="l">
+              <a:buNone/>
               <a:defRPr sz="1275" b="1">
                 <a:solidFill>
                   <a:srgbClr val="C83C42"/>
@@ -20425,6 +20650,7 @@
           <a:lstStyle xmlns:a="http://schemas.openxmlformats.org/drawingml/2006/main"/>
           <a:p xmlns:a="http://schemas.openxmlformats.org/drawingml/2006/main">
             <a:pPr algn="ctr">
+              <a:buNone/>
               <a:defRPr sz="1650" b="1">
                 <a:solidFill>
                   <a:srgbClr val="17324D"/>
@@ -20443,7 +20669,7 @@
                 <a:ea typeface="Tahoma"/>
                 <a:cs typeface="Tahoma"/>
               </a:rPr>
-              <a:t>ตรวจผลที่ปลายทาง</a:t>
+              <a:t>Route B · ตรวจ site จาก IT</a:t>
             </a:r>
           </a:p>
         </p:txBody>
@@ -20517,6 +20743,7 @@
           <a:lstStyle xmlns:a="http://schemas.openxmlformats.org/drawingml/2006/main"/>
           <a:p xmlns:a="http://schemas.openxmlformats.org/drawingml/2006/main">
             <a:pPr algn="l">
+              <a:buNone/>
               <a:defRPr sz="1125" b="1">
                 <a:solidFill>
                   <a:srgbClr val="C83C42"/>
@@ -20574,6 +20801,7 @@
           <a:lstStyle xmlns:a="http://schemas.openxmlformats.org/drawingml/2006/main"/>
           <a:p xmlns:a="http://schemas.openxmlformats.org/drawingml/2006/main">
             <a:pPr algn="l">
+              <a:buNone/>
               <a:defRPr sz="1575" b="0">
                 <a:solidFill>
                   <a:srgbClr val="17324D"/>
@@ -20592,7 +20820,7 @@
                 <a:ea typeface="Tahoma"/>
                 <a:cs typeface="Tahoma"/>
               </a:rPr>
-              <a:t>ตรวจ Site Address, Folder Path, File Name และ File Content</a:t>
+              <a:t>ส่ง direct link ของ route ที่เลือก; readiness ไม่ผ่านให้กลับ reinforcement</a:t>
             </a:r>
           </a:p>
         </p:txBody>
@@ -20660,6 +20888,7 @@
           <a:lstStyle xmlns:a="http://schemas.openxmlformats.org/drawingml/2006/main"/>
           <a:p xmlns:a="http://schemas.openxmlformats.org/drawingml/2006/main">
             <a:pPr algn="l">
+              <a:buNone/>
               <a:defRPr sz="1125" b="1">
                 <a:solidFill>
                   <a:srgbClr val="C83C42"/>
@@ -20678,7 +20907,7 @@
                 <a:ea typeface="Tahoma"/>
                 <a:cs typeface="Tahoma"/>
               </a:rPr>
-              <a:t>DAY 1  ·  POWER AUTOMATE  /  SHAREPOINT</a:t>
+              <a:t>DAY 1  ·  POWER AUTOMATE  /  INSTRUCTOR-SELECTED</a:t>
             </a:r>
           </a:p>
         </p:txBody>
@@ -20717,6 +20946,7 @@
           <a:lstStyle xmlns:a="http://schemas.openxmlformats.org/drawingml/2006/main"/>
           <a:p xmlns:a="http://schemas.openxmlformats.org/drawingml/2006/main">
             <a:pPr algn="l">
+              <a:buNone/>
               <a:defRPr sz="2925" b="1">
                 <a:solidFill>
                   <a:srgbClr val="17324D"/>
@@ -20735,7 +20965,7 @@
                 <a:ea typeface="Tahoma"/>
                 <a:cs typeface="Tahoma"/>
               </a:rPr>
-              <a:t>Prove the boundary</a:t>
+              <a:t>Rejoin at the checkpoint</a:t>
             </a:r>
           </a:p>
         </p:txBody>
@@ -20807,6 +21037,7 @@
           <a:lstStyle xmlns:a="http://schemas.openxmlformats.org/drawingml/2006/main"/>
           <a:p xmlns:a="http://schemas.openxmlformats.org/drawingml/2006/main">
             <a:pPr algn="l">
+              <a:buNone/>
               <a:defRPr sz="975" b="0">
                 <a:solidFill>
                   <a:srgbClr val="506174"/>
@@ -20864,6 +21095,7 @@
           <a:lstStyle xmlns:a="http://schemas.openxmlformats.org/drawingml/2006/main"/>
           <a:p xmlns:a="http://schemas.openxmlformats.org/drawingml/2006/main">
             <a:pPr algn="r">
+              <a:buNone/>
               <a:defRPr sz="1200" b="1">
                 <a:solidFill>
                   <a:srgbClr val="17324D"/>
@@ -20921,6 +21153,7 @@
           <a:lstStyle xmlns:a="http://schemas.openxmlformats.org/drawingml/2006/main"/>
           <a:p xmlns:a="http://schemas.openxmlformats.org/drawingml/2006/main">
             <a:pPr algn="ctr">
+              <a:buNone/>
               <a:defRPr sz="2100" b="1">
                 <a:solidFill>
                   <a:srgbClr val="17324D"/>
@@ -20939,7 +21172,7 @@
                 <a:ea typeface="Tahoma"/>
                 <a:cs typeface="Tahoma"/>
               </a:rPr>
-              <a:t>Approved ต้องมีไฟล์; Rejected ต้องไม่มีไฟล์</a:t>
+              <a:t>แต่ละเส้นทางใช้หลักฐานของตน แล้วกลับมาเริ่ม Teams เหมือนกัน</a:t>
             </a:r>
           </a:p>
         </p:txBody>
@@ -21013,6 +21246,7 @@
           <a:lstStyle xmlns:a="http://schemas.openxmlformats.org/drawingml/2006/main"/>
           <a:p xmlns:a="http://schemas.openxmlformats.org/drawingml/2006/main">
             <a:pPr algn="l">
+              <a:buNone/>
               <a:defRPr sz="1275" b="1">
                 <a:solidFill>
                   <a:srgbClr val="C83C42"/>
@@ -21070,6 +21304,7 @@
           <a:lstStyle xmlns:a="http://schemas.openxmlformats.org/drawingml/2006/main"/>
           <a:p xmlns:a="http://schemas.openxmlformats.org/drawingml/2006/main">
             <a:pPr algn="ctr">
+              <a:buNone/>
               <a:defRPr sz="1650" b="1">
                 <a:solidFill>
                   <a:srgbClr val="17324D"/>
@@ -21088,7 +21323,7 @@
                 <a:ea typeface="Tahoma"/>
                 <a:cs typeface="Tahoma"/>
               </a:rPr>
-              <a:t>Two test cards</a:t>
+              <a:t>Approval, Excel และ email ตรงกัน</a:t>
             </a:r>
           </a:p>
         </p:txBody>
@@ -21195,6 +21430,7 @@
           <a:lstStyle xmlns:a="http://schemas.openxmlformats.org/drawingml/2006/main"/>
           <a:p xmlns:a="http://schemas.openxmlformats.org/drawingml/2006/main">
             <a:pPr algn="l">
+              <a:buNone/>
               <a:defRPr sz="1275" b="1">
                 <a:solidFill>
                   <a:srgbClr val="C83C42"/>
@@ -21252,6 +21488,7 @@
           <a:lstStyle xmlns:a="http://schemas.openxmlformats.org/drawingml/2006/main"/>
           <a:p xmlns:a="http://schemas.openxmlformats.org/drawingml/2006/main">
             <a:pPr algn="ctr">
+              <a:buNone/>
               <a:defRPr sz="1650" b="1">
                 <a:solidFill>
                   <a:srgbClr val="17324D"/>
@@ -21270,7 +21507,7 @@
                 <a:ea typeface="Tahoma"/>
                 <a:cs typeface="Tahoma"/>
               </a:rPr>
-              <a:t>one file and one no-file result</a:t>
+              <a:t>SharePoint: Approved มีไฟล์</a:t>
             </a:r>
           </a:p>
         </p:txBody>
@@ -21344,6 +21581,7 @@
           <a:lstStyle xmlns:a="http://schemas.openxmlformats.org/drawingml/2006/main"/>
           <a:p xmlns:a="http://schemas.openxmlformats.org/drawingml/2006/main">
             <a:pPr algn="l">
+              <a:buNone/>
               <a:defRPr sz="1125" b="1">
                 <a:solidFill>
                   <a:srgbClr val="C83C42"/>
@@ -21401,6 +21639,7 @@
           <a:lstStyle xmlns:a="http://schemas.openxmlformats.org/drawingml/2006/main"/>
           <a:p xmlns:a="http://schemas.openxmlformats.org/drawingml/2006/main">
             <a:pPr algn="l">
+              <a:buNone/>
               <a:defRPr sz="1575" b="0">
                 <a:solidFill>
                   <a:srgbClr val="17324D"/>
@@ -21419,7 +21658,7 @@
                 <a:ea typeface="Tahoma"/>
                 <a:cs typeface="Tahoma"/>
               </a:rPr>
-              <a:t>การไม่เกิดไฟล์ใน Rejected เป็นผลที่ต้องตรวจ ไม่ใช่สิ่งที่เดา</a:t>
+              <a:t>SharePoint บันทึก Passed, Skipped by instructor หรือ Blocked</a:t>
             </a:r>
           </a:p>
         </p:txBody>
@@ -21487,6 +21726,7 @@
           <a:lstStyle xmlns:a="http://schemas.openxmlformats.org/drawingml/2006/main"/>
           <a:p xmlns:a="http://schemas.openxmlformats.org/drawingml/2006/main">
             <a:pPr algn="l">
+              <a:buNone/>
               <a:defRPr sz="1125" b="1">
                 <a:solidFill>
                   <a:srgbClr val="C83C42"/>
@@ -21544,6 +21784,7 @@
           <a:lstStyle xmlns:a="http://schemas.openxmlformats.org/drawingml/2006/main"/>
           <a:p xmlns:a="http://schemas.openxmlformats.org/drawingml/2006/main">
             <a:pPr algn="l">
+              <a:buNone/>
               <a:defRPr sz="2925" b="1">
                 <a:solidFill>
                   <a:srgbClr val="17324D"/>
@@ -21634,6 +21875,7 @@
           <a:lstStyle xmlns:a="http://schemas.openxmlformats.org/drawingml/2006/main"/>
           <a:p xmlns:a="http://schemas.openxmlformats.org/drawingml/2006/main">
             <a:pPr algn="l">
+              <a:buNone/>
               <a:defRPr sz="975" b="0">
                 <a:solidFill>
                   <a:srgbClr val="506174"/>
@@ -21691,6 +21933,7 @@
           <a:lstStyle xmlns:a="http://schemas.openxmlformats.org/drawingml/2006/main"/>
           <a:p xmlns:a="http://schemas.openxmlformats.org/drawingml/2006/main">
             <a:pPr algn="r">
+              <a:buNone/>
               <a:defRPr sz="1200" b="1">
                 <a:solidFill>
                   <a:srgbClr val="17324D"/>
@@ -21748,6 +21991,7 @@
           <a:lstStyle xmlns:a="http://schemas.openxmlformats.org/drawingml/2006/main"/>
           <a:p xmlns:a="http://schemas.openxmlformats.org/drawingml/2006/main">
             <a:pPr algn="ctr">
+              <a:buNone/>
               <a:defRPr sz="1875" b="0">
                 <a:solidFill>
                   <a:srgbClr val="506174"/>
@@ -21840,6 +22084,7 @@
           <a:lstStyle xmlns:a="http://schemas.openxmlformats.org/drawingml/2006/main"/>
           <a:p xmlns:a="http://schemas.openxmlformats.org/drawingml/2006/main">
             <a:pPr algn="l">
+              <a:buNone/>
               <a:defRPr sz="1125" b="1">
                 <a:solidFill>
                   <a:srgbClr val="C83C42"/>
@@ -21897,6 +22142,7 @@
           <a:lstStyle xmlns:a="http://schemas.openxmlformats.org/drawingml/2006/main"/>
           <a:p xmlns:a="http://schemas.openxmlformats.org/drawingml/2006/main">
             <a:pPr algn="l">
+              <a:buNone/>
               <a:defRPr sz="1875" b="0">
                 <a:solidFill>
                   <a:srgbClr val="17324D"/>
@@ -22022,6 +22268,7 @@
           <a:lstStyle xmlns:a="http://schemas.openxmlformats.org/drawingml/2006/main"/>
           <a:p xmlns:a="http://schemas.openxmlformats.org/drawingml/2006/main">
             <a:pPr algn="l">
+              <a:buNone/>
               <a:defRPr sz="1125" b="1">
                 <a:solidFill>
                   <a:srgbClr val="17324D"/>
@@ -22079,6 +22326,7 @@
           <a:lstStyle xmlns:a="http://schemas.openxmlformats.org/drawingml/2006/main"/>
           <a:p xmlns:a="http://schemas.openxmlformats.org/drawingml/2006/main">
             <a:pPr algn="l">
+              <a:buNone/>
               <a:defRPr sz="1875" b="1">
                 <a:solidFill>
                   <a:srgbClr val="17324D"/>
@@ -22204,6 +22452,7 @@
           <a:lstStyle xmlns:a="http://schemas.openxmlformats.org/drawingml/2006/main"/>
           <a:p xmlns:a="http://schemas.openxmlformats.org/drawingml/2006/main">
             <a:pPr algn="l">
+              <a:buNone/>
               <a:defRPr sz="1125" b="1">
                 <a:solidFill>
                   <a:srgbClr val="17324D"/>
@@ -22261,6 +22510,7 @@
           <a:lstStyle xmlns:a="http://schemas.openxmlformats.org/drawingml/2006/main"/>
           <a:p xmlns:a="http://schemas.openxmlformats.org/drawingml/2006/main">
             <a:pPr algn="l">
+              <a:buNone/>
               <a:defRPr sz="1875" b="0">
                 <a:solidFill>
                   <a:srgbClr val="17324D"/>
@@ -22318,6 +22568,7 @@
           <a:lstStyle xmlns:a="http://schemas.openxmlformats.org/drawingml/2006/main"/>
           <a:p xmlns:a="http://schemas.openxmlformats.org/drawingml/2006/main">
             <a:pPr algn="ctr">
+              <a:buNone/>
               <a:defRPr sz="1650" b="0">
                 <a:solidFill>
                   <a:srgbClr val="506174"/>
@@ -22404,6 +22655,7 @@
           <a:lstStyle xmlns:a="http://schemas.openxmlformats.org/drawingml/2006/main"/>
           <a:p xmlns:a="http://schemas.openxmlformats.org/drawingml/2006/main">
             <a:pPr algn="l">
+              <a:buNone/>
               <a:defRPr sz="1125" b="1">
                 <a:solidFill>
                   <a:srgbClr val="C83C42"/>
@@ -22461,6 +22713,7 @@
           <a:lstStyle xmlns:a="http://schemas.openxmlformats.org/drawingml/2006/main"/>
           <a:p xmlns:a="http://schemas.openxmlformats.org/drawingml/2006/main">
             <a:pPr algn="l">
+              <a:buNone/>
               <a:defRPr sz="2925" b="1">
                 <a:solidFill>
                   <a:srgbClr val="17324D"/>
@@ -22551,6 +22804,7 @@
           <a:lstStyle xmlns:a="http://schemas.openxmlformats.org/drawingml/2006/main"/>
           <a:p xmlns:a="http://schemas.openxmlformats.org/drawingml/2006/main">
             <a:pPr algn="l">
+              <a:buNone/>
               <a:defRPr sz="975" b="0">
                 <a:solidFill>
                   <a:srgbClr val="506174"/>
@@ -22608,6 +22862,7 @@
           <a:lstStyle xmlns:a="http://schemas.openxmlformats.org/drawingml/2006/main"/>
           <a:p xmlns:a="http://schemas.openxmlformats.org/drawingml/2006/main">
             <a:pPr algn="r">
+              <a:buNone/>
               <a:defRPr sz="1200" b="1">
                 <a:solidFill>
                   <a:srgbClr val="17324D"/>
@@ -22665,6 +22920,7 @@
           <a:lstStyle xmlns:a="http://schemas.openxmlformats.org/drawingml/2006/main"/>
           <a:p xmlns:a="http://schemas.openxmlformats.org/drawingml/2006/main">
             <a:pPr algn="ctr">
+              <a:buNone/>
               <a:defRPr sz="1875" b="0">
                 <a:solidFill>
                   <a:srgbClr val="506174"/>
@@ -22757,6 +23013,7 @@
           <a:lstStyle xmlns:a="http://schemas.openxmlformats.org/drawingml/2006/main"/>
           <a:p xmlns:a="http://schemas.openxmlformats.org/drawingml/2006/main">
             <a:pPr algn="l">
+              <a:buNone/>
               <a:defRPr sz="1125" b="1">
                 <a:solidFill>
                   <a:srgbClr val="C83C42"/>
@@ -22814,6 +23071,7 @@
           <a:lstStyle xmlns:a="http://schemas.openxmlformats.org/drawingml/2006/main"/>
           <a:p xmlns:a="http://schemas.openxmlformats.org/drawingml/2006/main">
             <a:pPr algn="l">
+              <a:buNone/>
               <a:defRPr sz="1875" b="0">
                 <a:solidFill>
                   <a:srgbClr val="17324D"/>
@@ -22939,6 +23197,7 @@
           <a:lstStyle xmlns:a="http://schemas.openxmlformats.org/drawingml/2006/main"/>
           <a:p xmlns:a="http://schemas.openxmlformats.org/drawingml/2006/main">
             <a:pPr algn="l">
+              <a:buNone/>
               <a:defRPr sz="1125" b="1">
                 <a:solidFill>
                   <a:srgbClr val="17324D"/>
@@ -22996,6 +23255,7 @@
           <a:lstStyle xmlns:a="http://schemas.openxmlformats.org/drawingml/2006/main"/>
           <a:p xmlns:a="http://schemas.openxmlformats.org/drawingml/2006/main">
             <a:pPr algn="l">
+              <a:buNone/>
               <a:defRPr sz="1875" b="1">
                 <a:solidFill>
                   <a:srgbClr val="17324D"/>
@@ -23121,6 +23381,7 @@
           <a:lstStyle xmlns:a="http://schemas.openxmlformats.org/drawingml/2006/main"/>
           <a:p xmlns:a="http://schemas.openxmlformats.org/drawingml/2006/main">
             <a:pPr algn="l">
+              <a:buNone/>
               <a:defRPr sz="1125" b="1">
                 <a:solidFill>
                   <a:srgbClr val="17324D"/>
@@ -23178,6 +23439,7 @@
           <a:lstStyle xmlns:a="http://schemas.openxmlformats.org/drawingml/2006/main"/>
           <a:p xmlns:a="http://schemas.openxmlformats.org/drawingml/2006/main">
             <a:pPr algn="l">
+              <a:buNone/>
               <a:defRPr sz="1875" b="0">
                 <a:solidFill>
                   <a:srgbClr val="17324D"/>
@@ -23235,6 +23497,7 @@
           <a:lstStyle xmlns:a="http://schemas.openxmlformats.org/drawingml/2006/main"/>
           <a:p xmlns:a="http://schemas.openxmlformats.org/drawingml/2006/main">
             <a:pPr algn="ctr">
+              <a:buNone/>
               <a:defRPr sz="1650" b="0">
                 <a:solidFill>
                   <a:srgbClr val="506174"/>
@@ -23321,6 +23584,7 @@
           <a:lstStyle xmlns:a="http://schemas.openxmlformats.org/drawingml/2006/main"/>
           <a:p xmlns:a="http://schemas.openxmlformats.org/drawingml/2006/main">
             <a:pPr algn="l">
+              <a:buNone/>
               <a:defRPr sz="1125" b="1">
                 <a:solidFill>
                   <a:srgbClr val="C83C42"/>
@@ -23378,6 +23642,7 @@
           <a:lstStyle xmlns:a="http://schemas.openxmlformats.org/drawingml/2006/main"/>
           <a:p xmlns:a="http://schemas.openxmlformats.org/drawingml/2006/main">
             <a:pPr algn="l">
+              <a:buNone/>
               <a:defRPr sz="2925" b="1">
                 <a:solidFill>
                   <a:srgbClr val="17324D"/>
@@ -23468,6 +23733,7 @@
           <a:lstStyle xmlns:a="http://schemas.openxmlformats.org/drawingml/2006/main"/>
           <a:p xmlns:a="http://schemas.openxmlformats.org/drawingml/2006/main">
             <a:pPr algn="l">
+              <a:buNone/>
               <a:defRPr sz="975" b="0">
                 <a:solidFill>
                   <a:srgbClr val="506174"/>
@@ -23525,6 +23791,7 @@
           <a:lstStyle xmlns:a="http://schemas.openxmlformats.org/drawingml/2006/main"/>
           <a:p xmlns:a="http://schemas.openxmlformats.org/drawingml/2006/main">
             <a:pPr algn="r">
+              <a:buNone/>
               <a:defRPr sz="1200" b="1">
                 <a:solidFill>
                   <a:srgbClr val="17324D"/>
@@ -23582,6 +23849,7 @@
           <a:lstStyle xmlns:a="http://schemas.openxmlformats.org/drawingml/2006/main"/>
           <a:p xmlns:a="http://schemas.openxmlformats.org/drawingml/2006/main">
             <a:pPr algn="ctr">
+              <a:buNone/>
               <a:defRPr sz="2100" b="1">
                 <a:solidFill>
                   <a:srgbClr val="17324D"/>
@@ -23674,6 +23942,7 @@
           <a:lstStyle xmlns:a="http://schemas.openxmlformats.org/drawingml/2006/main"/>
           <a:p xmlns:a="http://schemas.openxmlformats.org/drawingml/2006/main">
             <a:pPr algn="l">
+              <a:buNone/>
               <a:defRPr sz="1275" b="1">
                 <a:solidFill>
                   <a:srgbClr val="C83C42"/>
@@ -23731,6 +24000,7 @@
           <a:lstStyle xmlns:a="http://schemas.openxmlformats.org/drawingml/2006/main"/>
           <a:p xmlns:a="http://schemas.openxmlformats.org/drawingml/2006/main">
             <a:pPr algn="ctr">
+              <a:buNone/>
               <a:defRPr sz="1650" b="1">
                 <a:solidFill>
                   <a:srgbClr val="17324D"/>
@@ -23856,6 +24126,7 @@
           <a:lstStyle xmlns:a="http://schemas.openxmlformats.org/drawingml/2006/main"/>
           <a:p xmlns:a="http://schemas.openxmlformats.org/drawingml/2006/main">
             <a:pPr algn="l">
+              <a:buNone/>
               <a:defRPr sz="1275" b="1">
                 <a:solidFill>
                   <a:srgbClr val="C83C42"/>
@@ -23913,6 +24184,7 @@
           <a:lstStyle xmlns:a="http://schemas.openxmlformats.org/drawingml/2006/main"/>
           <a:p xmlns:a="http://schemas.openxmlformats.org/drawingml/2006/main">
             <a:pPr algn="ctr">
+              <a:buNone/>
               <a:defRPr sz="1650" b="1">
                 <a:solidFill>
                   <a:srgbClr val="17324D"/>
@@ -24005,6 +24277,7 @@
           <a:lstStyle xmlns:a="http://schemas.openxmlformats.org/drawingml/2006/main"/>
           <a:p xmlns:a="http://schemas.openxmlformats.org/drawingml/2006/main">
             <a:pPr algn="l">
+              <a:buNone/>
               <a:defRPr sz="1125" b="1">
                 <a:solidFill>
                   <a:srgbClr val="C83C42"/>
@@ -24062,6 +24335,7 @@
           <a:lstStyle xmlns:a="http://schemas.openxmlformats.org/drawingml/2006/main"/>
           <a:p xmlns:a="http://schemas.openxmlformats.org/drawingml/2006/main">
             <a:pPr algn="l">
+              <a:buNone/>
               <a:defRPr sz="1575" b="0">
                 <a:solidFill>
                   <a:srgbClr val="17324D"/>
@@ -24148,6 +24422,7 @@
           <a:lstStyle xmlns:a="http://schemas.openxmlformats.org/drawingml/2006/main"/>
           <a:p xmlns:a="http://schemas.openxmlformats.org/drawingml/2006/main">
             <a:pPr algn="l">
+              <a:buNone/>
               <a:defRPr sz="1125" b="1">
                 <a:solidFill>
                   <a:srgbClr val="C83C42"/>
@@ -24205,6 +24480,7 @@
           <a:lstStyle xmlns:a="http://schemas.openxmlformats.org/drawingml/2006/main"/>
           <a:p xmlns:a="http://schemas.openxmlformats.org/drawingml/2006/main">
             <a:pPr algn="l">
+              <a:buNone/>
               <a:defRPr sz="2925" b="1">
                 <a:solidFill>
                   <a:srgbClr val="17324D"/>
@@ -24295,6 +24571,7 @@
           <a:lstStyle xmlns:a="http://schemas.openxmlformats.org/drawingml/2006/main"/>
           <a:p xmlns:a="http://schemas.openxmlformats.org/drawingml/2006/main">
             <a:pPr algn="l">
+              <a:buNone/>
               <a:defRPr sz="975" b="0">
                 <a:solidFill>
                   <a:srgbClr val="506174"/>
@@ -24352,6 +24629,7 @@
           <a:lstStyle xmlns:a="http://schemas.openxmlformats.org/drawingml/2006/main"/>
           <a:p xmlns:a="http://schemas.openxmlformats.org/drawingml/2006/main">
             <a:pPr algn="r">
+              <a:buNone/>
               <a:defRPr sz="1200" b="1">
                 <a:solidFill>
                   <a:srgbClr val="17324D"/>
@@ -24409,6 +24687,7 @@
           <a:lstStyle xmlns:a="http://schemas.openxmlformats.org/drawingml/2006/main"/>
           <a:p xmlns:a="http://schemas.openxmlformats.org/drawingml/2006/main">
             <a:pPr algn="ctr">
+              <a:buNone/>
               <a:defRPr sz="2100" b="1">
                 <a:solidFill>
                   <a:srgbClr val="17324D"/>
@@ -24501,6 +24780,7 @@
           <a:lstStyle xmlns:a="http://schemas.openxmlformats.org/drawingml/2006/main"/>
           <a:p xmlns:a="http://schemas.openxmlformats.org/drawingml/2006/main">
             <a:pPr algn="l">
+              <a:buNone/>
               <a:defRPr sz="1275" b="1">
                 <a:solidFill>
                   <a:srgbClr val="C83C42"/>
@@ -24558,6 +24838,7 @@
           <a:lstStyle xmlns:a="http://schemas.openxmlformats.org/drawingml/2006/main"/>
           <a:p xmlns:a="http://schemas.openxmlformats.org/drawingml/2006/main">
             <a:pPr algn="ctr">
+              <a:buNone/>
               <a:defRPr sz="1650" b="1">
                 <a:solidFill>
                   <a:srgbClr val="17324D"/>
@@ -24683,6 +24964,7 @@
           <a:lstStyle xmlns:a="http://schemas.openxmlformats.org/drawingml/2006/main"/>
           <a:p xmlns:a="http://schemas.openxmlformats.org/drawingml/2006/main">
             <a:pPr algn="l">
+              <a:buNone/>
               <a:defRPr sz="1275" b="1">
                 <a:solidFill>
                   <a:srgbClr val="C83C42"/>
@@ -24740,6 +25022,7 @@
           <a:lstStyle xmlns:a="http://schemas.openxmlformats.org/drawingml/2006/main"/>
           <a:p xmlns:a="http://schemas.openxmlformats.org/drawingml/2006/main">
             <a:pPr algn="ctr">
+              <a:buNone/>
               <a:defRPr sz="1650" b="1">
                 <a:solidFill>
                   <a:srgbClr val="17324D"/>
@@ -24832,6 +25115,7 @@
           <a:lstStyle xmlns:a="http://schemas.openxmlformats.org/drawingml/2006/main"/>
           <a:p xmlns:a="http://schemas.openxmlformats.org/drawingml/2006/main">
             <a:pPr algn="l">
+              <a:buNone/>
               <a:defRPr sz="1125" b="1">
                 <a:solidFill>
                   <a:srgbClr val="C83C42"/>
@@ -24889,6 +25173,7 @@
           <a:lstStyle xmlns:a="http://schemas.openxmlformats.org/drawingml/2006/main"/>
           <a:p xmlns:a="http://schemas.openxmlformats.org/drawingml/2006/main">
             <a:pPr algn="l">
+              <a:buNone/>
               <a:defRPr sz="1575" b="0">
                 <a:solidFill>
                   <a:srgbClr val="17324D"/>
@@ -24975,6 +25260,7 @@
           <a:lstStyle xmlns:a="http://schemas.openxmlformats.org/drawingml/2006/main"/>
           <a:p xmlns:a="http://schemas.openxmlformats.org/drawingml/2006/main">
             <a:pPr algn="l">
+              <a:buNone/>
               <a:defRPr sz="1125" b="1">
                 <a:solidFill>
                   <a:srgbClr val="C83C42"/>
@@ -25032,6 +25318,7 @@
           <a:lstStyle xmlns:a="http://schemas.openxmlformats.org/drawingml/2006/main"/>
           <a:p xmlns:a="http://schemas.openxmlformats.org/drawingml/2006/main">
             <a:pPr algn="l">
+              <a:buNone/>
               <a:defRPr sz="2925" b="1">
                 <a:solidFill>
                   <a:srgbClr val="17324D"/>
@@ -25122,6 +25409,7 @@
           <a:lstStyle xmlns:a="http://schemas.openxmlformats.org/drawingml/2006/main"/>
           <a:p xmlns:a="http://schemas.openxmlformats.org/drawingml/2006/main">
             <a:pPr algn="l">
+              <a:buNone/>
               <a:defRPr sz="975" b="0">
                 <a:solidFill>
                   <a:srgbClr val="506174"/>
@@ -25179,6 +25467,7 @@
           <a:lstStyle xmlns:a="http://schemas.openxmlformats.org/drawingml/2006/main"/>
           <a:p xmlns:a="http://schemas.openxmlformats.org/drawingml/2006/main">
             <a:pPr algn="r">
+              <a:buNone/>
               <a:defRPr sz="1200" b="1">
                 <a:solidFill>
                   <a:srgbClr val="17324D"/>
@@ -25236,6 +25525,7 @@
           <a:lstStyle xmlns:a="http://schemas.openxmlformats.org/drawingml/2006/main"/>
           <a:p xmlns:a="http://schemas.openxmlformats.org/drawingml/2006/main">
             <a:pPr algn="ctr">
+              <a:buNone/>
               <a:defRPr sz="2100" b="1">
                 <a:solidFill>
                   <a:srgbClr val="17324D"/>
@@ -25328,6 +25618,7 @@
           <a:lstStyle xmlns:a="http://schemas.openxmlformats.org/drawingml/2006/main"/>
           <a:p xmlns:a="http://schemas.openxmlformats.org/drawingml/2006/main">
             <a:pPr algn="l">
+              <a:buNone/>
               <a:defRPr sz="1275" b="1">
                 <a:solidFill>
                   <a:srgbClr val="C83C42"/>
@@ -25385,6 +25676,7 @@
           <a:lstStyle xmlns:a="http://schemas.openxmlformats.org/drawingml/2006/main"/>
           <a:p xmlns:a="http://schemas.openxmlformats.org/drawingml/2006/main">
             <a:pPr algn="ctr">
+              <a:buNone/>
               <a:defRPr sz="1650" b="1">
                 <a:solidFill>
                   <a:srgbClr val="17324D"/>
@@ -25510,6 +25802,7 @@
           <a:lstStyle xmlns:a="http://schemas.openxmlformats.org/drawingml/2006/main"/>
           <a:p xmlns:a="http://schemas.openxmlformats.org/drawingml/2006/main">
             <a:pPr algn="l">
+              <a:buNone/>
               <a:defRPr sz="1275" b="1">
                 <a:solidFill>
                   <a:srgbClr val="C83C42"/>
@@ -25567,6 +25860,7 @@
           <a:lstStyle xmlns:a="http://schemas.openxmlformats.org/drawingml/2006/main"/>
           <a:p xmlns:a="http://schemas.openxmlformats.org/drawingml/2006/main">
             <a:pPr algn="ctr">
+              <a:buNone/>
               <a:defRPr sz="1650" b="1">
                 <a:solidFill>
                   <a:srgbClr val="17324D"/>
@@ -25585,7 +25879,7 @@
                 <a:ea typeface="Tahoma"/>
                 <a:cs typeface="Tahoma"/>
               </a:rPr>
-              <a:t>SharePoint and Teams</a:t>
+              <a:t>Teams + optional SharePoint</a:t>
             </a:r>
           </a:p>
         </p:txBody>
@@ -25659,6 +25953,7 @@
           <a:lstStyle xmlns:a="http://schemas.openxmlformats.org/drawingml/2006/main"/>
           <a:p xmlns:a="http://schemas.openxmlformats.org/drawingml/2006/main">
             <a:pPr algn="l">
+              <a:buNone/>
               <a:defRPr sz="1125" b="1">
                 <a:solidFill>
                   <a:srgbClr val="C83C42"/>
@@ -25711,11 +26006,12 @@
         </p:spPr>
         <p:txBody>
           <a:bodyPr xmlns:a="http://schemas.openxmlformats.org/drawingml/2006/main" anchor="ctr">
-            <a:normAutofit fontScale="90131"/>
+            <a:normAutofit fontScale="100000"/>
           </a:bodyPr>
           <a:lstStyle xmlns:a="http://schemas.openxmlformats.org/drawingml/2006/main"/>
           <a:p xmlns:a="http://schemas.openxmlformats.org/drawingml/2006/main">
             <a:pPr algn="l">
+              <a:buNone/>
               <a:defRPr sz="1575" b="0">
                 <a:solidFill>
                   <a:srgbClr val="17324D"/>
@@ -25734,7 +26030,7 @@
                 <a:ea typeface="Tahoma"/>
                 <a:cs typeface="Tahoma"/>
               </a:rPr>
-              <a:t>Approved: Excel updated, file created, Teams sent. Rejected: Excel updated, no file, Teams sent.</a:t>
+              <a:t>Core: Excel และ Teams ผ่านทั้งสองผล; SharePoint เป็นหลักฐานเสริม</a:t>
             </a:r>
           </a:p>
         </p:txBody>
@@ -25802,6 +26098,7 @@
           <a:lstStyle xmlns:a="http://schemas.openxmlformats.org/drawingml/2006/main"/>
           <a:p xmlns:a="http://schemas.openxmlformats.org/drawingml/2006/main">
             <a:pPr algn="l">
+              <a:buNone/>
               <a:defRPr sz="1125" b="1">
                 <a:solidFill>
                   <a:srgbClr val="C83C42"/>
@@ -25859,6 +26156,7 @@
           <a:lstStyle xmlns:a="http://schemas.openxmlformats.org/drawingml/2006/main"/>
           <a:p xmlns:a="http://schemas.openxmlformats.org/drawingml/2006/main">
             <a:pPr algn="l">
+              <a:buNone/>
               <a:defRPr sz="2925" b="1">
                 <a:solidFill>
                   <a:srgbClr val="17324D"/>
@@ -25949,6 +26247,7 @@
           <a:lstStyle xmlns:a="http://schemas.openxmlformats.org/drawingml/2006/main"/>
           <a:p xmlns:a="http://schemas.openxmlformats.org/drawingml/2006/main">
             <a:pPr algn="l">
+              <a:buNone/>
               <a:defRPr sz="975" b="0">
                 <a:solidFill>
                   <a:srgbClr val="506174"/>
@@ -26006,6 +26305,7 @@
           <a:lstStyle xmlns:a="http://schemas.openxmlformats.org/drawingml/2006/main"/>
           <a:p xmlns:a="http://schemas.openxmlformats.org/drawingml/2006/main">
             <a:pPr algn="r">
+              <a:buNone/>
               <a:defRPr sz="1200" b="1">
                 <a:solidFill>
                   <a:srgbClr val="17324D"/>
@@ -26063,6 +26363,7 @@
           <a:lstStyle xmlns:a="http://schemas.openxmlformats.org/drawingml/2006/main"/>
           <a:p xmlns:a="http://schemas.openxmlformats.org/drawingml/2006/main">
             <a:pPr algn="l">
+              <a:buNone/>
               <a:defRPr sz="2100" b="1">
                 <a:solidFill>
                   <a:srgbClr val="17324D"/>
@@ -26120,6 +26421,7 @@
           <a:lstStyle xmlns:a="http://schemas.openxmlformats.org/drawingml/2006/main"/>
           <a:p xmlns:a="http://schemas.openxmlformats.org/drawingml/2006/main">
             <a:pPr algn="l">
+              <a:buNone/>
               <a:defRPr sz="1650" b="0">
                 <a:solidFill>
                   <a:srgbClr val="506174"/>
@@ -26212,6 +26514,7 @@
           <a:lstStyle xmlns:a="http://schemas.openxmlformats.org/drawingml/2006/main"/>
           <a:p xmlns:a="http://schemas.openxmlformats.org/drawingml/2006/main">
             <a:pPr algn="l">
+              <a:buNone/>
               <a:defRPr sz="1425" b="0">
                 <a:solidFill>
                   <a:srgbClr val="C83C42"/>
@@ -26237,14 +26540,14 @@
       </p:sp>
       <p:pic>
         <p:nvPicPr>
-          <p:cNvPr id="20" name=""/>
+          <p:cNvPr id="22" name=""/>
           <p:cNvPicPr>
             <a:picLocks xmlns:a="http://schemas.openxmlformats.org/drawingml/2006/main" noChangeAspect="1"/>
           </p:cNvPicPr>
           <p:nvPr/>
         </p:nvPicPr>
         <p:blipFill>
-          <a:blip xmlns:r="http://schemas.openxmlformats.org/officeDocument/2006/relationships" xmlns:a="http://schemas.openxmlformats.org/drawingml/2006/main" r:embed="R28b6c8abbe6a4704"/>
+          <a:blip xmlns:r="http://schemas.openxmlformats.org/officeDocument/2006/relationships" xmlns:a="http://schemas.openxmlformats.org/drawingml/2006/main" r:embed="R64ca3cd8ce71458f"/>
           <a:srcRect xmlns:a="http://schemas.openxmlformats.org/drawingml/2006/main" l="16727" t="0" r="16727" b="0"/>
           <a:stretch xmlns:a="http://schemas.openxmlformats.org/drawingml/2006/main">
             <a:fillRect l="0" t="0" r="0" b="0"/>
@@ -26325,6 +26628,7 @@
           <a:lstStyle xmlns:a="http://schemas.openxmlformats.org/drawingml/2006/main"/>
           <a:p xmlns:a="http://schemas.openxmlformats.org/drawingml/2006/main">
             <a:pPr algn="l">
+              <a:buNone/>
               <a:defRPr sz="1125" b="1">
                 <a:solidFill>
                   <a:srgbClr val="C83C42"/>
@@ -26382,6 +26686,7 @@
           <a:lstStyle xmlns:a="http://schemas.openxmlformats.org/drawingml/2006/main"/>
           <a:p xmlns:a="http://schemas.openxmlformats.org/drawingml/2006/main">
             <a:pPr algn="l">
+              <a:buNone/>
               <a:defRPr sz="2925" b="1">
                 <a:solidFill>
                   <a:srgbClr val="17324D"/>
@@ -26472,6 +26777,7 @@
           <a:lstStyle xmlns:a="http://schemas.openxmlformats.org/drawingml/2006/main"/>
           <a:p xmlns:a="http://schemas.openxmlformats.org/drawingml/2006/main">
             <a:pPr algn="l">
+              <a:buNone/>
               <a:defRPr sz="975" b="0">
                 <a:solidFill>
                   <a:srgbClr val="506174"/>
@@ -26529,6 +26835,7 @@
           <a:lstStyle xmlns:a="http://schemas.openxmlformats.org/drawingml/2006/main"/>
           <a:p xmlns:a="http://schemas.openxmlformats.org/drawingml/2006/main">
             <a:pPr algn="r">
+              <a:buNone/>
               <a:defRPr sz="1200" b="1">
                 <a:solidFill>
                   <a:srgbClr val="17324D"/>
@@ -26586,6 +26893,7 @@
           <a:lstStyle xmlns:a="http://schemas.openxmlformats.org/drawingml/2006/main"/>
           <a:p xmlns:a="http://schemas.openxmlformats.org/drawingml/2006/main">
             <a:pPr algn="ctr">
+              <a:buNone/>
               <a:defRPr sz="2100" b="1">
                 <a:solidFill>
                   <a:srgbClr val="17324D"/>
@@ -26678,6 +26986,7 @@
           <a:lstStyle xmlns:a="http://schemas.openxmlformats.org/drawingml/2006/main"/>
           <a:p xmlns:a="http://schemas.openxmlformats.org/drawingml/2006/main">
             <a:pPr algn="l">
+              <a:buNone/>
               <a:defRPr sz="1275" b="1">
                 <a:solidFill>
                   <a:srgbClr val="C83C42"/>
@@ -26735,6 +27044,7 @@
           <a:lstStyle xmlns:a="http://schemas.openxmlformats.org/drawingml/2006/main"/>
           <a:p xmlns:a="http://schemas.openxmlformats.org/drawingml/2006/main">
             <a:pPr algn="ctr">
+              <a:buNone/>
               <a:defRPr sz="1650" b="1">
                 <a:solidFill>
                   <a:srgbClr val="17324D"/>
@@ -26860,6 +27170,7 @@
           <a:lstStyle xmlns:a="http://schemas.openxmlformats.org/drawingml/2006/main"/>
           <a:p xmlns:a="http://schemas.openxmlformats.org/drawingml/2006/main">
             <a:pPr algn="l">
+              <a:buNone/>
               <a:defRPr sz="1275" b="1">
                 <a:solidFill>
                   <a:srgbClr val="C83C42"/>
@@ -26917,6 +27228,7 @@
           <a:lstStyle xmlns:a="http://schemas.openxmlformats.org/drawingml/2006/main"/>
           <a:p xmlns:a="http://schemas.openxmlformats.org/drawingml/2006/main">
             <a:pPr algn="ctr">
+              <a:buNone/>
               <a:defRPr sz="1650" b="1">
                 <a:solidFill>
                   <a:srgbClr val="17324D"/>
@@ -27009,6 +27321,7 @@
           <a:lstStyle xmlns:a="http://schemas.openxmlformats.org/drawingml/2006/main"/>
           <a:p xmlns:a="http://schemas.openxmlformats.org/drawingml/2006/main">
             <a:pPr algn="l">
+              <a:buNone/>
               <a:defRPr sz="1125" b="1">
                 <a:solidFill>
                   <a:srgbClr val="C83C42"/>
@@ -27066,6 +27379,7 @@
           <a:lstStyle xmlns:a="http://schemas.openxmlformats.org/drawingml/2006/main"/>
           <a:p xmlns:a="http://schemas.openxmlformats.org/drawingml/2006/main">
             <a:pPr algn="l">
+              <a:buNone/>
               <a:defRPr sz="1575" b="0">
                 <a:solidFill>
                   <a:srgbClr val="17324D"/>
@@ -27152,6 +27466,7 @@
           <a:lstStyle xmlns:a="http://schemas.openxmlformats.org/drawingml/2006/main"/>
           <a:p xmlns:a="http://schemas.openxmlformats.org/drawingml/2006/main">
             <a:pPr algn="l">
+              <a:buNone/>
               <a:defRPr sz="1125" b="1">
                 <a:solidFill>
                   <a:srgbClr val="C83C42"/>
@@ -27209,6 +27524,7 @@
           <a:lstStyle xmlns:a="http://schemas.openxmlformats.org/drawingml/2006/main"/>
           <a:p xmlns:a="http://schemas.openxmlformats.org/drawingml/2006/main">
             <a:pPr algn="l">
+              <a:buNone/>
               <a:defRPr sz="2925" b="1">
                 <a:solidFill>
                   <a:srgbClr val="17324D"/>
@@ -27299,6 +27615,7 @@
           <a:lstStyle xmlns:a="http://schemas.openxmlformats.org/drawingml/2006/main"/>
           <a:p xmlns:a="http://schemas.openxmlformats.org/drawingml/2006/main">
             <a:pPr algn="l">
+              <a:buNone/>
               <a:defRPr sz="975" b="0">
                 <a:solidFill>
                   <a:srgbClr val="506174"/>
@@ -27356,6 +27673,7 @@
           <a:lstStyle xmlns:a="http://schemas.openxmlformats.org/drawingml/2006/main"/>
           <a:p xmlns:a="http://schemas.openxmlformats.org/drawingml/2006/main">
             <a:pPr algn="r">
+              <a:buNone/>
               <a:defRPr sz="1200" b="1">
                 <a:solidFill>
                   <a:srgbClr val="17324D"/>
@@ -27413,6 +27731,7 @@
           <a:lstStyle xmlns:a="http://schemas.openxmlformats.org/drawingml/2006/main"/>
           <a:p xmlns:a="http://schemas.openxmlformats.org/drawingml/2006/main">
             <a:pPr algn="ctr">
+              <a:buNone/>
               <a:defRPr sz="2100" b="1">
                 <a:solidFill>
                   <a:srgbClr val="17324D"/>
@@ -27505,6 +27824,7 @@
           <a:lstStyle xmlns:a="http://schemas.openxmlformats.org/drawingml/2006/main"/>
           <a:p xmlns:a="http://schemas.openxmlformats.org/drawingml/2006/main">
             <a:pPr algn="l">
+              <a:buNone/>
               <a:defRPr sz="1275" b="1">
                 <a:solidFill>
                   <a:srgbClr val="C83C42"/>
@@ -27562,6 +27882,7 @@
           <a:lstStyle xmlns:a="http://schemas.openxmlformats.org/drawingml/2006/main"/>
           <a:p xmlns:a="http://schemas.openxmlformats.org/drawingml/2006/main">
             <a:pPr algn="ctr">
+              <a:buNone/>
               <a:defRPr sz="1650" b="1">
                 <a:solidFill>
                   <a:srgbClr val="17324D"/>
@@ -27687,6 +28008,7 @@
           <a:lstStyle xmlns:a="http://schemas.openxmlformats.org/drawingml/2006/main"/>
           <a:p xmlns:a="http://schemas.openxmlformats.org/drawingml/2006/main">
             <a:pPr algn="l">
+              <a:buNone/>
               <a:defRPr sz="1275" b="1">
                 <a:solidFill>
                   <a:srgbClr val="C83C42"/>
@@ -27744,6 +28066,7 @@
           <a:lstStyle xmlns:a="http://schemas.openxmlformats.org/drawingml/2006/main"/>
           <a:p xmlns:a="http://schemas.openxmlformats.org/drawingml/2006/main">
             <a:pPr algn="ctr">
+              <a:buNone/>
               <a:defRPr sz="1650" b="1">
                 <a:solidFill>
                   <a:srgbClr val="17324D"/>
@@ -27869,6 +28192,7 @@
           <a:lstStyle xmlns:a="http://schemas.openxmlformats.org/drawingml/2006/main"/>
           <a:p xmlns:a="http://schemas.openxmlformats.org/drawingml/2006/main">
             <a:pPr algn="l">
+              <a:buNone/>
               <a:defRPr sz="1275" b="1">
                 <a:solidFill>
                   <a:srgbClr val="C83C42"/>
@@ -27926,6 +28250,7 @@
           <a:lstStyle xmlns:a="http://schemas.openxmlformats.org/drawingml/2006/main"/>
           <a:p xmlns:a="http://schemas.openxmlformats.org/drawingml/2006/main">
             <a:pPr algn="ctr">
+              <a:buNone/>
               <a:defRPr sz="1650" b="1">
                 <a:solidFill>
                   <a:srgbClr val="17324D"/>
@@ -28018,6 +28343,7 @@
           <a:lstStyle xmlns:a="http://schemas.openxmlformats.org/drawingml/2006/main"/>
           <a:p xmlns:a="http://schemas.openxmlformats.org/drawingml/2006/main">
             <a:pPr algn="l">
+              <a:buNone/>
               <a:defRPr sz="1125" b="1">
                 <a:solidFill>
                   <a:srgbClr val="C83C42"/>
@@ -28075,6 +28401,7 @@
           <a:lstStyle xmlns:a="http://schemas.openxmlformats.org/drawingml/2006/main"/>
           <a:p xmlns:a="http://schemas.openxmlformats.org/drawingml/2006/main">
             <a:pPr algn="l">
+              <a:buNone/>
               <a:defRPr sz="1575" b="0">
                 <a:solidFill>
                   <a:srgbClr val="17324D"/>
@@ -28161,6 +28488,7 @@
           <a:lstStyle xmlns:a="http://schemas.openxmlformats.org/drawingml/2006/main"/>
           <a:p xmlns:a="http://schemas.openxmlformats.org/drawingml/2006/main">
             <a:pPr algn="l">
+              <a:buNone/>
               <a:defRPr sz="1125" b="1">
                 <a:solidFill>
                   <a:srgbClr val="C83C42"/>
@@ -28218,6 +28546,7 @@
           <a:lstStyle xmlns:a="http://schemas.openxmlformats.org/drawingml/2006/main"/>
           <a:p xmlns:a="http://schemas.openxmlformats.org/drawingml/2006/main">
             <a:pPr algn="l">
+              <a:buNone/>
               <a:defRPr sz="2925" b="1">
                 <a:solidFill>
                   <a:srgbClr val="17324D"/>
@@ -28308,6 +28637,7 @@
           <a:lstStyle xmlns:a="http://schemas.openxmlformats.org/drawingml/2006/main"/>
           <a:p xmlns:a="http://schemas.openxmlformats.org/drawingml/2006/main">
             <a:pPr algn="l">
+              <a:buNone/>
               <a:defRPr sz="975" b="0">
                 <a:solidFill>
                   <a:srgbClr val="506174"/>
@@ -28365,6 +28695,7 @@
           <a:lstStyle xmlns:a="http://schemas.openxmlformats.org/drawingml/2006/main"/>
           <a:p xmlns:a="http://schemas.openxmlformats.org/drawingml/2006/main">
             <a:pPr algn="r">
+              <a:buNone/>
               <a:defRPr sz="1200" b="1">
                 <a:solidFill>
                   <a:srgbClr val="17324D"/>
@@ -28422,6 +28753,7 @@
           <a:lstStyle xmlns:a="http://schemas.openxmlformats.org/drawingml/2006/main"/>
           <a:p xmlns:a="http://schemas.openxmlformats.org/drawingml/2006/main">
             <a:pPr algn="ctr">
+              <a:buNone/>
               <a:defRPr sz="1875" b="0">
                 <a:solidFill>
                   <a:srgbClr val="506174"/>
@@ -28514,6 +28846,7 @@
           <a:lstStyle xmlns:a="http://schemas.openxmlformats.org/drawingml/2006/main"/>
           <a:p xmlns:a="http://schemas.openxmlformats.org/drawingml/2006/main">
             <a:pPr algn="l">
+              <a:buNone/>
               <a:defRPr sz="1125" b="1">
                 <a:solidFill>
                   <a:srgbClr val="C83C42"/>
@@ -28571,6 +28904,7 @@
           <a:lstStyle xmlns:a="http://schemas.openxmlformats.org/drawingml/2006/main"/>
           <a:p xmlns:a="http://schemas.openxmlformats.org/drawingml/2006/main">
             <a:pPr algn="l">
+              <a:buNone/>
               <a:defRPr sz="1875" b="0">
                 <a:solidFill>
                   <a:srgbClr val="17324D"/>
@@ -28696,6 +29030,7 @@
           <a:lstStyle xmlns:a="http://schemas.openxmlformats.org/drawingml/2006/main"/>
           <a:p xmlns:a="http://schemas.openxmlformats.org/drawingml/2006/main">
             <a:pPr algn="l">
+              <a:buNone/>
               <a:defRPr sz="1125" b="1">
                 <a:solidFill>
                   <a:srgbClr val="17324D"/>
@@ -28753,6 +29088,7 @@
           <a:lstStyle xmlns:a="http://schemas.openxmlformats.org/drawingml/2006/main"/>
           <a:p xmlns:a="http://schemas.openxmlformats.org/drawingml/2006/main">
             <a:pPr algn="l">
+              <a:buNone/>
               <a:defRPr sz="1875" b="1">
                 <a:solidFill>
                   <a:srgbClr val="17324D"/>
@@ -28878,6 +29214,7 @@
           <a:lstStyle xmlns:a="http://schemas.openxmlformats.org/drawingml/2006/main"/>
           <a:p xmlns:a="http://schemas.openxmlformats.org/drawingml/2006/main">
             <a:pPr algn="l">
+              <a:buNone/>
               <a:defRPr sz="1125" b="1">
                 <a:solidFill>
                   <a:srgbClr val="17324D"/>
@@ -28935,6 +29272,7 @@
           <a:lstStyle xmlns:a="http://schemas.openxmlformats.org/drawingml/2006/main"/>
           <a:p xmlns:a="http://schemas.openxmlformats.org/drawingml/2006/main">
             <a:pPr algn="l">
+              <a:buNone/>
               <a:defRPr sz="1875" b="0">
                 <a:solidFill>
                   <a:srgbClr val="17324D"/>
@@ -28992,6 +29330,7 @@
           <a:lstStyle xmlns:a="http://schemas.openxmlformats.org/drawingml/2006/main"/>
           <a:p xmlns:a="http://schemas.openxmlformats.org/drawingml/2006/main">
             <a:pPr algn="ctr">
+              <a:buNone/>
               <a:defRPr sz="1650" b="0">
                 <a:solidFill>
                   <a:srgbClr val="506174"/>
@@ -29078,6 +29417,7 @@
           <a:lstStyle xmlns:a="http://schemas.openxmlformats.org/drawingml/2006/main"/>
           <a:p xmlns:a="http://schemas.openxmlformats.org/drawingml/2006/main">
             <a:pPr algn="l">
+              <a:buNone/>
               <a:defRPr sz="1125" b="1">
                 <a:solidFill>
                   <a:srgbClr val="C83C42"/>
@@ -29135,6 +29475,7 @@
           <a:lstStyle xmlns:a="http://schemas.openxmlformats.org/drawingml/2006/main"/>
           <a:p xmlns:a="http://schemas.openxmlformats.org/drawingml/2006/main">
             <a:pPr algn="l">
+              <a:buNone/>
               <a:defRPr sz="2925" b="1">
                 <a:solidFill>
                   <a:srgbClr val="17324D"/>
@@ -29225,6 +29566,7 @@
           <a:lstStyle xmlns:a="http://schemas.openxmlformats.org/drawingml/2006/main"/>
           <a:p xmlns:a="http://schemas.openxmlformats.org/drawingml/2006/main">
             <a:pPr algn="l">
+              <a:buNone/>
               <a:defRPr sz="975" b="0">
                 <a:solidFill>
                   <a:srgbClr val="506174"/>
@@ -29282,6 +29624,7 @@
           <a:lstStyle xmlns:a="http://schemas.openxmlformats.org/drawingml/2006/main"/>
           <a:p xmlns:a="http://schemas.openxmlformats.org/drawingml/2006/main">
             <a:pPr algn="r">
+              <a:buNone/>
               <a:defRPr sz="1200" b="1">
                 <a:solidFill>
                   <a:srgbClr val="17324D"/>
@@ -29339,6 +29682,7 @@
           <a:lstStyle xmlns:a="http://schemas.openxmlformats.org/drawingml/2006/main"/>
           <a:p xmlns:a="http://schemas.openxmlformats.org/drawingml/2006/main">
             <a:pPr algn="ctr">
+              <a:buNone/>
               <a:defRPr sz="2100" b="1">
                 <a:solidFill>
                   <a:srgbClr val="17324D"/>
@@ -29357,7 +29701,7 @@
                 <a:ea typeface="Tahoma"/>
                 <a:cs typeface="Tahoma"/>
               </a:rPr>
-              <a:t>สร้าง ทดสอบ ตรวจผลปลายทาง และอ่าน Run history ได้</a:t>
+              <a:t>สร้าง ทดสอบ ตรวจผลปลายทาง และอ่าน Run history ได้ โดยไม่ต้องผ่าน SharePoint</a:t>
             </a:r>
           </a:p>
         </p:txBody>
@@ -29431,6 +29775,7 @@
           <a:lstStyle xmlns:a="http://schemas.openxmlformats.org/drawingml/2006/main"/>
           <a:p xmlns:a="http://schemas.openxmlformats.org/drawingml/2006/main">
             <a:pPr algn="l">
+              <a:buNone/>
               <a:defRPr sz="1275" b="1">
                 <a:solidFill>
                   <a:srgbClr val="C83C42"/>
@@ -29488,6 +29833,7 @@
           <a:lstStyle xmlns:a="http://schemas.openxmlformats.org/drawingml/2006/main"/>
           <a:p xmlns:a="http://schemas.openxmlformats.org/drawingml/2006/main">
             <a:pPr algn="ctr">
+              <a:buNone/>
               <a:defRPr sz="1650" b="1">
                 <a:solidFill>
                   <a:srgbClr val="17324D"/>
@@ -29613,6 +29959,7 @@
           <a:lstStyle xmlns:a="http://schemas.openxmlformats.org/drawingml/2006/main"/>
           <a:p xmlns:a="http://schemas.openxmlformats.org/drawingml/2006/main">
             <a:pPr algn="l">
+              <a:buNone/>
               <a:defRPr sz="1275" b="1">
                 <a:solidFill>
                   <a:srgbClr val="C83C42"/>
@@ -29670,6 +30017,7 @@
           <a:lstStyle xmlns:a="http://schemas.openxmlformats.org/drawingml/2006/main"/>
           <a:p xmlns:a="http://schemas.openxmlformats.org/drawingml/2006/main">
             <a:pPr algn="ctr">
+              <a:buNone/>
               <a:defRPr sz="1650" b="1">
                 <a:solidFill>
                   <a:srgbClr val="17324D"/>
@@ -29795,6 +30143,7 @@
           <a:lstStyle xmlns:a="http://schemas.openxmlformats.org/drawingml/2006/main"/>
           <a:p xmlns:a="http://schemas.openxmlformats.org/drawingml/2006/main">
             <a:pPr algn="l">
+              <a:buNone/>
               <a:defRPr sz="1275" b="1">
                 <a:solidFill>
                   <a:srgbClr val="C83C42"/>
@@ -29852,6 +30201,7 @@
           <a:lstStyle xmlns:a="http://schemas.openxmlformats.org/drawingml/2006/main"/>
           <a:p xmlns:a="http://schemas.openxmlformats.org/drawingml/2006/main">
             <a:pPr algn="ctr">
+              <a:buNone/>
               <a:defRPr sz="1650" b="1">
                 <a:solidFill>
                   <a:srgbClr val="17324D"/>
@@ -29977,6 +30327,7 @@
           <a:lstStyle xmlns:a="http://schemas.openxmlformats.org/drawingml/2006/main"/>
           <a:p xmlns:a="http://schemas.openxmlformats.org/drawingml/2006/main">
             <a:pPr algn="l">
+              <a:buNone/>
               <a:defRPr sz="1275" b="1">
                 <a:solidFill>
                   <a:srgbClr val="C83C42"/>
@@ -30034,6 +30385,7 @@
           <a:lstStyle xmlns:a="http://schemas.openxmlformats.org/drawingml/2006/main"/>
           <a:p xmlns:a="http://schemas.openxmlformats.org/drawingml/2006/main">
             <a:pPr algn="ctr">
+              <a:buNone/>
               <a:defRPr sz="1650" b="1">
                 <a:solidFill>
                   <a:srgbClr val="17324D"/>
@@ -30126,6 +30478,7 @@
           <a:lstStyle xmlns:a="http://schemas.openxmlformats.org/drawingml/2006/main"/>
           <a:p xmlns:a="http://schemas.openxmlformats.org/drawingml/2006/main">
             <a:pPr algn="l">
+              <a:buNone/>
               <a:defRPr sz="1125" b="1">
                 <a:solidFill>
                   <a:srgbClr val="C83C42"/>
@@ -30183,6 +30536,7 @@
           <a:lstStyle xmlns:a="http://schemas.openxmlformats.org/drawingml/2006/main"/>
           <a:p xmlns:a="http://schemas.openxmlformats.org/drawingml/2006/main">
             <a:pPr algn="l">
+              <a:buNone/>
               <a:defRPr sz="1575" b="0">
                 <a:solidFill>
                   <a:srgbClr val="17324D"/>
@@ -30269,6 +30623,7 @@
           <a:lstStyle xmlns:a="http://schemas.openxmlformats.org/drawingml/2006/main"/>
           <a:p xmlns:a="http://schemas.openxmlformats.org/drawingml/2006/main">
             <a:pPr algn="l">
+              <a:buNone/>
               <a:defRPr sz="1125" b="1">
                 <a:solidFill>
                   <a:srgbClr val="C83C42"/>
@@ -30326,6 +30681,7 @@
           <a:lstStyle xmlns:a="http://schemas.openxmlformats.org/drawingml/2006/main"/>
           <a:p xmlns:a="http://schemas.openxmlformats.org/drawingml/2006/main">
             <a:pPr algn="l">
+              <a:buNone/>
               <a:defRPr sz="2925" b="1">
                 <a:solidFill>
                   <a:srgbClr val="17324D"/>
@@ -30416,6 +30772,7 @@
           <a:lstStyle xmlns:a="http://schemas.openxmlformats.org/drawingml/2006/main"/>
           <a:p xmlns:a="http://schemas.openxmlformats.org/drawingml/2006/main">
             <a:pPr algn="l">
+              <a:buNone/>
               <a:defRPr sz="975" b="0">
                 <a:solidFill>
                   <a:srgbClr val="506174"/>
@@ -30473,6 +30830,7 @@
           <a:lstStyle xmlns:a="http://schemas.openxmlformats.org/drawingml/2006/main"/>
           <a:p xmlns:a="http://schemas.openxmlformats.org/drawingml/2006/main">
             <a:pPr algn="r">
+              <a:buNone/>
               <a:defRPr sz="1200" b="1">
                 <a:solidFill>
                   <a:srgbClr val="17324D"/>
@@ -30530,6 +30888,7 @@
           <a:lstStyle xmlns:a="http://schemas.openxmlformats.org/drawingml/2006/main"/>
           <a:p xmlns:a="http://schemas.openxmlformats.org/drawingml/2006/main">
             <a:pPr algn="ctr">
+              <a:buNone/>
               <a:defRPr sz="2100" b="1">
                 <a:solidFill>
                   <a:srgbClr val="17324D"/>
@@ -30622,6 +30981,7 @@
           <a:lstStyle xmlns:a="http://schemas.openxmlformats.org/drawingml/2006/main"/>
           <a:p xmlns:a="http://schemas.openxmlformats.org/drawingml/2006/main">
             <a:pPr algn="l">
+              <a:buNone/>
               <a:defRPr sz="1275" b="1">
                 <a:solidFill>
                   <a:srgbClr val="C83C42"/>
@@ -30679,6 +31039,7 @@
           <a:lstStyle xmlns:a="http://schemas.openxmlformats.org/drawingml/2006/main"/>
           <a:p xmlns:a="http://schemas.openxmlformats.org/drawingml/2006/main">
             <a:pPr algn="ctr">
+              <a:buNone/>
               <a:defRPr sz="1650" b="1">
                 <a:solidFill>
                   <a:srgbClr val="17324D"/>
@@ -30804,6 +31165,7 @@
           <a:lstStyle xmlns:a="http://schemas.openxmlformats.org/drawingml/2006/main"/>
           <a:p xmlns:a="http://schemas.openxmlformats.org/drawingml/2006/main">
             <a:pPr algn="l">
+              <a:buNone/>
               <a:defRPr sz="1275" b="1">
                 <a:solidFill>
                   <a:srgbClr val="C83C42"/>
@@ -30861,6 +31223,7 @@
           <a:lstStyle xmlns:a="http://schemas.openxmlformats.org/drawingml/2006/main"/>
           <a:p xmlns:a="http://schemas.openxmlformats.org/drawingml/2006/main">
             <a:pPr algn="ctr">
+              <a:buNone/>
               <a:defRPr sz="1650" b="1">
                 <a:solidFill>
                   <a:srgbClr val="17324D"/>
@@ -30953,6 +31316,7 @@
           <a:lstStyle xmlns:a="http://schemas.openxmlformats.org/drawingml/2006/main"/>
           <a:p xmlns:a="http://schemas.openxmlformats.org/drawingml/2006/main">
             <a:pPr algn="l">
+              <a:buNone/>
               <a:defRPr sz="1125" b="1">
                 <a:solidFill>
                   <a:srgbClr val="C83C42"/>
@@ -31010,6 +31374,7 @@
           <a:lstStyle xmlns:a="http://schemas.openxmlformats.org/drawingml/2006/main"/>
           <a:p xmlns:a="http://schemas.openxmlformats.org/drawingml/2006/main">
             <a:pPr algn="l">
+              <a:buNone/>
               <a:defRPr sz="1575" b="0">
                 <a:solidFill>
                   <a:srgbClr val="17324D"/>
@@ -31096,6 +31461,7 @@
           <a:lstStyle xmlns:a="http://schemas.openxmlformats.org/drawingml/2006/main"/>
           <a:p xmlns:a="http://schemas.openxmlformats.org/drawingml/2006/main">
             <a:pPr algn="l">
+              <a:buNone/>
               <a:defRPr sz="1125" b="1">
                 <a:solidFill>
                   <a:srgbClr val="C83C42"/>
@@ -31153,6 +31519,7 @@
           <a:lstStyle xmlns:a="http://schemas.openxmlformats.org/drawingml/2006/main"/>
           <a:p xmlns:a="http://schemas.openxmlformats.org/drawingml/2006/main">
             <a:pPr algn="l">
+              <a:buNone/>
               <a:defRPr sz="2925" b="1">
                 <a:solidFill>
                   <a:srgbClr val="17324D"/>
@@ -31243,6 +31610,7 @@
           <a:lstStyle xmlns:a="http://schemas.openxmlformats.org/drawingml/2006/main"/>
           <a:p xmlns:a="http://schemas.openxmlformats.org/drawingml/2006/main">
             <a:pPr algn="l">
+              <a:buNone/>
               <a:defRPr sz="975" b="0">
                 <a:solidFill>
                   <a:srgbClr val="506174"/>
@@ -31300,6 +31668,7 @@
           <a:lstStyle xmlns:a="http://schemas.openxmlformats.org/drawingml/2006/main"/>
           <a:p xmlns:a="http://schemas.openxmlformats.org/drawingml/2006/main">
             <a:pPr algn="r">
+              <a:buNone/>
               <a:defRPr sz="1200" b="1">
                 <a:solidFill>
                   <a:srgbClr val="17324D"/>
@@ -31357,6 +31726,7 @@
           <a:lstStyle xmlns:a="http://schemas.openxmlformats.org/drawingml/2006/main"/>
           <a:p xmlns:a="http://schemas.openxmlformats.org/drawingml/2006/main">
             <a:pPr algn="l">
+              <a:buNone/>
               <a:defRPr sz="2100" b="1">
                 <a:solidFill>
                   <a:srgbClr val="17324D"/>
@@ -31414,6 +31784,7 @@
           <a:lstStyle xmlns:a="http://schemas.openxmlformats.org/drawingml/2006/main"/>
           <a:p xmlns:a="http://schemas.openxmlformats.org/drawingml/2006/main">
             <a:pPr algn="l">
+              <a:buNone/>
               <a:defRPr sz="1650" b="0">
                 <a:solidFill>
                   <a:srgbClr val="506174"/>
@@ -31506,6 +31877,7 @@
           <a:lstStyle xmlns:a="http://schemas.openxmlformats.org/drawingml/2006/main"/>
           <a:p xmlns:a="http://schemas.openxmlformats.org/drawingml/2006/main">
             <a:pPr algn="l">
+              <a:buNone/>
               <a:defRPr sz="1425" b="0">
                 <a:solidFill>
                   <a:srgbClr val="C83C42"/>
@@ -31531,14 +31903,14 @@
       </p:sp>
       <p:pic>
         <p:nvPicPr>
-          <p:cNvPr id="20" name=""/>
+          <p:cNvPr id="22" name=""/>
           <p:cNvPicPr>
             <a:picLocks xmlns:a="http://schemas.openxmlformats.org/drawingml/2006/main" noChangeAspect="1"/>
           </p:cNvPicPr>
           <p:nvPr/>
         </p:nvPicPr>
         <p:blipFill>
-          <a:blip xmlns:r="http://schemas.openxmlformats.org/officeDocument/2006/relationships" xmlns:a="http://schemas.openxmlformats.org/drawingml/2006/main" r:embed="Ra6eacaeb5b684101"/>
+          <a:blip xmlns:r="http://schemas.openxmlformats.org/officeDocument/2006/relationships" xmlns:a="http://schemas.openxmlformats.org/drawingml/2006/main" r:embed="Raa9f4b5405604331"/>
           <a:srcRect xmlns:a="http://schemas.openxmlformats.org/drawingml/2006/main" l="16727" t="0" r="16727" b="0"/>
           <a:stretch xmlns:a="http://schemas.openxmlformats.org/drawingml/2006/main">
             <a:fillRect l="0" t="0" r="0" b="0"/>
@@ -31619,6 +31991,7 @@
           <a:lstStyle xmlns:a="http://schemas.openxmlformats.org/drawingml/2006/main"/>
           <a:p xmlns:a="http://schemas.openxmlformats.org/drawingml/2006/main">
             <a:pPr algn="l">
+              <a:buNone/>
               <a:defRPr sz="1125" b="1">
                 <a:solidFill>
                   <a:srgbClr val="C83C42"/>
@@ -31676,6 +32049,7 @@
           <a:lstStyle xmlns:a="http://schemas.openxmlformats.org/drawingml/2006/main"/>
           <a:p xmlns:a="http://schemas.openxmlformats.org/drawingml/2006/main">
             <a:pPr algn="l">
+              <a:buNone/>
               <a:defRPr sz="2925" b="1">
                 <a:solidFill>
                   <a:srgbClr val="17324D"/>
@@ -31766,6 +32140,7 @@
           <a:lstStyle xmlns:a="http://schemas.openxmlformats.org/drawingml/2006/main"/>
           <a:p xmlns:a="http://schemas.openxmlformats.org/drawingml/2006/main">
             <a:pPr algn="l">
+              <a:buNone/>
               <a:defRPr sz="975" b="0">
                 <a:solidFill>
                   <a:srgbClr val="506174"/>
@@ -31823,6 +32198,7 @@
           <a:lstStyle xmlns:a="http://schemas.openxmlformats.org/drawingml/2006/main"/>
           <a:p xmlns:a="http://schemas.openxmlformats.org/drawingml/2006/main">
             <a:pPr algn="r">
+              <a:buNone/>
               <a:defRPr sz="1200" b="1">
                 <a:solidFill>
                   <a:srgbClr val="17324D"/>
@@ -31880,6 +32256,7 @@
           <a:lstStyle xmlns:a="http://schemas.openxmlformats.org/drawingml/2006/main"/>
           <a:p xmlns:a="http://schemas.openxmlformats.org/drawingml/2006/main">
             <a:pPr algn="ctr">
+              <a:buNone/>
               <a:defRPr sz="2100" b="1">
                 <a:solidFill>
                   <a:srgbClr val="17324D"/>
@@ -31972,6 +32349,7 @@
           <a:lstStyle xmlns:a="http://schemas.openxmlformats.org/drawingml/2006/main"/>
           <a:p xmlns:a="http://schemas.openxmlformats.org/drawingml/2006/main">
             <a:pPr algn="l">
+              <a:buNone/>
               <a:defRPr sz="1275" b="1">
                 <a:solidFill>
                   <a:srgbClr val="C83C42"/>
@@ -32029,6 +32407,7 @@
           <a:lstStyle xmlns:a="http://schemas.openxmlformats.org/drawingml/2006/main"/>
           <a:p xmlns:a="http://schemas.openxmlformats.org/drawingml/2006/main">
             <a:pPr algn="ctr">
+              <a:buNone/>
               <a:defRPr sz="1650" b="1">
                 <a:solidFill>
                   <a:srgbClr val="17324D"/>
@@ -32154,6 +32533,7 @@
           <a:lstStyle xmlns:a="http://schemas.openxmlformats.org/drawingml/2006/main"/>
           <a:p xmlns:a="http://schemas.openxmlformats.org/drawingml/2006/main">
             <a:pPr algn="l">
+              <a:buNone/>
               <a:defRPr sz="1275" b="1">
                 <a:solidFill>
                   <a:srgbClr val="C83C42"/>
@@ -32211,6 +32591,7 @@
           <a:lstStyle xmlns:a="http://schemas.openxmlformats.org/drawingml/2006/main"/>
           <a:p xmlns:a="http://schemas.openxmlformats.org/drawingml/2006/main">
             <a:pPr algn="ctr">
+              <a:buNone/>
               <a:defRPr sz="1650" b="1">
                 <a:solidFill>
                   <a:srgbClr val="17324D"/>
@@ -32336,6 +32717,7 @@
           <a:lstStyle xmlns:a="http://schemas.openxmlformats.org/drawingml/2006/main"/>
           <a:p xmlns:a="http://schemas.openxmlformats.org/drawingml/2006/main">
             <a:pPr algn="l">
+              <a:buNone/>
               <a:defRPr sz="1275" b="1">
                 <a:solidFill>
                   <a:srgbClr val="C83C42"/>
@@ -32393,6 +32775,7 @@
           <a:lstStyle xmlns:a="http://schemas.openxmlformats.org/drawingml/2006/main"/>
           <a:p xmlns:a="http://schemas.openxmlformats.org/drawingml/2006/main">
             <a:pPr algn="ctr">
+              <a:buNone/>
               <a:defRPr sz="1650" b="1">
                 <a:solidFill>
                   <a:srgbClr val="17324D"/>
@@ -32485,6 +32868,7 @@
           <a:lstStyle xmlns:a="http://schemas.openxmlformats.org/drawingml/2006/main"/>
           <a:p xmlns:a="http://schemas.openxmlformats.org/drawingml/2006/main">
             <a:pPr algn="l">
+              <a:buNone/>
               <a:defRPr sz="1125" b="1">
                 <a:solidFill>
                   <a:srgbClr val="C83C42"/>
@@ -32542,6 +32926,7 @@
           <a:lstStyle xmlns:a="http://schemas.openxmlformats.org/drawingml/2006/main"/>
           <a:p xmlns:a="http://schemas.openxmlformats.org/drawingml/2006/main">
             <a:pPr algn="l">
+              <a:buNone/>
               <a:defRPr sz="1575" b="0">
                 <a:solidFill>
                   <a:srgbClr val="17324D"/>
@@ -32628,6 +33013,7 @@
           <a:lstStyle xmlns:a="http://schemas.openxmlformats.org/drawingml/2006/main"/>
           <a:p xmlns:a="http://schemas.openxmlformats.org/drawingml/2006/main">
             <a:pPr algn="l">
+              <a:buNone/>
               <a:defRPr sz="1125" b="1">
                 <a:solidFill>
                   <a:srgbClr val="C83C42"/>
@@ -32685,6 +33071,7 @@
           <a:lstStyle xmlns:a="http://schemas.openxmlformats.org/drawingml/2006/main"/>
           <a:p xmlns:a="http://schemas.openxmlformats.org/drawingml/2006/main">
             <a:pPr algn="l">
+              <a:buNone/>
               <a:defRPr sz="2925" b="1">
                 <a:solidFill>
                   <a:srgbClr val="17324D"/>
@@ -32775,6 +33162,7 @@
           <a:lstStyle xmlns:a="http://schemas.openxmlformats.org/drawingml/2006/main"/>
           <a:p xmlns:a="http://schemas.openxmlformats.org/drawingml/2006/main">
             <a:pPr algn="l">
+              <a:buNone/>
               <a:defRPr sz="975" b="0">
                 <a:solidFill>
                   <a:srgbClr val="506174"/>
@@ -32832,6 +33220,7 @@
           <a:lstStyle xmlns:a="http://schemas.openxmlformats.org/drawingml/2006/main"/>
           <a:p xmlns:a="http://schemas.openxmlformats.org/drawingml/2006/main">
             <a:pPr algn="r">
+              <a:buNone/>
               <a:defRPr sz="1200" b="1">
                 <a:solidFill>
                   <a:srgbClr val="17324D"/>
@@ -32889,6 +33278,7 @@
           <a:lstStyle xmlns:a="http://schemas.openxmlformats.org/drawingml/2006/main"/>
           <a:p xmlns:a="http://schemas.openxmlformats.org/drawingml/2006/main">
             <a:pPr algn="ctr">
+              <a:buNone/>
               <a:defRPr sz="1875" b="0">
                 <a:solidFill>
                   <a:srgbClr val="506174"/>
@@ -32907,7 +33297,7 @@
                 <a:ea typeface="Tahoma"/>
                 <a:cs typeface="Tahoma"/>
               </a:rPr>
-              <a:t>Outlook, Forms, Excel, Approvals, SharePoint และ Teams เป็น Standard connectors ในเส้นทางนี้</a:t>
+              <a:t>Outlook, Forms, Excel, Approvals และ Teams คือ core; SharePoint เป็น extension</a:t>
             </a:r>
           </a:p>
         </p:txBody>
@@ -32981,6 +33371,7 @@
           <a:lstStyle xmlns:a="http://schemas.openxmlformats.org/drawingml/2006/main"/>
           <a:p xmlns:a="http://schemas.openxmlformats.org/drawingml/2006/main">
             <a:pPr algn="l">
+              <a:buNone/>
               <a:defRPr sz="1125" b="1">
                 <a:solidFill>
                   <a:srgbClr val="C83C42"/>
@@ -33038,6 +33429,7 @@
           <a:lstStyle xmlns:a="http://schemas.openxmlformats.org/drawingml/2006/main"/>
           <a:p xmlns:a="http://schemas.openxmlformats.org/drawingml/2006/main">
             <a:pPr algn="l">
+              <a:buNone/>
               <a:defRPr sz="1875" b="0">
                 <a:solidFill>
                   <a:srgbClr val="17324D"/>
@@ -33056,7 +33448,7 @@
                 <a:ea typeface="Tahoma"/>
                 <a:cs typeface="Tahoma"/>
               </a:rPr>
-              <a:t>จุดบริการหกจุดในหลังร้าน</a:t>
+              <a:t>จุดบริการหลักในหลังร้าน</a:t>
             </a:r>
           </a:p>
         </p:txBody>
@@ -33163,6 +33555,7 @@
           <a:lstStyle xmlns:a="http://schemas.openxmlformats.org/drawingml/2006/main"/>
           <a:p xmlns:a="http://schemas.openxmlformats.org/drawingml/2006/main">
             <a:pPr algn="l">
+              <a:buNone/>
               <a:defRPr sz="1125" b="1">
                 <a:solidFill>
                   <a:srgbClr val="17324D"/>
@@ -33220,6 +33613,7 @@
           <a:lstStyle xmlns:a="http://schemas.openxmlformats.org/drawingml/2006/main"/>
           <a:p xmlns:a="http://schemas.openxmlformats.org/drawingml/2006/main">
             <a:pPr algn="l">
+              <a:buNone/>
               <a:defRPr sz="1875" b="1">
                 <a:solidFill>
                   <a:srgbClr val="17324D"/>
@@ -33238,7 +33632,7 @@
                 <a:ea typeface="Tahoma"/>
                 <a:cs typeface="Tahoma"/>
               </a:rPr>
-              <a:t>six Standard connectors</a:t>
+              <a:t>core + optional connector</a:t>
             </a:r>
           </a:p>
         </p:txBody>
@@ -33345,6 +33739,7 @@
           <a:lstStyle xmlns:a="http://schemas.openxmlformats.org/drawingml/2006/main"/>
           <a:p xmlns:a="http://schemas.openxmlformats.org/drawingml/2006/main">
             <a:pPr algn="l">
+              <a:buNone/>
               <a:defRPr sz="1125" b="1">
                 <a:solidFill>
                   <a:srgbClr val="17324D"/>
@@ -33402,6 +33797,7 @@
           <a:lstStyle xmlns:a="http://schemas.openxmlformats.org/drawingml/2006/main"/>
           <a:p xmlns:a="http://schemas.openxmlformats.org/drawingml/2006/main">
             <a:pPr algn="l">
+              <a:buNone/>
               <a:defRPr sz="1875" b="0">
                 <a:solidFill>
                   <a:srgbClr val="17324D"/>
@@ -33459,6 +33855,7 @@
           <a:lstStyle xmlns:a="http://schemas.openxmlformats.org/drawingml/2006/main"/>
           <a:p xmlns:a="http://schemas.openxmlformats.org/drawingml/2006/main">
             <a:pPr algn="ctr">
+              <a:buNone/>
               <a:defRPr sz="1650" b="0">
                 <a:solidFill>
                   <a:srgbClr val="506174"/>
@@ -33545,6 +33942,7 @@
           <a:lstStyle xmlns:a="http://schemas.openxmlformats.org/drawingml/2006/main"/>
           <a:p xmlns:a="http://schemas.openxmlformats.org/drawingml/2006/main">
             <a:pPr algn="l">
+              <a:buNone/>
               <a:defRPr sz="1125" b="1">
                 <a:solidFill>
                   <a:srgbClr val="C83C42"/>
@@ -33602,6 +34000,7 @@
           <a:lstStyle xmlns:a="http://schemas.openxmlformats.org/drawingml/2006/main"/>
           <a:p xmlns:a="http://schemas.openxmlformats.org/drawingml/2006/main">
             <a:pPr algn="l">
+              <a:buNone/>
               <a:defRPr sz="2925" b="1">
                 <a:solidFill>
                   <a:srgbClr val="17324D"/>
@@ -33692,6 +34091,7 @@
           <a:lstStyle xmlns:a="http://schemas.openxmlformats.org/drawingml/2006/main"/>
           <a:p xmlns:a="http://schemas.openxmlformats.org/drawingml/2006/main">
             <a:pPr algn="l">
+              <a:buNone/>
               <a:defRPr sz="975" b="0">
                 <a:solidFill>
                   <a:srgbClr val="506174"/>
@@ -33749,6 +34149,7 @@
           <a:lstStyle xmlns:a="http://schemas.openxmlformats.org/drawingml/2006/main"/>
           <a:p xmlns:a="http://schemas.openxmlformats.org/drawingml/2006/main">
             <a:pPr algn="r">
+              <a:buNone/>
               <a:defRPr sz="1200" b="1">
                 <a:solidFill>
                   <a:srgbClr val="17324D"/>
@@ -33806,6 +34207,7 @@
           <a:lstStyle xmlns:a="http://schemas.openxmlformats.org/drawingml/2006/main"/>
           <a:p xmlns:a="http://schemas.openxmlformats.org/drawingml/2006/main">
             <a:pPr algn="ctr">
+              <a:buNone/>
               <a:defRPr sz="2100" b="1">
                 <a:solidFill>
                   <a:srgbClr val="17324D"/>
@@ -33898,6 +34300,7 @@
           <a:lstStyle xmlns:a="http://schemas.openxmlformats.org/drawingml/2006/main"/>
           <a:p xmlns:a="http://schemas.openxmlformats.org/drawingml/2006/main">
             <a:pPr algn="l">
+              <a:buNone/>
               <a:defRPr sz="1275" b="1">
                 <a:solidFill>
                   <a:srgbClr val="C83C42"/>
@@ -33955,6 +34358,7 @@
           <a:lstStyle xmlns:a="http://schemas.openxmlformats.org/drawingml/2006/main"/>
           <a:p xmlns:a="http://schemas.openxmlformats.org/drawingml/2006/main">
             <a:pPr algn="ctr">
+              <a:buNone/>
               <a:defRPr sz="1650" b="1">
                 <a:solidFill>
                   <a:srgbClr val="17324D"/>
@@ -34080,6 +34484,7 @@
           <a:lstStyle xmlns:a="http://schemas.openxmlformats.org/drawingml/2006/main"/>
           <a:p xmlns:a="http://schemas.openxmlformats.org/drawingml/2006/main">
             <a:pPr algn="l">
+              <a:buNone/>
               <a:defRPr sz="1275" b="1">
                 <a:solidFill>
                   <a:srgbClr val="C83C42"/>
@@ -34137,6 +34542,7 @@
           <a:lstStyle xmlns:a="http://schemas.openxmlformats.org/drawingml/2006/main"/>
           <a:p xmlns:a="http://schemas.openxmlformats.org/drawingml/2006/main">
             <a:pPr algn="ctr">
+              <a:buNone/>
               <a:defRPr sz="1650" b="1">
                 <a:solidFill>
                   <a:srgbClr val="17324D"/>
@@ -34262,6 +34668,7 @@
           <a:lstStyle xmlns:a="http://schemas.openxmlformats.org/drawingml/2006/main"/>
           <a:p xmlns:a="http://schemas.openxmlformats.org/drawingml/2006/main">
             <a:pPr algn="l">
+              <a:buNone/>
               <a:defRPr sz="1275" b="1">
                 <a:solidFill>
                   <a:srgbClr val="C83C42"/>
@@ -34319,6 +34726,7 @@
           <a:lstStyle xmlns:a="http://schemas.openxmlformats.org/drawingml/2006/main"/>
           <a:p xmlns:a="http://schemas.openxmlformats.org/drawingml/2006/main">
             <a:pPr algn="ctr">
+              <a:buNone/>
               <a:defRPr sz="1650" b="1">
                 <a:solidFill>
                   <a:srgbClr val="17324D"/>
@@ -34411,6 +34819,7 @@
           <a:lstStyle xmlns:a="http://schemas.openxmlformats.org/drawingml/2006/main"/>
           <a:p xmlns:a="http://schemas.openxmlformats.org/drawingml/2006/main">
             <a:pPr algn="l">
+              <a:buNone/>
               <a:defRPr sz="1125" b="1">
                 <a:solidFill>
                   <a:srgbClr val="C83C42"/>
@@ -34468,6 +34877,7 @@
           <a:lstStyle xmlns:a="http://schemas.openxmlformats.org/drawingml/2006/main"/>
           <a:p xmlns:a="http://schemas.openxmlformats.org/drawingml/2006/main">
             <a:pPr algn="l">
+              <a:buNone/>
               <a:defRPr sz="1575" b="0">
                 <a:solidFill>
                   <a:srgbClr val="17324D"/>

</xml_diff>